<commit_message>
Clarify replaceable models and hardware-dependent AI configuration
</commit_message>
<xml_diff>
--- a/docs/pitch/Vantemio_Presentation_2026-10-05.pptx
+++ b/docs/pitch/Vantemio_Presentation_2026-10-05.pptx
@@ -2,48 +2,48 @@
 <file path=ppt/presentation.xml><?xml version="1.0" encoding="utf-8"?>
 <p:presentation xmlns:p="http://schemas.openxmlformats.org/presentationml/2006/main">
   <p:sldMasterIdLst>
-    <p:sldMasterId xmlns:r="http://schemas.openxmlformats.org/officeDocument/2006/relationships" id="2147483648" r:id="R91d9d9038706461e"/>
+    <p:sldMasterId xmlns:r="http://schemas.openxmlformats.org/officeDocument/2006/relationships" id="2147483648" r:id="R8441f55b22b0472b"/>
   </p:sldMasterIdLst>
   <p:notesMasterIdLst>
-    <p:notesMasterId xmlns:r="http://schemas.openxmlformats.org/officeDocument/2006/relationships" r:id="R8d7bb21aa3da46c0"/>
+    <p:notesMasterId xmlns:r="http://schemas.openxmlformats.org/officeDocument/2006/relationships" r:id="Rcb0920350e24455a"/>
   </p:notesMasterIdLst>
   <p:sldIdLst>
-    <p:sldId xmlns:r="http://schemas.openxmlformats.org/officeDocument/2006/relationships" id="256" r:id="Rac56fd634386430c"/>
-    <p:sldId xmlns:r="http://schemas.openxmlformats.org/officeDocument/2006/relationships" id="257" r:id="R6548f37bd4f64151"/>
-    <p:sldId xmlns:r="http://schemas.openxmlformats.org/officeDocument/2006/relationships" id="258" r:id="R68cf23c22a224df1"/>
-    <p:sldId xmlns:r="http://schemas.openxmlformats.org/officeDocument/2006/relationships" id="259" r:id="R1c0dd1a9cc334ffc"/>
-    <p:sldId xmlns:r="http://schemas.openxmlformats.org/officeDocument/2006/relationships" id="260" r:id="R3f0531faaf6b42d1"/>
-    <p:sldId xmlns:r="http://schemas.openxmlformats.org/officeDocument/2006/relationships" id="261" r:id="R666fcd8e1cdf4bb7"/>
-    <p:sldId xmlns:r="http://schemas.openxmlformats.org/officeDocument/2006/relationships" id="262" r:id="Rbff25bed28f64312"/>
-    <p:sldId xmlns:r="http://schemas.openxmlformats.org/officeDocument/2006/relationships" id="263" r:id="R88c8ff408a384120"/>
-    <p:sldId xmlns:r="http://schemas.openxmlformats.org/officeDocument/2006/relationships" id="264" r:id="Rf194ca0ddb454aa3"/>
-    <p:sldId xmlns:r="http://schemas.openxmlformats.org/officeDocument/2006/relationships" id="265" r:id="Rfe1028ecd07c4836"/>
-    <p:sldId xmlns:r="http://schemas.openxmlformats.org/officeDocument/2006/relationships" id="266" r:id="Rc7ae666ca56c4d55"/>
-    <p:sldId xmlns:r="http://schemas.openxmlformats.org/officeDocument/2006/relationships" id="267" r:id="R6f6cf5d66e0d47b9"/>
-    <p:sldId xmlns:r="http://schemas.openxmlformats.org/officeDocument/2006/relationships" id="268" r:id="Re71feec291764ce2"/>
-    <p:sldId xmlns:r="http://schemas.openxmlformats.org/officeDocument/2006/relationships" id="269" r:id="Rcf8b7b1bd2bc493b"/>
-    <p:sldId xmlns:r="http://schemas.openxmlformats.org/officeDocument/2006/relationships" id="270" r:id="R99e5f8c871a24ca3"/>
-    <p:sldId xmlns:r="http://schemas.openxmlformats.org/officeDocument/2006/relationships" id="271" r:id="Rc30b0968dc9542c9"/>
-    <p:sldId xmlns:r="http://schemas.openxmlformats.org/officeDocument/2006/relationships" id="272" r:id="R5db2dadd09214f8e"/>
-    <p:sldId xmlns:r="http://schemas.openxmlformats.org/officeDocument/2006/relationships" id="273" r:id="Rd68d34e141554ee3"/>
-    <p:sldId xmlns:r="http://schemas.openxmlformats.org/officeDocument/2006/relationships" id="274" r:id="R2bbf6d9f5baa4aa0"/>
-    <p:sldId xmlns:r="http://schemas.openxmlformats.org/officeDocument/2006/relationships" id="275" r:id="Ra4b9fcdde3f3460d"/>
-    <p:sldId xmlns:r="http://schemas.openxmlformats.org/officeDocument/2006/relationships" id="276" r:id="R9f3422ca96ba4a30"/>
-    <p:sldId xmlns:r="http://schemas.openxmlformats.org/officeDocument/2006/relationships" id="277" r:id="R948bb06de5c644b4"/>
-    <p:sldId xmlns:r="http://schemas.openxmlformats.org/officeDocument/2006/relationships" id="278" r:id="R3d05ec9e7ce741ae"/>
-    <p:sldId xmlns:r="http://schemas.openxmlformats.org/officeDocument/2006/relationships" id="279" r:id="R08e7fb7f96664d14"/>
-    <p:sldId xmlns:r="http://schemas.openxmlformats.org/officeDocument/2006/relationships" id="280" r:id="R43dd613d0dac4eee"/>
-    <p:sldId xmlns:r="http://schemas.openxmlformats.org/officeDocument/2006/relationships" id="281" r:id="Rdf57a0f30d404d08"/>
-    <p:sldId xmlns:r="http://schemas.openxmlformats.org/officeDocument/2006/relationships" id="282" r:id="R92ed4226b53b484f"/>
-    <p:sldId xmlns:r="http://schemas.openxmlformats.org/officeDocument/2006/relationships" id="283" r:id="R891eae2f937b4306"/>
-    <p:sldId xmlns:r="http://schemas.openxmlformats.org/officeDocument/2006/relationships" id="284" r:id="R4bec77a708da4d50"/>
-    <p:sldId xmlns:r="http://schemas.openxmlformats.org/officeDocument/2006/relationships" id="285" r:id="R83ed80cd62744524"/>
-    <p:sldId xmlns:r="http://schemas.openxmlformats.org/officeDocument/2006/relationships" id="286" r:id="R0897421f29c14e93"/>
-    <p:sldId xmlns:r="http://schemas.openxmlformats.org/officeDocument/2006/relationships" id="287" r:id="R5a9a0864bb784381"/>
-    <p:sldId xmlns:r="http://schemas.openxmlformats.org/officeDocument/2006/relationships" id="288" r:id="Red29e4a87199424d"/>
-    <p:sldId xmlns:r="http://schemas.openxmlformats.org/officeDocument/2006/relationships" id="289" r:id="R57ac3f8eabc74569"/>
-    <p:sldId xmlns:r="http://schemas.openxmlformats.org/officeDocument/2006/relationships" id="290" r:id="R633d30c013064496"/>
-    <p:sldId xmlns:r="http://schemas.openxmlformats.org/officeDocument/2006/relationships" id="291" r:id="R18136bb9aff14e38"/>
+    <p:sldId xmlns:r="http://schemas.openxmlformats.org/officeDocument/2006/relationships" id="256" r:id="Rf9fd0ece3a8a41dc"/>
+    <p:sldId xmlns:r="http://schemas.openxmlformats.org/officeDocument/2006/relationships" id="257" r:id="Rb2f4ad4560634e7a"/>
+    <p:sldId xmlns:r="http://schemas.openxmlformats.org/officeDocument/2006/relationships" id="258" r:id="R3114b50427994abd"/>
+    <p:sldId xmlns:r="http://schemas.openxmlformats.org/officeDocument/2006/relationships" id="259" r:id="R076897a53e554eac"/>
+    <p:sldId xmlns:r="http://schemas.openxmlformats.org/officeDocument/2006/relationships" id="260" r:id="R96c104310939406a"/>
+    <p:sldId xmlns:r="http://schemas.openxmlformats.org/officeDocument/2006/relationships" id="261" r:id="R81637e5938a94e3a"/>
+    <p:sldId xmlns:r="http://schemas.openxmlformats.org/officeDocument/2006/relationships" id="262" r:id="R3b456fded7464de2"/>
+    <p:sldId xmlns:r="http://schemas.openxmlformats.org/officeDocument/2006/relationships" id="263" r:id="R890a0b3b3ab64634"/>
+    <p:sldId xmlns:r="http://schemas.openxmlformats.org/officeDocument/2006/relationships" id="264" r:id="Rad0a0cb960da4881"/>
+    <p:sldId xmlns:r="http://schemas.openxmlformats.org/officeDocument/2006/relationships" id="265" r:id="R17c2afbf1264427e"/>
+    <p:sldId xmlns:r="http://schemas.openxmlformats.org/officeDocument/2006/relationships" id="266" r:id="Rb9e2e665ca2e4192"/>
+    <p:sldId xmlns:r="http://schemas.openxmlformats.org/officeDocument/2006/relationships" id="267" r:id="Re53e924c172047a4"/>
+    <p:sldId xmlns:r="http://schemas.openxmlformats.org/officeDocument/2006/relationships" id="268" r:id="Reada4685aa794fc5"/>
+    <p:sldId xmlns:r="http://schemas.openxmlformats.org/officeDocument/2006/relationships" id="269" r:id="R9911bc4867d347dc"/>
+    <p:sldId xmlns:r="http://schemas.openxmlformats.org/officeDocument/2006/relationships" id="270" r:id="R037621eb7826422c"/>
+    <p:sldId xmlns:r="http://schemas.openxmlformats.org/officeDocument/2006/relationships" id="271" r:id="Racf5a6bfca984a91"/>
+    <p:sldId xmlns:r="http://schemas.openxmlformats.org/officeDocument/2006/relationships" id="272" r:id="Rcabe9b8f84a44765"/>
+    <p:sldId xmlns:r="http://schemas.openxmlformats.org/officeDocument/2006/relationships" id="273" r:id="Rc86f68cb1898418e"/>
+    <p:sldId xmlns:r="http://schemas.openxmlformats.org/officeDocument/2006/relationships" id="274" r:id="Rd6cd8fe59854403a"/>
+    <p:sldId xmlns:r="http://schemas.openxmlformats.org/officeDocument/2006/relationships" id="275" r:id="Rff7e36fae2bf4888"/>
+    <p:sldId xmlns:r="http://schemas.openxmlformats.org/officeDocument/2006/relationships" id="276" r:id="R8ed6577ecd4a4a33"/>
+    <p:sldId xmlns:r="http://schemas.openxmlformats.org/officeDocument/2006/relationships" id="277" r:id="Raf33c35961ce4875"/>
+    <p:sldId xmlns:r="http://schemas.openxmlformats.org/officeDocument/2006/relationships" id="278" r:id="R2eef0e87c8774098"/>
+    <p:sldId xmlns:r="http://schemas.openxmlformats.org/officeDocument/2006/relationships" id="279" r:id="Rb14ad18c8fa44c9e"/>
+    <p:sldId xmlns:r="http://schemas.openxmlformats.org/officeDocument/2006/relationships" id="280" r:id="Rffb17211edc04a81"/>
+    <p:sldId xmlns:r="http://schemas.openxmlformats.org/officeDocument/2006/relationships" id="281" r:id="R785ef2b63b204ed2"/>
+    <p:sldId xmlns:r="http://schemas.openxmlformats.org/officeDocument/2006/relationships" id="282" r:id="R59e2f8c865e444a3"/>
+    <p:sldId xmlns:r="http://schemas.openxmlformats.org/officeDocument/2006/relationships" id="283" r:id="R29cefafe8c494999"/>
+    <p:sldId xmlns:r="http://schemas.openxmlformats.org/officeDocument/2006/relationships" id="284" r:id="R1c1b2b851d4e4faf"/>
+    <p:sldId xmlns:r="http://schemas.openxmlformats.org/officeDocument/2006/relationships" id="285" r:id="R94113eaca2e440dc"/>
+    <p:sldId xmlns:r="http://schemas.openxmlformats.org/officeDocument/2006/relationships" id="286" r:id="Re7124135696f48bb"/>
+    <p:sldId xmlns:r="http://schemas.openxmlformats.org/officeDocument/2006/relationships" id="287" r:id="R4889908239274b90"/>
+    <p:sldId xmlns:r="http://schemas.openxmlformats.org/officeDocument/2006/relationships" id="288" r:id="R9386b35d5d064617"/>
+    <p:sldId xmlns:r="http://schemas.openxmlformats.org/officeDocument/2006/relationships" id="289" r:id="R0ad9fe237f174f06"/>
+    <p:sldId xmlns:r="http://schemas.openxmlformats.org/officeDocument/2006/relationships" id="290" r:id="R8e5ba5a3844240da"/>
+    <p:sldId xmlns:r="http://schemas.openxmlformats.org/officeDocument/2006/relationships" id="291" r:id="R2acb619359c04500"/>
   </p:sldIdLst>
   <p:sldSz cx="12192000" cy="6858000"/>
   <p:notesSz cx="6858000" cy="9144000"/>
@@ -687,7 +687,7 @@
           <a:lstStyle xmlns:a="http://schemas.openxmlformats.org/drawingml/2006/main"/>
           <a:p xmlns:a="http://schemas.openxmlformats.org/drawingml/2006/main">
             <a:r>
-              <a:t>Private engineering review, 5 October 2026. Sources: Station model registry and dated model-role/production receipts. Qwen 27B is the project label for its quantized local build. Recorded scheduled-owner use includes an accepted 4,916-token local narration/graphics decision, without a new cloud request. Specialist registration and historical execution do not establish current simultaneous readiness or complete film acceptance. No addresses, prompts, leases or private production data are disclosed.</a:t>
+              <a:t>The model list is a baseline configuration, not a permanent dependency. Replacement models require compatible adapters, sufficient resources and validation for the assigned task. Broader provider substitution is a development direction, not verified plug-and-play support for every model. Private engineering review, 5 October 2026. Sources: Station model registry and dated model-role/production receipts. Qwen 27B is the project label for its quantized local build. Recorded scheduled-owner use includes an accepted 4,916-token local narration/graphics decision, without a new cloud request. Specialist registration and historical execution do not establish current simultaneous readiness or complete film acceptance. No addresses, prompts, leases or private production data are disclosed.</a:t>
             </a:r>
           </a:p>
         </p:txBody>
@@ -2995,7 +2995,7 @@
   </p:cSld>
   <p:clrMap bg1="lt1" tx1="dk1" bg2="lt2" tx2="dk2" accent1="accent1" accent2="accent2" accent3="accent3" accent4="accent4" accent5="accent5" accent6="accent6" hlink="hlink" folHlink="folHlink"/>
   <p:sldLayoutIdLst>
-    <p:sldLayoutId xmlns:r="http://schemas.openxmlformats.org/officeDocument/2006/relationships" id="2147483649" r:id="R209b5c799e5e41c1"/>
+    <p:sldLayoutId xmlns:r="http://schemas.openxmlformats.org/officeDocument/2006/relationships" id="2147483649" r:id="Rc3ea95d8c24f4d6c"/>
   </p:sldLayoutIdLst>
   <p:txStyles>
     <p:titleStyle>
@@ -3550,7 +3550,7 @@
           <p:nvPr/>
         </p:nvPicPr>
         <p:blipFill>
-          <a:blip xmlns:r="http://schemas.openxmlformats.org/officeDocument/2006/relationships" xmlns:a="http://schemas.openxmlformats.org/drawingml/2006/main" r:embed="R16aa6313f63744db"/>
+          <a:blip xmlns:r="http://schemas.openxmlformats.org/officeDocument/2006/relationships" xmlns:a="http://schemas.openxmlformats.org/drawingml/2006/main" r:embed="Rb8a4005bfff34d58"/>
           <a:srcRect xmlns:a="http://schemas.openxmlformats.org/drawingml/2006/main" l="0" t="27" r="0" b="27"/>
           <a:stretch xmlns:a="http://schemas.openxmlformats.org/drawingml/2006/main">
             <a:fillRect l="0" t="0" r="0" b="0"/>
@@ -3571,7 +3571,7 @@
           <p:cNvPr id="2" name="">
             <a:extLst xmlns:a="http://schemas.openxmlformats.org/drawingml/2006/main">
               <a:ext uri="{FF2B5EF4-FFF2-40B4-BE49-F238E27FC236}">
-                <a16:creationId xmlns:a16="http://schemas.microsoft.com/office/drawing/2014/main" id="{7A9AB16F-AE2C-4CF6-A113-D0939831DAD6}"/>
+                <a16:creationId xmlns:a16="http://schemas.microsoft.com/office/drawing/2014/main" id="{C7C31E07-DF6A-4BB8-BC0C-6B93B6AF2D0A}"/>
               </a:ext>
             </a:extLst>
           </p:cNvPr>
@@ -3628,7 +3628,7 @@
           <p:cNvPr id="3" name="">
             <a:extLst xmlns:a="http://schemas.openxmlformats.org/drawingml/2006/main">
               <a:ext uri="{FF2B5EF4-FFF2-40B4-BE49-F238E27FC236}">
-                <a16:creationId xmlns:a16="http://schemas.microsoft.com/office/drawing/2014/main" id="{37D88397-F3C6-4EF1-B51F-73271C5EDFAD}"/>
+                <a16:creationId xmlns:a16="http://schemas.microsoft.com/office/drawing/2014/main" id="{00005F2B-FC69-4FB8-8333-7FB6AC733EB0}"/>
               </a:ext>
             </a:extLst>
           </p:cNvPr>
@@ -3708,7 +3708,7 @@
           <p:cNvPr id="4" name="">
             <a:extLst xmlns:a="http://schemas.openxmlformats.org/drawingml/2006/main">
               <a:ext uri="{FF2B5EF4-FFF2-40B4-BE49-F238E27FC236}">
-                <a16:creationId xmlns:a16="http://schemas.microsoft.com/office/drawing/2014/main" id="{4A9510F0-9437-4D52-97B5-ADF15497E695}"/>
+                <a16:creationId xmlns:a16="http://schemas.microsoft.com/office/drawing/2014/main" id="{3A2595BB-9C7A-4892-B12B-F31EEF512597}"/>
               </a:ext>
             </a:extLst>
           </p:cNvPr>
@@ -3788,7 +3788,7 @@
           <p:cNvPr id="5" name="">
             <a:extLst xmlns:a="http://schemas.openxmlformats.org/drawingml/2006/main">
               <a:ext uri="{FF2B5EF4-FFF2-40B4-BE49-F238E27FC236}">
-                <a16:creationId xmlns:a16="http://schemas.microsoft.com/office/drawing/2014/main" id="{12D11C8F-10B1-4EA9-9C26-1C0649CD7707}"/>
+                <a16:creationId xmlns:a16="http://schemas.microsoft.com/office/drawing/2014/main" id="{2B6C0594-FFED-4C2F-9FE4-BD8258D20331}"/>
               </a:ext>
             </a:extLst>
           </p:cNvPr>
@@ -3866,7 +3866,7 @@
     </p:spTree>
     <p:extLst>
       <p:ext uri="{BB962C8B-B14F-4D97-AF65-F5344CB8AC3E}">
-        <p14:creationId xmlns:p14="http://schemas.microsoft.com/office/powerpoint/2010/main" val="1927666894"/>
+        <p14:creationId xmlns:p14="http://schemas.microsoft.com/office/powerpoint/2010/main" val="1993221493"/>
       </p:ext>
     </p:extLst>
   </p:cSld>
@@ -3897,7 +3897,7 @@
           <p:cNvPr id="15" name="">
             <a:extLst xmlns:a="http://schemas.openxmlformats.org/drawingml/2006/main">
               <a:ext uri="{FF2B5EF4-FFF2-40B4-BE49-F238E27FC236}">
-                <a16:creationId xmlns:a16="http://schemas.microsoft.com/office/drawing/2014/main" id="{1D6EBE02-26F3-4847-A581-409BCD49405C}"/>
+                <a16:creationId xmlns:a16="http://schemas.microsoft.com/office/drawing/2014/main" id="{73247C13-08EB-43E0-8895-B7D5510E537C}"/>
               </a:ext>
             </a:extLst>
           </p:cNvPr>
@@ -3954,7 +3954,7 @@
           <p:cNvPr id="2" name="">
             <a:extLst xmlns:a="http://schemas.openxmlformats.org/drawingml/2006/main">
               <a:ext uri="{FF2B5EF4-FFF2-40B4-BE49-F238E27FC236}">
-                <a16:creationId xmlns:a16="http://schemas.microsoft.com/office/drawing/2014/main" id="{92AA4D15-66BA-4235-9D3D-7693598EB56D}"/>
+                <a16:creationId xmlns:a16="http://schemas.microsoft.com/office/drawing/2014/main" id="{074A8A80-36CE-4ABE-B422-652E07091DC2}"/>
               </a:ext>
             </a:extLst>
           </p:cNvPr>
@@ -4011,7 +4011,7 @@
           <p:cNvPr id="3" name="">
             <a:extLst xmlns:a="http://schemas.openxmlformats.org/drawingml/2006/main">
               <a:ext uri="{FF2B5EF4-FFF2-40B4-BE49-F238E27FC236}">
-                <a16:creationId xmlns:a16="http://schemas.microsoft.com/office/drawing/2014/main" id="{1774FC4B-A2AB-4B3B-B9B3-2AE4B36C1B88}"/>
+                <a16:creationId xmlns:a16="http://schemas.microsoft.com/office/drawing/2014/main" id="{31B011EB-5F7F-4154-96DF-AD11EE5B72E9}"/>
               </a:ext>
             </a:extLst>
           </p:cNvPr>
@@ -4072,7 +4072,7 @@
           <p:cNvPr id="4" name="">
             <a:extLst xmlns:a="http://schemas.openxmlformats.org/drawingml/2006/main">
               <a:ext uri="{FF2B5EF4-FFF2-40B4-BE49-F238E27FC236}">
-                <a16:creationId xmlns:a16="http://schemas.microsoft.com/office/drawing/2014/main" id="{E1E21AEE-E12A-42D1-AF21-9CE5B267B0E4}"/>
+                <a16:creationId xmlns:a16="http://schemas.microsoft.com/office/drawing/2014/main" id="{46075DA5-7073-4C17-8A86-A47E1C727F8E}"/>
               </a:ext>
             </a:extLst>
           </p:cNvPr>
@@ -4133,7 +4133,7 @@
           <p:cNvPr id="5" name="">
             <a:extLst xmlns:a="http://schemas.openxmlformats.org/drawingml/2006/main">
               <a:ext uri="{FF2B5EF4-FFF2-40B4-BE49-F238E27FC236}">
-                <a16:creationId xmlns:a16="http://schemas.microsoft.com/office/drawing/2014/main" id="{73838A4A-CB3F-4CCC-8E22-D35A8C410D50}"/>
+                <a16:creationId xmlns:a16="http://schemas.microsoft.com/office/drawing/2014/main" id="{5E7D57F9-15AE-413E-898B-6A3875C75DCB}"/>
               </a:ext>
             </a:extLst>
           </p:cNvPr>
@@ -4194,7 +4194,7 @@
           <p:cNvPr id="6" name="">
             <a:extLst xmlns:a="http://schemas.openxmlformats.org/drawingml/2006/main">
               <a:ext uri="{FF2B5EF4-FFF2-40B4-BE49-F238E27FC236}">
-                <a16:creationId xmlns:a16="http://schemas.microsoft.com/office/drawing/2014/main" id="{A281E747-1778-4BAB-982D-7C93595A6473}"/>
+                <a16:creationId xmlns:a16="http://schemas.microsoft.com/office/drawing/2014/main" id="{AA847E6C-1C12-4975-B645-DE945012E3C6}"/>
               </a:ext>
             </a:extLst>
           </p:cNvPr>
@@ -4330,7 +4330,7 @@
           <p:cNvPr id="10" name="">
             <a:extLst xmlns:a="http://schemas.openxmlformats.org/drawingml/2006/main">
               <a:ext uri="{FF2B5EF4-FFF2-40B4-BE49-F238E27FC236}">
-                <a16:creationId xmlns:a16="http://schemas.microsoft.com/office/drawing/2014/main" id="{CE3369D6-0B2F-4FBE-911D-53B7409011BA}"/>
+                <a16:creationId xmlns:a16="http://schemas.microsoft.com/office/drawing/2014/main" id="{F69A11B6-304E-4122-9138-492954A1FAC4}"/>
               </a:ext>
             </a:extLst>
           </p:cNvPr>
@@ -4387,7 +4387,7 @@
           <p:cNvPr id="11" name="">
             <a:extLst xmlns:a="http://schemas.openxmlformats.org/drawingml/2006/main">
               <a:ext uri="{FF2B5EF4-FFF2-40B4-BE49-F238E27FC236}">
-                <a16:creationId xmlns:a16="http://schemas.microsoft.com/office/drawing/2014/main" id="{1CD5BE6A-98E2-464C-B1DE-AEBEF5AEAB50}"/>
+                <a16:creationId xmlns:a16="http://schemas.microsoft.com/office/drawing/2014/main" id="{B6917653-CB42-4B71-A820-EDD4DAC791B7}"/>
               </a:ext>
             </a:extLst>
           </p:cNvPr>
@@ -4444,7 +4444,7 @@
           <p:cNvPr id="12" name="">
             <a:extLst xmlns:a="http://schemas.openxmlformats.org/drawingml/2006/main">
               <a:ext uri="{FF2B5EF4-FFF2-40B4-BE49-F238E27FC236}">
-                <a16:creationId xmlns:a16="http://schemas.microsoft.com/office/drawing/2014/main" id="{AAE9C745-03AC-4C69-8397-F1A3904FCD84}"/>
+                <a16:creationId xmlns:a16="http://schemas.microsoft.com/office/drawing/2014/main" id="{9E9B82BA-6161-4EFB-89D2-E404E6EAE1AD}"/>
               </a:ext>
             </a:extLst>
           </p:cNvPr>
@@ -4501,7 +4501,7 @@
           <p:cNvPr id="13" name="">
             <a:extLst xmlns:a="http://schemas.openxmlformats.org/drawingml/2006/main">
               <a:ext uri="{FF2B5EF4-FFF2-40B4-BE49-F238E27FC236}">
-                <a16:creationId xmlns:a16="http://schemas.microsoft.com/office/drawing/2014/main" id="{2F165985-933B-40FE-B337-5E5D80959710}"/>
+                <a16:creationId xmlns:a16="http://schemas.microsoft.com/office/drawing/2014/main" id="{2222CBE5-666D-42F3-8B49-E4D9BF3343AD}"/>
               </a:ext>
             </a:extLst>
           </p:cNvPr>
@@ -4558,7 +4558,7 @@
           <p:cNvPr id="14" name="">
             <a:extLst xmlns:a="http://schemas.openxmlformats.org/drawingml/2006/main">
               <a:ext uri="{FF2B5EF4-FFF2-40B4-BE49-F238E27FC236}">
-                <a16:creationId xmlns:a16="http://schemas.microsoft.com/office/drawing/2014/main" id="{149F8BC2-4A68-4637-94DF-797DE0880D31}"/>
+                <a16:creationId xmlns:a16="http://schemas.microsoft.com/office/drawing/2014/main" id="{B15A24E7-BC14-49ED-9835-80C2F2B32FFD}"/>
               </a:ext>
             </a:extLst>
           </p:cNvPr>
@@ -4613,7 +4613,7 @@
     </p:spTree>
     <p:extLst>
       <p:ext uri="{BB962C8B-B14F-4D97-AF65-F5344CB8AC3E}">
-        <p14:creationId xmlns:p14="http://schemas.microsoft.com/office/powerpoint/2010/main" val="375392135"/>
+        <p14:creationId xmlns:p14="http://schemas.microsoft.com/office/powerpoint/2010/main" val="878599602"/>
       </p:ext>
     </p:extLst>
   </p:cSld>
@@ -4644,7 +4644,7 @@
           <p:cNvPr id="12" name="">
             <a:extLst xmlns:a="http://schemas.openxmlformats.org/drawingml/2006/main">
               <a:ext uri="{FF2B5EF4-FFF2-40B4-BE49-F238E27FC236}">
-                <a16:creationId xmlns:a16="http://schemas.microsoft.com/office/drawing/2014/main" id="{2E09FEFE-63AB-41B4-9B86-3C408163BEBA}"/>
+                <a16:creationId xmlns:a16="http://schemas.microsoft.com/office/drawing/2014/main" id="{627BDB27-CF78-4EF5-B33F-8011EFD23CA8}"/>
               </a:ext>
             </a:extLst>
           </p:cNvPr>
@@ -4701,7 +4701,7 @@
           <p:cNvPr id="2" name="">
             <a:extLst xmlns:a="http://schemas.openxmlformats.org/drawingml/2006/main">
               <a:ext uri="{FF2B5EF4-FFF2-40B4-BE49-F238E27FC236}">
-                <a16:creationId xmlns:a16="http://schemas.microsoft.com/office/drawing/2014/main" id="{00278CFC-778E-4AEF-A64F-0EEAF99FE100}"/>
+                <a16:creationId xmlns:a16="http://schemas.microsoft.com/office/drawing/2014/main" id="{DC7D8FEB-3FF8-40E5-8A6C-BEEDED189133}"/>
               </a:ext>
             </a:extLst>
           </p:cNvPr>
@@ -4758,7 +4758,7 @@
           <p:cNvPr id="3" name="">
             <a:extLst xmlns:a="http://schemas.openxmlformats.org/drawingml/2006/main">
               <a:ext uri="{FF2B5EF4-FFF2-40B4-BE49-F238E27FC236}">
-                <a16:creationId xmlns:a16="http://schemas.microsoft.com/office/drawing/2014/main" id="{94E41EE1-44F8-4E29-907F-6F8B8B901D61}"/>
+                <a16:creationId xmlns:a16="http://schemas.microsoft.com/office/drawing/2014/main" id="{8225F23B-C521-47BA-97C3-C88A7DA15171}"/>
               </a:ext>
             </a:extLst>
           </p:cNvPr>
@@ -4815,7 +4815,7 @@
           <p:cNvPr id="4" name="">
             <a:extLst xmlns:a="http://schemas.openxmlformats.org/drawingml/2006/main">
               <a:ext uri="{FF2B5EF4-FFF2-40B4-BE49-F238E27FC236}">
-                <a16:creationId xmlns:a16="http://schemas.microsoft.com/office/drawing/2014/main" id="{356639A2-1B59-4AE8-A4B7-9D8D529F654A}"/>
+                <a16:creationId xmlns:a16="http://schemas.microsoft.com/office/drawing/2014/main" id="{C81C207A-9A34-4B38-B1E2-E2BBC2786B65}"/>
               </a:ext>
             </a:extLst>
           </p:cNvPr>
@@ -4872,7 +4872,7 @@
           <p:cNvPr id="5" name="">
             <a:extLst xmlns:a="http://schemas.openxmlformats.org/drawingml/2006/main">
               <a:ext uri="{FF2B5EF4-FFF2-40B4-BE49-F238E27FC236}">
-                <a16:creationId xmlns:a16="http://schemas.microsoft.com/office/drawing/2014/main" id="{7263A042-A8DE-4F5E-B2FA-1EECAA69C991}"/>
+                <a16:creationId xmlns:a16="http://schemas.microsoft.com/office/drawing/2014/main" id="{C207CDC0-12A3-4D09-BE0E-4B920B5388A2}"/>
               </a:ext>
             </a:extLst>
           </p:cNvPr>
@@ -4929,7 +4929,7 @@
           <p:cNvPr id="6" name="">
             <a:extLst xmlns:a="http://schemas.openxmlformats.org/drawingml/2006/main">
               <a:ext uri="{FF2B5EF4-FFF2-40B4-BE49-F238E27FC236}">
-                <a16:creationId xmlns:a16="http://schemas.microsoft.com/office/drawing/2014/main" id="{20F915CD-147A-4A8D-880F-933E59A62435}"/>
+                <a16:creationId xmlns:a16="http://schemas.microsoft.com/office/drawing/2014/main" id="{F8A8B951-CB53-4900-8C69-E146FA4B4D45}"/>
               </a:ext>
             </a:extLst>
           </p:cNvPr>
@@ -5032,7 +5032,7 @@
           <p:cNvPr id="7" name="">
             <a:extLst xmlns:a="http://schemas.openxmlformats.org/drawingml/2006/main">
               <a:ext uri="{FF2B5EF4-FFF2-40B4-BE49-F238E27FC236}">
-                <a16:creationId xmlns:a16="http://schemas.microsoft.com/office/drawing/2014/main" id="{78674C58-FA60-4176-AFD2-3C0FD1D5EF03}"/>
+                <a16:creationId xmlns:a16="http://schemas.microsoft.com/office/drawing/2014/main" id="{3C583A31-4D85-40DA-8BB7-74928DA370A5}"/>
               </a:ext>
             </a:extLst>
           </p:cNvPr>
@@ -5089,7 +5089,7 @@
           <p:cNvPr id="8" name="">
             <a:extLst xmlns:a="http://schemas.openxmlformats.org/drawingml/2006/main">
               <a:ext uri="{FF2B5EF4-FFF2-40B4-BE49-F238E27FC236}">
-                <a16:creationId xmlns:a16="http://schemas.microsoft.com/office/drawing/2014/main" id="{9EF92658-2517-4E03-9E75-79781E8420BA}"/>
+                <a16:creationId xmlns:a16="http://schemas.microsoft.com/office/drawing/2014/main" id="{37CC72D8-6AFC-4D8B-874E-F3777736373A}"/>
               </a:ext>
             </a:extLst>
           </p:cNvPr>
@@ -5192,7 +5192,7 @@
           <p:cNvPr id="9" name="">
             <a:extLst xmlns:a="http://schemas.openxmlformats.org/drawingml/2006/main">
               <a:ext uri="{FF2B5EF4-FFF2-40B4-BE49-F238E27FC236}">
-                <a16:creationId xmlns:a16="http://schemas.microsoft.com/office/drawing/2014/main" id="{9A6546B9-6077-4B58-AFA5-8C7D9B370316}"/>
+                <a16:creationId xmlns:a16="http://schemas.microsoft.com/office/drawing/2014/main" id="{868D795B-7B61-404A-A734-9ED70342497A}"/>
               </a:ext>
             </a:extLst>
           </p:cNvPr>
@@ -5249,7 +5249,7 @@
           <p:cNvPr id="10" name="">
             <a:extLst xmlns:a="http://schemas.openxmlformats.org/drawingml/2006/main">
               <a:ext uri="{FF2B5EF4-FFF2-40B4-BE49-F238E27FC236}">
-                <a16:creationId xmlns:a16="http://schemas.microsoft.com/office/drawing/2014/main" id="{0B88B744-E9E0-4409-8D8C-3002E90AC5FE}"/>
+                <a16:creationId xmlns:a16="http://schemas.microsoft.com/office/drawing/2014/main" id="{79BE4006-F656-4353-91D5-4F1123BB9B54}"/>
               </a:ext>
             </a:extLst>
           </p:cNvPr>
@@ -5352,7 +5352,7 @@
           <p:cNvPr id="11" name="">
             <a:extLst xmlns:a="http://schemas.openxmlformats.org/drawingml/2006/main">
               <a:ext uri="{FF2B5EF4-FFF2-40B4-BE49-F238E27FC236}">
-                <a16:creationId xmlns:a16="http://schemas.microsoft.com/office/drawing/2014/main" id="{FFEB1AD7-C38F-488A-AD3E-0EE70FA34AE2}"/>
+                <a16:creationId xmlns:a16="http://schemas.microsoft.com/office/drawing/2014/main" id="{D5114543-99BD-452A-A5E5-7D012B0A91CF}"/>
               </a:ext>
             </a:extLst>
           </p:cNvPr>
@@ -5407,7 +5407,7 @@
     </p:spTree>
     <p:extLst>
       <p:ext uri="{BB962C8B-B14F-4D97-AF65-F5344CB8AC3E}">
-        <p14:creationId xmlns:p14="http://schemas.microsoft.com/office/powerpoint/2010/main" val="1720160613"/>
+        <p14:creationId xmlns:p14="http://schemas.microsoft.com/office/powerpoint/2010/main" val="806095551"/>
       </p:ext>
     </p:extLst>
   </p:cSld>
@@ -5438,7 +5438,7 @@
           <p:cNvPr id="5" name="">
             <a:extLst xmlns:a="http://schemas.openxmlformats.org/drawingml/2006/main">
               <a:ext uri="{FF2B5EF4-FFF2-40B4-BE49-F238E27FC236}">
-                <a16:creationId xmlns:a16="http://schemas.microsoft.com/office/drawing/2014/main" id="{B398E0EE-955A-41DA-B21F-139801BCF0AD}"/>
+                <a16:creationId xmlns:a16="http://schemas.microsoft.com/office/drawing/2014/main" id="{C4282E62-D02D-4720-8E34-8896BFED768B}"/>
               </a:ext>
             </a:extLst>
           </p:cNvPr>
@@ -5495,7 +5495,7 @@
           <p:cNvPr id="2" name="">
             <a:extLst xmlns:a="http://schemas.openxmlformats.org/drawingml/2006/main">
               <a:ext uri="{FF2B5EF4-FFF2-40B4-BE49-F238E27FC236}">
-                <a16:creationId xmlns:a16="http://schemas.microsoft.com/office/drawing/2014/main" id="{08B9995F-12E1-46F8-9582-E9805BD29AD6}"/>
+                <a16:creationId xmlns:a16="http://schemas.microsoft.com/office/drawing/2014/main" id="{AC1CEA8C-BAD9-4190-B0B7-B1B2CDE0771B}"/>
               </a:ext>
             </a:extLst>
           </p:cNvPr>
@@ -6120,7 +6120,7 @@
           <p:cNvPr id="4" name="">
             <a:extLst xmlns:a="http://schemas.openxmlformats.org/drawingml/2006/main">
               <a:ext uri="{FF2B5EF4-FFF2-40B4-BE49-F238E27FC236}">
-                <a16:creationId xmlns:a16="http://schemas.microsoft.com/office/drawing/2014/main" id="{B2CB96AA-D84F-450E-92C1-FCA6CF2BCFA1}"/>
+                <a16:creationId xmlns:a16="http://schemas.microsoft.com/office/drawing/2014/main" id="{8CB05FB1-5733-4945-AB26-766B30B48F51}"/>
               </a:ext>
             </a:extLst>
           </p:cNvPr>
@@ -6167,7 +6167,7 @@
                 <a:ea typeface="Helvetica Neue"/>
                 <a:cs typeface="Helvetica Neue"/>
               </a:rPr>
-              <a:t>Code validates model outputs before execution. Recorded results support recovery and targeted repair.</a:t>
+              <a:t>Initial model set for available hardware. Compatible replacements must pass the same execution checks.</a:t>
             </a:r>
           </a:p>
         </p:txBody>
@@ -6175,7 +6175,7 @@
     </p:spTree>
     <p:extLst>
       <p:ext uri="{BB962C8B-B14F-4D97-AF65-F5344CB8AC3E}">
-        <p14:creationId xmlns:p14="http://schemas.microsoft.com/office/powerpoint/2010/main" val="1678685225"/>
+        <p14:creationId xmlns:p14="http://schemas.microsoft.com/office/powerpoint/2010/main" val="1772979675"/>
       </p:ext>
     </p:extLst>
   </p:cSld>
@@ -6206,7 +6206,7 @@
           <p:cNvPr id="13" name="">
             <a:extLst xmlns:a="http://schemas.openxmlformats.org/drawingml/2006/main">
               <a:ext uri="{FF2B5EF4-FFF2-40B4-BE49-F238E27FC236}">
-                <a16:creationId xmlns:a16="http://schemas.microsoft.com/office/drawing/2014/main" id="{1E2CA987-072D-42D5-B465-85059FB616FE}"/>
+                <a16:creationId xmlns:a16="http://schemas.microsoft.com/office/drawing/2014/main" id="{FA939C30-76BA-4933-84E4-07C68179A781}"/>
               </a:ext>
             </a:extLst>
           </p:cNvPr>
@@ -6263,7 +6263,7 @@
           <p:cNvPr id="2" name="">
             <a:extLst xmlns:a="http://schemas.openxmlformats.org/drawingml/2006/main">
               <a:ext uri="{FF2B5EF4-FFF2-40B4-BE49-F238E27FC236}">
-                <a16:creationId xmlns:a16="http://schemas.microsoft.com/office/drawing/2014/main" id="{A0A8AAF1-D46F-4114-A98C-C75ADA722087}"/>
+                <a16:creationId xmlns:a16="http://schemas.microsoft.com/office/drawing/2014/main" id="{D2EC53D5-0B8B-4765-907D-0D02E247358F}"/>
               </a:ext>
             </a:extLst>
           </p:cNvPr>
@@ -6320,7 +6320,7 @@
           <p:cNvPr id="3" name="">
             <a:extLst xmlns:a="http://schemas.openxmlformats.org/drawingml/2006/main">
               <a:ext uri="{FF2B5EF4-FFF2-40B4-BE49-F238E27FC236}">
-                <a16:creationId xmlns:a16="http://schemas.microsoft.com/office/drawing/2014/main" id="{390F04DF-1686-4D32-8D8E-751E1762D107}"/>
+                <a16:creationId xmlns:a16="http://schemas.microsoft.com/office/drawing/2014/main" id="{C208F05A-FFA7-439F-BF74-73DBF08ED889}"/>
               </a:ext>
             </a:extLst>
           </p:cNvPr>
@@ -6377,7 +6377,7 @@
           <p:cNvPr id="4" name="">
             <a:extLst xmlns:a="http://schemas.openxmlformats.org/drawingml/2006/main">
               <a:ext uri="{FF2B5EF4-FFF2-40B4-BE49-F238E27FC236}">
-                <a16:creationId xmlns:a16="http://schemas.microsoft.com/office/drawing/2014/main" id="{C3F9EC44-5922-4782-BBD7-C7BEA4CD6558}"/>
+                <a16:creationId xmlns:a16="http://schemas.microsoft.com/office/drawing/2014/main" id="{5F0189AC-86C1-4D5F-B89F-1736F7375AD3}"/>
               </a:ext>
             </a:extLst>
           </p:cNvPr>
@@ -6434,7 +6434,7 @@
           <p:cNvPr id="5" name="">
             <a:extLst xmlns:a="http://schemas.openxmlformats.org/drawingml/2006/main">
               <a:ext uri="{FF2B5EF4-FFF2-40B4-BE49-F238E27FC236}">
-                <a16:creationId xmlns:a16="http://schemas.microsoft.com/office/drawing/2014/main" id="{EEBA856D-D8E4-4061-A80C-A0AF1373F237}"/>
+                <a16:creationId xmlns:a16="http://schemas.microsoft.com/office/drawing/2014/main" id="{E6B1FBD6-341D-4F74-866A-4FA4D363AF31}"/>
               </a:ext>
             </a:extLst>
           </p:cNvPr>
@@ -6491,7 +6491,7 @@
           <p:cNvPr id="6" name="">
             <a:extLst xmlns:a="http://schemas.openxmlformats.org/drawingml/2006/main">
               <a:ext uri="{FF2B5EF4-FFF2-40B4-BE49-F238E27FC236}">
-                <a16:creationId xmlns:a16="http://schemas.microsoft.com/office/drawing/2014/main" id="{429AB762-45E6-4A30-B53C-71E997B0DDA2}"/>
+                <a16:creationId xmlns:a16="http://schemas.microsoft.com/office/drawing/2014/main" id="{12406987-7539-4F0B-923F-C0047C35D95A}"/>
               </a:ext>
             </a:extLst>
           </p:cNvPr>
@@ -6575,7 +6575,7 @@
           <p:cNvPr id="7" name="">
             <a:extLst xmlns:a="http://schemas.openxmlformats.org/drawingml/2006/main">
               <a:ext uri="{FF2B5EF4-FFF2-40B4-BE49-F238E27FC236}">
-                <a16:creationId xmlns:a16="http://schemas.microsoft.com/office/drawing/2014/main" id="{3302E785-171B-4606-9D1F-27C357EF7E2E}"/>
+                <a16:creationId xmlns:a16="http://schemas.microsoft.com/office/drawing/2014/main" id="{672E3348-D119-4AB3-9B5A-4786A34F249E}"/>
               </a:ext>
             </a:extLst>
           </p:cNvPr>
@@ -6659,7 +6659,7 @@
           <p:cNvPr id="8" name="">
             <a:extLst xmlns:a="http://schemas.openxmlformats.org/drawingml/2006/main">
               <a:ext uri="{FF2B5EF4-FFF2-40B4-BE49-F238E27FC236}">
-                <a16:creationId xmlns:a16="http://schemas.microsoft.com/office/drawing/2014/main" id="{5D95A02B-EB7C-400F-A481-818BE0914C1F}"/>
+                <a16:creationId xmlns:a16="http://schemas.microsoft.com/office/drawing/2014/main" id="{1CE6A730-F772-465E-8980-A6E9524389F9}"/>
               </a:ext>
             </a:extLst>
           </p:cNvPr>
@@ -6799,7 +6799,7 @@
           <p:cNvPr id="11" name="">
             <a:extLst xmlns:a="http://schemas.openxmlformats.org/drawingml/2006/main">
               <a:ext uri="{FF2B5EF4-FFF2-40B4-BE49-F238E27FC236}">
-                <a16:creationId xmlns:a16="http://schemas.microsoft.com/office/drawing/2014/main" id="{24E5B32D-01A1-4EA0-830E-256E48633C7E}"/>
+                <a16:creationId xmlns:a16="http://schemas.microsoft.com/office/drawing/2014/main" id="{15715618-D1ED-42AB-9A4C-72503C0F56B7}"/>
               </a:ext>
             </a:extLst>
           </p:cNvPr>
@@ -6846,7 +6846,7 @@
                 <a:ea typeface="Helvetica Neue"/>
                 <a:cs typeface="Helvetica Neue"/>
               </a:rPr>
-              <a:t>Cloud models handle tasks that exceed local quality or capacity. Station applies budgets and records outcomes.</a:t>
+              <a:t>Models can change with hardware and workload needs. Compatible adapters preserve task schemas, validation and Station control.</a:t>
             </a:r>
           </a:p>
         </p:txBody>
@@ -6856,7 +6856,7 @@
           <p:cNvPr id="12" name="">
             <a:extLst xmlns:a="http://schemas.openxmlformats.org/drawingml/2006/main">
               <a:ext uri="{FF2B5EF4-FFF2-40B4-BE49-F238E27FC236}">
-                <a16:creationId xmlns:a16="http://schemas.microsoft.com/office/drawing/2014/main" id="{0DB4FF88-FDAF-4DB7-BA97-9BBA80421BA6}"/>
+                <a16:creationId xmlns:a16="http://schemas.microsoft.com/office/drawing/2014/main" id="{B66EA466-F4CA-42B9-BF6E-3544FD5213F1}"/>
               </a:ext>
             </a:extLst>
           </p:cNvPr>
@@ -6911,7 +6911,7 @@
     </p:spTree>
     <p:extLst>
       <p:ext uri="{BB962C8B-B14F-4D97-AF65-F5344CB8AC3E}">
-        <p14:creationId xmlns:p14="http://schemas.microsoft.com/office/powerpoint/2010/main" val="703119702"/>
+        <p14:creationId xmlns:p14="http://schemas.microsoft.com/office/powerpoint/2010/main" val="1038894536"/>
       </p:ext>
     </p:extLst>
   </p:cSld>
@@ -6942,7 +6942,7 @@
           <p:cNvPr id="9" name="">
             <a:extLst xmlns:a="http://schemas.openxmlformats.org/drawingml/2006/main">
               <a:ext uri="{FF2B5EF4-FFF2-40B4-BE49-F238E27FC236}">
-                <a16:creationId xmlns:a16="http://schemas.microsoft.com/office/drawing/2014/main" id="{9545B6BE-2DAC-425F-8F26-EB86798170C1}"/>
+                <a16:creationId xmlns:a16="http://schemas.microsoft.com/office/drawing/2014/main" id="{0BE1342A-509C-474C-A884-9F3CDD13EED4}"/>
               </a:ext>
             </a:extLst>
           </p:cNvPr>
@@ -6999,7 +6999,7 @@
           <p:cNvPr id="2" name="">
             <a:extLst xmlns:a="http://schemas.openxmlformats.org/drawingml/2006/main">
               <a:ext uri="{FF2B5EF4-FFF2-40B4-BE49-F238E27FC236}">
-                <a16:creationId xmlns:a16="http://schemas.microsoft.com/office/drawing/2014/main" id="{4CD4EE67-3E79-4340-AD24-EEAF2A68D8E0}"/>
+                <a16:creationId xmlns:a16="http://schemas.microsoft.com/office/drawing/2014/main" id="{72CA787B-D8E5-4250-9BF8-1E9603ACB217}"/>
               </a:ext>
             </a:extLst>
           </p:cNvPr>
@@ -7056,7 +7056,7 @@
           <p:cNvPr id="3" name="">
             <a:extLst xmlns:a="http://schemas.openxmlformats.org/drawingml/2006/main">
               <a:ext uri="{FF2B5EF4-FFF2-40B4-BE49-F238E27FC236}">
-                <a16:creationId xmlns:a16="http://schemas.microsoft.com/office/drawing/2014/main" id="{377549E7-B909-4864-A354-DFA9BE67813D}"/>
+                <a16:creationId xmlns:a16="http://schemas.microsoft.com/office/drawing/2014/main" id="{52308F92-870E-4752-802D-2BAE0FEF04F0}"/>
               </a:ext>
             </a:extLst>
           </p:cNvPr>
@@ -7113,7 +7113,7 @@
           <p:cNvPr id="4" name="">
             <a:extLst xmlns:a="http://schemas.openxmlformats.org/drawingml/2006/main">
               <a:ext uri="{FF2B5EF4-FFF2-40B4-BE49-F238E27FC236}">
-                <a16:creationId xmlns:a16="http://schemas.microsoft.com/office/drawing/2014/main" id="{E32E6889-37A1-45E4-A550-AD919E2AE97A}"/>
+                <a16:creationId xmlns:a16="http://schemas.microsoft.com/office/drawing/2014/main" id="{B8C3D3AC-AA86-430D-BA15-88EC850CBB06}"/>
               </a:ext>
             </a:extLst>
           </p:cNvPr>
@@ -7170,7 +7170,7 @@
           <p:cNvPr id="5" name="">
             <a:extLst xmlns:a="http://schemas.openxmlformats.org/drawingml/2006/main">
               <a:ext uri="{FF2B5EF4-FFF2-40B4-BE49-F238E27FC236}">
-                <a16:creationId xmlns:a16="http://schemas.microsoft.com/office/drawing/2014/main" id="{CF2D53BF-9E0C-4326-BBEB-19FDFB00B168}"/>
+                <a16:creationId xmlns:a16="http://schemas.microsoft.com/office/drawing/2014/main" id="{69B40714-7EE2-4908-9CA4-91AD42EAF0A1}"/>
               </a:ext>
             </a:extLst>
           </p:cNvPr>
@@ -7227,7 +7227,7 @@
           <p:cNvPr id="6" name="">
             <a:extLst xmlns:a="http://schemas.openxmlformats.org/drawingml/2006/main">
               <a:ext uri="{FF2B5EF4-FFF2-40B4-BE49-F238E27FC236}">
-                <a16:creationId xmlns:a16="http://schemas.microsoft.com/office/drawing/2014/main" id="{CFD883AE-D055-4A20-AE13-0DB2E5478219}"/>
+                <a16:creationId xmlns:a16="http://schemas.microsoft.com/office/drawing/2014/main" id="{78A9C864-61C5-420A-8873-C1D13EC29C0A}"/>
               </a:ext>
             </a:extLst>
           </p:cNvPr>
@@ -7284,7 +7284,7 @@
           <p:cNvPr id="7" name="">
             <a:extLst xmlns:a="http://schemas.openxmlformats.org/drawingml/2006/main">
               <a:ext uri="{FF2B5EF4-FFF2-40B4-BE49-F238E27FC236}">
-                <a16:creationId xmlns:a16="http://schemas.microsoft.com/office/drawing/2014/main" id="{E8E63A81-511C-49DB-8D75-B7C03DAD67DE}"/>
+                <a16:creationId xmlns:a16="http://schemas.microsoft.com/office/drawing/2014/main" id="{40B7B89D-DDBE-4C7E-B1DD-E6A98F97B7A5}"/>
               </a:ext>
             </a:extLst>
           </p:cNvPr>
@@ -7341,7 +7341,7 @@
           <p:cNvPr id="8" name="">
             <a:extLst xmlns:a="http://schemas.openxmlformats.org/drawingml/2006/main">
               <a:ext uri="{FF2B5EF4-FFF2-40B4-BE49-F238E27FC236}">
-                <a16:creationId xmlns:a16="http://schemas.microsoft.com/office/drawing/2014/main" id="{67F9787B-6BE2-4E4C-8461-279F04F3D057}"/>
+                <a16:creationId xmlns:a16="http://schemas.microsoft.com/office/drawing/2014/main" id="{0353A54A-8AC4-47EC-8882-1F17D02F677D}"/>
               </a:ext>
             </a:extLst>
           </p:cNvPr>
@@ -7396,7 +7396,7 @@
     </p:spTree>
     <p:extLst>
       <p:ext uri="{BB962C8B-B14F-4D97-AF65-F5344CB8AC3E}">
-        <p14:creationId xmlns:p14="http://schemas.microsoft.com/office/powerpoint/2010/main" val="662648276"/>
+        <p14:creationId xmlns:p14="http://schemas.microsoft.com/office/powerpoint/2010/main" val="1093032746"/>
       </p:ext>
     </p:extLst>
   </p:cSld>
@@ -7427,7 +7427,7 @@
           <p:cNvPr id="10" name="">
             <a:extLst xmlns:a="http://schemas.openxmlformats.org/drawingml/2006/main">
               <a:ext uri="{FF2B5EF4-FFF2-40B4-BE49-F238E27FC236}">
-                <a16:creationId xmlns:a16="http://schemas.microsoft.com/office/drawing/2014/main" id="{4A3E8E31-3A95-4AB9-90BA-994E65B2FE76}"/>
+                <a16:creationId xmlns:a16="http://schemas.microsoft.com/office/drawing/2014/main" id="{B47DEF6E-DAB5-4E4F-8EF6-066C7D95276D}"/>
               </a:ext>
             </a:extLst>
           </p:cNvPr>
@@ -7484,7 +7484,7 @@
           <p:cNvPr id="2" name="">
             <a:extLst xmlns:a="http://schemas.openxmlformats.org/drawingml/2006/main">
               <a:ext uri="{FF2B5EF4-FFF2-40B4-BE49-F238E27FC236}">
-                <a16:creationId xmlns:a16="http://schemas.microsoft.com/office/drawing/2014/main" id="{1FB58C69-8A25-4DA2-9CF8-3588033173A4}"/>
+                <a16:creationId xmlns:a16="http://schemas.microsoft.com/office/drawing/2014/main" id="{B98EB146-818B-473F-BAB7-76DB90B406AE}"/>
               </a:ext>
             </a:extLst>
           </p:cNvPr>
@@ -7541,7 +7541,7 @@
           <p:cNvPr id="3" name="">
             <a:extLst xmlns:a="http://schemas.openxmlformats.org/drawingml/2006/main">
               <a:ext uri="{FF2B5EF4-FFF2-40B4-BE49-F238E27FC236}">
-                <a16:creationId xmlns:a16="http://schemas.microsoft.com/office/drawing/2014/main" id="{07B33C19-FB9C-416C-B602-40F60648D143}"/>
+                <a16:creationId xmlns:a16="http://schemas.microsoft.com/office/drawing/2014/main" id="{5A8D0406-2E32-47DE-9BB2-890779B19CDA}"/>
               </a:ext>
             </a:extLst>
           </p:cNvPr>
@@ -7598,7 +7598,7 @@
           <p:cNvPr id="4" name="">
             <a:extLst xmlns:a="http://schemas.openxmlformats.org/drawingml/2006/main">
               <a:ext uri="{FF2B5EF4-FFF2-40B4-BE49-F238E27FC236}">
-                <a16:creationId xmlns:a16="http://schemas.microsoft.com/office/drawing/2014/main" id="{FBFFE546-BBDA-4EB1-91EF-68611BF542FA}"/>
+                <a16:creationId xmlns:a16="http://schemas.microsoft.com/office/drawing/2014/main" id="{2FBE7258-A362-476A-A134-D84FED88DF03}"/>
               </a:ext>
             </a:extLst>
           </p:cNvPr>
@@ -7655,7 +7655,7 @@
           <p:cNvPr id="5" name="">
             <a:extLst xmlns:a="http://schemas.openxmlformats.org/drawingml/2006/main">
               <a:ext uri="{FF2B5EF4-FFF2-40B4-BE49-F238E27FC236}">
-                <a16:creationId xmlns:a16="http://schemas.microsoft.com/office/drawing/2014/main" id="{85E46BBC-29A3-4310-AAF8-828C11BD59D1}"/>
+                <a16:creationId xmlns:a16="http://schemas.microsoft.com/office/drawing/2014/main" id="{979EBFA0-40F6-4E9D-BAEA-E630DA274406}"/>
               </a:ext>
             </a:extLst>
           </p:cNvPr>
@@ -7712,7 +7712,7 @@
           <p:cNvPr id="6" name="">
             <a:extLst xmlns:a="http://schemas.openxmlformats.org/drawingml/2006/main">
               <a:ext uri="{FF2B5EF4-FFF2-40B4-BE49-F238E27FC236}">
-                <a16:creationId xmlns:a16="http://schemas.microsoft.com/office/drawing/2014/main" id="{0AD2AC6B-7DEA-445E-8832-7D7A7592BF93}"/>
+                <a16:creationId xmlns:a16="http://schemas.microsoft.com/office/drawing/2014/main" id="{010366AA-C4B1-416D-B622-6BBF43EDECCF}"/>
               </a:ext>
             </a:extLst>
           </p:cNvPr>
@@ -7769,7 +7769,7 @@
           <p:cNvPr id="7" name="">
             <a:extLst xmlns:a="http://schemas.openxmlformats.org/drawingml/2006/main">
               <a:ext uri="{FF2B5EF4-FFF2-40B4-BE49-F238E27FC236}">
-                <a16:creationId xmlns:a16="http://schemas.microsoft.com/office/drawing/2014/main" id="{61BBEB2F-3129-4BC0-9EC7-EE0E56D8B9AE}"/>
+                <a16:creationId xmlns:a16="http://schemas.microsoft.com/office/drawing/2014/main" id="{A9F469B1-1ADD-4ADF-BD1B-FFD8FC7EBA3D}"/>
               </a:ext>
             </a:extLst>
           </p:cNvPr>
@@ -7826,7 +7826,7 @@
           <p:cNvPr id="8" name="">
             <a:extLst xmlns:a="http://schemas.openxmlformats.org/drawingml/2006/main">
               <a:ext uri="{FF2B5EF4-FFF2-40B4-BE49-F238E27FC236}">
-                <a16:creationId xmlns:a16="http://schemas.microsoft.com/office/drawing/2014/main" id="{D2CFF7A6-4424-4606-807A-0833ADA1B7B0}"/>
+                <a16:creationId xmlns:a16="http://schemas.microsoft.com/office/drawing/2014/main" id="{7AB3B05F-0F78-43CA-B179-789E965AB0E6}"/>
               </a:ext>
             </a:extLst>
           </p:cNvPr>
@@ -7883,7 +7883,7 @@
           <p:cNvPr id="9" name="">
             <a:extLst xmlns:a="http://schemas.openxmlformats.org/drawingml/2006/main">
               <a:ext uri="{FF2B5EF4-FFF2-40B4-BE49-F238E27FC236}">
-                <a16:creationId xmlns:a16="http://schemas.microsoft.com/office/drawing/2014/main" id="{A42AEF44-FBE2-4AF4-9260-F477961246DD}"/>
+                <a16:creationId xmlns:a16="http://schemas.microsoft.com/office/drawing/2014/main" id="{A322F61C-E890-4D4B-93DE-22E6C9FA83A6}"/>
               </a:ext>
             </a:extLst>
           </p:cNvPr>
@@ -7938,7 +7938,7 @@
     </p:spTree>
     <p:extLst>
       <p:ext uri="{BB962C8B-B14F-4D97-AF65-F5344CB8AC3E}">
-        <p14:creationId xmlns:p14="http://schemas.microsoft.com/office/powerpoint/2010/main" val="34416153"/>
+        <p14:creationId xmlns:p14="http://schemas.microsoft.com/office/powerpoint/2010/main" val="1549367616"/>
       </p:ext>
     </p:extLst>
   </p:cSld>
@@ -7969,7 +7969,7 @@
           <p:cNvPr id="9" name="">
             <a:extLst xmlns:a="http://schemas.openxmlformats.org/drawingml/2006/main">
               <a:ext uri="{FF2B5EF4-FFF2-40B4-BE49-F238E27FC236}">
-                <a16:creationId xmlns:a16="http://schemas.microsoft.com/office/drawing/2014/main" id="{C4865BEF-A6B7-4087-BC23-DE20452FAE4F}"/>
+                <a16:creationId xmlns:a16="http://schemas.microsoft.com/office/drawing/2014/main" id="{E96078DA-07C1-4B5B-82B5-055542187597}"/>
               </a:ext>
             </a:extLst>
           </p:cNvPr>
@@ -8026,7 +8026,7 @@
           <p:cNvPr id="2" name="">
             <a:extLst xmlns:a="http://schemas.openxmlformats.org/drawingml/2006/main">
               <a:ext uri="{FF2B5EF4-FFF2-40B4-BE49-F238E27FC236}">
-                <a16:creationId xmlns:a16="http://schemas.microsoft.com/office/drawing/2014/main" id="{1C5CA805-60BD-4176-8845-F5269E73F517}"/>
+                <a16:creationId xmlns:a16="http://schemas.microsoft.com/office/drawing/2014/main" id="{32181633-C6F9-4658-8B7D-A42B650C0693}"/>
               </a:ext>
             </a:extLst>
           </p:cNvPr>
@@ -8083,7 +8083,7 @@
           <p:cNvPr id="3" name="">
             <a:extLst xmlns:a="http://schemas.openxmlformats.org/drawingml/2006/main">
               <a:ext uri="{FF2B5EF4-FFF2-40B4-BE49-F238E27FC236}">
-                <a16:creationId xmlns:a16="http://schemas.microsoft.com/office/drawing/2014/main" id="{3FD270E4-A8FD-4FED-AB4A-8313A7180025}"/>
+                <a16:creationId xmlns:a16="http://schemas.microsoft.com/office/drawing/2014/main" id="{2B048D33-B063-4FD6-BCFC-1DE8A82FA9B2}"/>
               </a:ext>
             </a:extLst>
           </p:cNvPr>
@@ -8140,7 +8140,7 @@
           <p:cNvPr id="4" name="">
             <a:extLst xmlns:a="http://schemas.openxmlformats.org/drawingml/2006/main">
               <a:ext uri="{FF2B5EF4-FFF2-40B4-BE49-F238E27FC236}">
-                <a16:creationId xmlns:a16="http://schemas.microsoft.com/office/drawing/2014/main" id="{ED27A261-58CF-4F2C-9859-E35A81E38A09}"/>
+                <a16:creationId xmlns:a16="http://schemas.microsoft.com/office/drawing/2014/main" id="{1A594370-5668-467B-862B-A7FD3F96B217}"/>
               </a:ext>
             </a:extLst>
           </p:cNvPr>
@@ -8197,7 +8197,7 @@
           <p:cNvPr id="5" name="">
             <a:extLst xmlns:a="http://schemas.openxmlformats.org/drawingml/2006/main">
               <a:ext uri="{FF2B5EF4-FFF2-40B4-BE49-F238E27FC236}">
-                <a16:creationId xmlns:a16="http://schemas.microsoft.com/office/drawing/2014/main" id="{CA7F62FB-47C2-4BA3-94B6-08301C0CE4CB}"/>
+                <a16:creationId xmlns:a16="http://schemas.microsoft.com/office/drawing/2014/main" id="{8723994B-95E8-4898-9B87-D56AE9F6C0BF}"/>
               </a:ext>
             </a:extLst>
           </p:cNvPr>
@@ -8254,7 +8254,7 @@
           <p:cNvPr id="6" name="">
             <a:extLst xmlns:a="http://schemas.openxmlformats.org/drawingml/2006/main">
               <a:ext uri="{FF2B5EF4-FFF2-40B4-BE49-F238E27FC236}">
-                <a16:creationId xmlns:a16="http://schemas.microsoft.com/office/drawing/2014/main" id="{E9A10828-24DD-40AA-A652-071FFC323FB0}"/>
+                <a16:creationId xmlns:a16="http://schemas.microsoft.com/office/drawing/2014/main" id="{4CEAD396-3CD4-43B9-AEC4-C8A69C9E78A9}"/>
               </a:ext>
             </a:extLst>
           </p:cNvPr>
@@ -8311,7 +8311,7 @@
           <p:cNvPr id="7" name="">
             <a:extLst xmlns:a="http://schemas.openxmlformats.org/drawingml/2006/main">
               <a:ext uri="{FF2B5EF4-FFF2-40B4-BE49-F238E27FC236}">
-                <a16:creationId xmlns:a16="http://schemas.microsoft.com/office/drawing/2014/main" id="{3B99277E-F467-48B5-92C6-012746C3A5F6}"/>
+                <a16:creationId xmlns:a16="http://schemas.microsoft.com/office/drawing/2014/main" id="{AE3A725E-B259-494B-9C61-B2B59F61ADB7}"/>
               </a:ext>
             </a:extLst>
           </p:cNvPr>
@@ -8368,7 +8368,7 @@
           <p:cNvPr id="8" name="">
             <a:extLst xmlns:a="http://schemas.openxmlformats.org/drawingml/2006/main">
               <a:ext uri="{FF2B5EF4-FFF2-40B4-BE49-F238E27FC236}">
-                <a16:creationId xmlns:a16="http://schemas.microsoft.com/office/drawing/2014/main" id="{BD1B3ED0-E354-4013-84C1-BBF761E6957E}"/>
+                <a16:creationId xmlns:a16="http://schemas.microsoft.com/office/drawing/2014/main" id="{787DBDBE-83B3-4FD5-8E95-FE2DA603D5AD}"/>
               </a:ext>
             </a:extLst>
           </p:cNvPr>
@@ -8423,7 +8423,7 @@
     </p:spTree>
     <p:extLst>
       <p:ext uri="{BB962C8B-B14F-4D97-AF65-F5344CB8AC3E}">
-        <p14:creationId xmlns:p14="http://schemas.microsoft.com/office/powerpoint/2010/main" val="671562204"/>
+        <p14:creationId xmlns:p14="http://schemas.microsoft.com/office/powerpoint/2010/main" val="1673122273"/>
       </p:ext>
     </p:extLst>
   </p:cSld>
@@ -8454,7 +8454,7 @@
           <p:cNvPr id="12" name="">
             <a:extLst xmlns:a="http://schemas.openxmlformats.org/drawingml/2006/main">
               <a:ext uri="{FF2B5EF4-FFF2-40B4-BE49-F238E27FC236}">
-                <a16:creationId xmlns:a16="http://schemas.microsoft.com/office/drawing/2014/main" id="{D748FC34-6DBE-4549-95AA-DF1372A29198}"/>
+                <a16:creationId xmlns:a16="http://schemas.microsoft.com/office/drawing/2014/main" id="{EFA3F543-9EFB-4739-ADC8-5596E92D3819}"/>
               </a:ext>
             </a:extLst>
           </p:cNvPr>
@@ -8511,7 +8511,7 @@
           <p:cNvPr id="2" name="">
             <a:extLst xmlns:a="http://schemas.openxmlformats.org/drawingml/2006/main">
               <a:ext uri="{FF2B5EF4-FFF2-40B4-BE49-F238E27FC236}">
-                <a16:creationId xmlns:a16="http://schemas.microsoft.com/office/drawing/2014/main" id="{3DE021A8-4E3E-4F77-A7DE-7BB2020E4BE9}"/>
+                <a16:creationId xmlns:a16="http://schemas.microsoft.com/office/drawing/2014/main" id="{A6376639-510C-45C3-82CB-3E66928F4876}"/>
               </a:ext>
             </a:extLst>
           </p:cNvPr>
@@ -8568,7 +8568,7 @@
           <p:cNvPr id="3" name="">
             <a:extLst xmlns:a="http://schemas.openxmlformats.org/drawingml/2006/main">
               <a:ext uri="{FF2B5EF4-FFF2-40B4-BE49-F238E27FC236}">
-                <a16:creationId xmlns:a16="http://schemas.microsoft.com/office/drawing/2014/main" id="{5D9A6868-83E7-4103-9477-83E7627B3F2E}"/>
+                <a16:creationId xmlns:a16="http://schemas.microsoft.com/office/drawing/2014/main" id="{363E8F37-F8EC-4AFE-AC5B-E0D8C7F958FF}"/>
               </a:ext>
             </a:extLst>
           </p:cNvPr>
@@ -8652,7 +8652,7 @@
           <p:cNvPr id="4" name="">
             <a:extLst xmlns:a="http://schemas.openxmlformats.org/drawingml/2006/main">
               <a:ext uri="{FF2B5EF4-FFF2-40B4-BE49-F238E27FC236}">
-                <a16:creationId xmlns:a16="http://schemas.microsoft.com/office/drawing/2014/main" id="{6AAC8F08-0CCB-49B8-9743-2417D0A650FF}"/>
+                <a16:creationId xmlns:a16="http://schemas.microsoft.com/office/drawing/2014/main" id="{6660C0C0-984E-4D5B-9001-E03C86E8DFE9}"/>
               </a:ext>
             </a:extLst>
           </p:cNvPr>
@@ -8736,7 +8736,7 @@
           <p:cNvPr id="5" name="">
             <a:extLst xmlns:a="http://schemas.openxmlformats.org/drawingml/2006/main">
               <a:ext uri="{FF2B5EF4-FFF2-40B4-BE49-F238E27FC236}">
-                <a16:creationId xmlns:a16="http://schemas.microsoft.com/office/drawing/2014/main" id="{06B753D3-3CCA-4FC6-A3C8-E559191743FE}"/>
+                <a16:creationId xmlns:a16="http://schemas.microsoft.com/office/drawing/2014/main" id="{81990C08-5F9B-40BF-920B-137CA26511CC}"/>
               </a:ext>
             </a:extLst>
           </p:cNvPr>
@@ -8870,7 +8870,7 @@
           <p:cNvPr id="8" name="">
             <a:extLst xmlns:a="http://schemas.openxmlformats.org/drawingml/2006/main">
               <a:ext uri="{FF2B5EF4-FFF2-40B4-BE49-F238E27FC236}">
-                <a16:creationId xmlns:a16="http://schemas.microsoft.com/office/drawing/2014/main" id="{2FE715F5-AF70-4FC9-8CEC-409012015F09}"/>
+                <a16:creationId xmlns:a16="http://schemas.microsoft.com/office/drawing/2014/main" id="{D6EEA0E9-EE74-45FD-A58C-75DC100ED866}"/>
               </a:ext>
             </a:extLst>
           </p:cNvPr>
@@ -8927,7 +8927,7 @@
           <p:cNvPr id="9" name="">
             <a:extLst xmlns:a="http://schemas.openxmlformats.org/drawingml/2006/main">
               <a:ext uri="{FF2B5EF4-FFF2-40B4-BE49-F238E27FC236}">
-                <a16:creationId xmlns:a16="http://schemas.microsoft.com/office/drawing/2014/main" id="{27DBEC43-C4E0-4E30-A819-DD0AE692314F}"/>
+                <a16:creationId xmlns:a16="http://schemas.microsoft.com/office/drawing/2014/main" id="{589566B4-9A2C-4C77-A291-A79584472D96}"/>
               </a:ext>
             </a:extLst>
           </p:cNvPr>
@@ -8984,7 +8984,7 @@
           <p:cNvPr id="10" name="">
             <a:extLst xmlns:a="http://schemas.openxmlformats.org/drawingml/2006/main">
               <a:ext uri="{FF2B5EF4-FFF2-40B4-BE49-F238E27FC236}">
-                <a16:creationId xmlns:a16="http://schemas.microsoft.com/office/drawing/2014/main" id="{B8FADAB9-568A-47D3-8D8E-D660BD7820D6}"/>
+                <a16:creationId xmlns:a16="http://schemas.microsoft.com/office/drawing/2014/main" id="{C6F019E4-B6AA-40D9-9745-60944C06BDDD}"/>
               </a:ext>
             </a:extLst>
           </p:cNvPr>
@@ -9041,7 +9041,7 @@
           <p:cNvPr id="11" name="">
             <a:extLst xmlns:a="http://schemas.openxmlformats.org/drawingml/2006/main">
               <a:ext uri="{FF2B5EF4-FFF2-40B4-BE49-F238E27FC236}">
-                <a16:creationId xmlns:a16="http://schemas.microsoft.com/office/drawing/2014/main" id="{991CDD63-0446-4B51-865C-46B99897141E}"/>
+                <a16:creationId xmlns:a16="http://schemas.microsoft.com/office/drawing/2014/main" id="{9BA6D3B2-F334-4BFC-9F11-ED7C31176BB9}"/>
               </a:ext>
             </a:extLst>
           </p:cNvPr>
@@ -9096,7 +9096,7 @@
     </p:spTree>
     <p:extLst>
       <p:ext uri="{BB962C8B-B14F-4D97-AF65-F5344CB8AC3E}">
-        <p14:creationId xmlns:p14="http://schemas.microsoft.com/office/powerpoint/2010/main" val="2070058163"/>
+        <p14:creationId xmlns:p14="http://schemas.microsoft.com/office/powerpoint/2010/main" val="393946003"/>
       </p:ext>
     </p:extLst>
   </p:cSld>
@@ -9127,7 +9127,7 @@
           <p:cNvPr id="5" name="">
             <a:extLst xmlns:a="http://schemas.openxmlformats.org/drawingml/2006/main">
               <a:ext uri="{FF2B5EF4-FFF2-40B4-BE49-F238E27FC236}">
-                <a16:creationId xmlns:a16="http://schemas.microsoft.com/office/drawing/2014/main" id="{D865A7F8-DA1C-4ECA-B343-E70F6E64D30B}"/>
+                <a16:creationId xmlns:a16="http://schemas.microsoft.com/office/drawing/2014/main" id="{2DDF5918-14E9-4628-8BDC-794485E646F3}"/>
               </a:ext>
             </a:extLst>
           </p:cNvPr>
@@ -9184,7 +9184,7 @@
           <p:cNvPr id="2" name="">
             <a:extLst xmlns:a="http://schemas.openxmlformats.org/drawingml/2006/main">
               <a:ext uri="{FF2B5EF4-FFF2-40B4-BE49-F238E27FC236}">
-                <a16:creationId xmlns:a16="http://schemas.microsoft.com/office/drawing/2014/main" id="{4F2C4634-D054-4AC1-B856-DB03878EF867}"/>
+                <a16:creationId xmlns:a16="http://schemas.microsoft.com/office/drawing/2014/main" id="{1CAE9053-FB2B-4F80-86C2-96973A4E70FC}"/>
               </a:ext>
             </a:extLst>
           </p:cNvPr>
@@ -9664,7 +9664,7 @@
           <p:cNvPr id="4" name="">
             <a:extLst xmlns:a="http://schemas.openxmlformats.org/drawingml/2006/main">
               <a:ext uri="{FF2B5EF4-FFF2-40B4-BE49-F238E27FC236}">
-                <a16:creationId xmlns:a16="http://schemas.microsoft.com/office/drawing/2014/main" id="{F6142B74-02CB-48DA-9EF5-A7CAC4C45261}"/>
+                <a16:creationId xmlns:a16="http://schemas.microsoft.com/office/drawing/2014/main" id="{1D42AB74-E684-45AA-948A-F4F1E03B3FD0}"/>
               </a:ext>
             </a:extLst>
           </p:cNvPr>
@@ -9719,7 +9719,7 @@
     </p:spTree>
     <p:extLst>
       <p:ext uri="{BB962C8B-B14F-4D97-AF65-F5344CB8AC3E}">
-        <p14:creationId xmlns:p14="http://schemas.microsoft.com/office/powerpoint/2010/main" val="1085347879"/>
+        <p14:creationId xmlns:p14="http://schemas.microsoft.com/office/powerpoint/2010/main" val="1239964537"/>
       </p:ext>
     </p:extLst>
   </p:cSld>
@@ -9750,7 +9750,7 @@
           <p:cNvPr id="11" name="">
             <a:extLst xmlns:a="http://schemas.openxmlformats.org/drawingml/2006/main">
               <a:ext uri="{FF2B5EF4-FFF2-40B4-BE49-F238E27FC236}">
-                <a16:creationId xmlns:a16="http://schemas.microsoft.com/office/drawing/2014/main" id="{9066B71C-DAFA-4AF3-9915-6C8A5258A23E}"/>
+                <a16:creationId xmlns:a16="http://schemas.microsoft.com/office/drawing/2014/main" id="{3AE3FD64-C69B-40B8-8CAA-E3FD82322805}"/>
               </a:ext>
             </a:extLst>
           </p:cNvPr>
@@ -9807,7 +9807,7 @@
           <p:cNvPr id="2" name="">
             <a:extLst xmlns:a="http://schemas.openxmlformats.org/drawingml/2006/main">
               <a:ext uri="{FF2B5EF4-FFF2-40B4-BE49-F238E27FC236}">
-                <a16:creationId xmlns:a16="http://schemas.microsoft.com/office/drawing/2014/main" id="{A926949C-B8C0-4F6A-8FCA-D88AEBB9B1CE}"/>
+                <a16:creationId xmlns:a16="http://schemas.microsoft.com/office/drawing/2014/main" id="{924AE3CC-650C-4683-BEEF-3C09AB4F358C}"/>
               </a:ext>
             </a:extLst>
           </p:cNvPr>
@@ -9864,7 +9864,7 @@
           <p:cNvPr id="3" name="">
             <a:extLst xmlns:a="http://schemas.openxmlformats.org/drawingml/2006/main">
               <a:ext uri="{FF2B5EF4-FFF2-40B4-BE49-F238E27FC236}">
-                <a16:creationId xmlns:a16="http://schemas.microsoft.com/office/drawing/2014/main" id="{5BAE30D1-ADF3-4F29-BF0D-3A0718EB9C36}"/>
+                <a16:creationId xmlns:a16="http://schemas.microsoft.com/office/drawing/2014/main" id="{BC85C509-46A0-4935-96D9-8607F75FB7D1}"/>
               </a:ext>
             </a:extLst>
           </p:cNvPr>
@@ -9921,7 +9921,7 @@
           <p:cNvPr id="4" name="">
             <a:extLst xmlns:a="http://schemas.openxmlformats.org/drawingml/2006/main">
               <a:ext uri="{FF2B5EF4-FFF2-40B4-BE49-F238E27FC236}">
-                <a16:creationId xmlns:a16="http://schemas.microsoft.com/office/drawing/2014/main" id="{987C946F-70CA-43C2-90B6-8B9889627D70}"/>
+                <a16:creationId xmlns:a16="http://schemas.microsoft.com/office/drawing/2014/main" id="{71068369-ED80-4689-92BC-A54A37514676}"/>
               </a:ext>
             </a:extLst>
           </p:cNvPr>
@@ -9978,7 +9978,7 @@
           <p:cNvPr id="5" name="">
             <a:extLst xmlns:a="http://schemas.openxmlformats.org/drawingml/2006/main">
               <a:ext uri="{FF2B5EF4-FFF2-40B4-BE49-F238E27FC236}">
-                <a16:creationId xmlns:a16="http://schemas.microsoft.com/office/drawing/2014/main" id="{6F38BA88-09FE-4E9A-B4C2-46FE9CEE6C17}"/>
+                <a16:creationId xmlns:a16="http://schemas.microsoft.com/office/drawing/2014/main" id="{1C36F3B9-881E-4E5C-B936-EC22DF5F8461}"/>
               </a:ext>
             </a:extLst>
           </p:cNvPr>
@@ -10035,7 +10035,7 @@
           <p:cNvPr id="6" name="">
             <a:extLst xmlns:a="http://schemas.openxmlformats.org/drawingml/2006/main">
               <a:ext uri="{FF2B5EF4-FFF2-40B4-BE49-F238E27FC236}">
-                <a16:creationId xmlns:a16="http://schemas.microsoft.com/office/drawing/2014/main" id="{9064E097-FF2B-4158-AD5E-9C16D4C7E361}"/>
+                <a16:creationId xmlns:a16="http://schemas.microsoft.com/office/drawing/2014/main" id="{95361E38-A5CF-4B7E-ADE1-467A28B8F336}"/>
               </a:ext>
             </a:extLst>
           </p:cNvPr>
@@ -10092,7 +10092,7 @@
           <p:cNvPr id="7" name="">
             <a:extLst xmlns:a="http://schemas.openxmlformats.org/drawingml/2006/main">
               <a:ext uri="{FF2B5EF4-FFF2-40B4-BE49-F238E27FC236}">
-                <a16:creationId xmlns:a16="http://schemas.microsoft.com/office/drawing/2014/main" id="{3E82B577-2832-4AEC-B244-FFC25AAB7136}"/>
+                <a16:creationId xmlns:a16="http://schemas.microsoft.com/office/drawing/2014/main" id="{506D6541-E990-45D9-9885-5D5343D4A704}"/>
               </a:ext>
             </a:extLst>
           </p:cNvPr>
@@ -10149,7 +10149,7 @@
           <p:cNvPr id="8" name="">
             <a:extLst xmlns:a="http://schemas.openxmlformats.org/drawingml/2006/main">
               <a:ext uri="{FF2B5EF4-FFF2-40B4-BE49-F238E27FC236}">
-                <a16:creationId xmlns:a16="http://schemas.microsoft.com/office/drawing/2014/main" id="{8355B603-F0DE-49EF-AC8A-5B24E8BD7DAB}"/>
+                <a16:creationId xmlns:a16="http://schemas.microsoft.com/office/drawing/2014/main" id="{EBF28F58-0361-4211-B1C1-D3A5E4071740}"/>
               </a:ext>
             </a:extLst>
           </p:cNvPr>
@@ -10206,7 +10206,7 @@
           <p:cNvPr id="9" name="">
             <a:extLst xmlns:a="http://schemas.openxmlformats.org/drawingml/2006/main">
               <a:ext uri="{FF2B5EF4-FFF2-40B4-BE49-F238E27FC236}">
-                <a16:creationId xmlns:a16="http://schemas.microsoft.com/office/drawing/2014/main" id="{1440E03F-1568-49D3-BB03-B461A220C271}"/>
+                <a16:creationId xmlns:a16="http://schemas.microsoft.com/office/drawing/2014/main" id="{FAE02F52-30B3-40BF-AFB7-45810F5C7DF7}"/>
               </a:ext>
             </a:extLst>
           </p:cNvPr>
@@ -10263,7 +10263,7 @@
           <p:cNvPr id="10" name="">
             <a:extLst xmlns:a="http://schemas.openxmlformats.org/drawingml/2006/main">
               <a:ext uri="{FF2B5EF4-FFF2-40B4-BE49-F238E27FC236}">
-                <a16:creationId xmlns:a16="http://schemas.microsoft.com/office/drawing/2014/main" id="{3E41912E-B937-4CCE-A9EB-1DE18C200B46}"/>
+                <a16:creationId xmlns:a16="http://schemas.microsoft.com/office/drawing/2014/main" id="{65B6788C-835F-4BF6-BCAE-B3C62763097C}"/>
               </a:ext>
             </a:extLst>
           </p:cNvPr>
@@ -10318,7 +10318,7 @@
     </p:spTree>
     <p:extLst>
       <p:ext uri="{BB962C8B-B14F-4D97-AF65-F5344CB8AC3E}">
-        <p14:creationId xmlns:p14="http://schemas.microsoft.com/office/powerpoint/2010/main" val="609703486"/>
+        <p14:creationId xmlns:p14="http://schemas.microsoft.com/office/powerpoint/2010/main" val="597182969"/>
       </p:ext>
     </p:extLst>
   </p:cSld>
@@ -10349,7 +10349,7 @@
           <p:cNvPr id="10" name="">
             <a:extLst xmlns:a="http://schemas.openxmlformats.org/drawingml/2006/main">
               <a:ext uri="{FF2B5EF4-FFF2-40B4-BE49-F238E27FC236}">
-                <a16:creationId xmlns:a16="http://schemas.microsoft.com/office/drawing/2014/main" id="{C76FEB98-30E0-4F2A-A627-1A3EEE80D555}"/>
+                <a16:creationId xmlns:a16="http://schemas.microsoft.com/office/drawing/2014/main" id="{A9ADDC7A-67C2-4DE0-99AC-7FED43C8F23D}"/>
               </a:ext>
             </a:extLst>
           </p:cNvPr>
@@ -10406,7 +10406,7 @@
           <p:cNvPr id="2" name="">
             <a:extLst xmlns:a="http://schemas.openxmlformats.org/drawingml/2006/main">
               <a:ext uri="{FF2B5EF4-FFF2-40B4-BE49-F238E27FC236}">
-                <a16:creationId xmlns:a16="http://schemas.microsoft.com/office/drawing/2014/main" id="{DE752A92-C2D5-4331-A117-D4CC32B92538}"/>
+                <a16:creationId xmlns:a16="http://schemas.microsoft.com/office/drawing/2014/main" id="{AA3B7492-DE65-4C2C-AA0C-8CD3349E9F04}"/>
               </a:ext>
             </a:extLst>
           </p:cNvPr>
@@ -10463,7 +10463,7 @@
           <p:cNvPr id="3" name="">
             <a:extLst xmlns:a="http://schemas.openxmlformats.org/drawingml/2006/main">
               <a:ext uri="{FF2B5EF4-FFF2-40B4-BE49-F238E27FC236}">
-                <a16:creationId xmlns:a16="http://schemas.microsoft.com/office/drawing/2014/main" id="{78AC1ABE-EB20-4089-8812-8BEC65745EFB}"/>
+                <a16:creationId xmlns:a16="http://schemas.microsoft.com/office/drawing/2014/main" id="{16360A26-010E-4A23-B4FF-A5D21C93A65A}"/>
               </a:ext>
             </a:extLst>
           </p:cNvPr>
@@ -10520,7 +10520,7 @@
           <p:cNvPr id="4" name="">
             <a:extLst xmlns:a="http://schemas.openxmlformats.org/drawingml/2006/main">
               <a:ext uri="{FF2B5EF4-FFF2-40B4-BE49-F238E27FC236}">
-                <a16:creationId xmlns:a16="http://schemas.microsoft.com/office/drawing/2014/main" id="{2E5FA1DE-7F25-4404-9CA0-4EFF407624F3}"/>
+                <a16:creationId xmlns:a16="http://schemas.microsoft.com/office/drawing/2014/main" id="{113B4679-4B97-4145-86E8-49E32089683A}"/>
               </a:ext>
             </a:extLst>
           </p:cNvPr>
@@ -10577,7 +10577,7 @@
           <p:cNvPr id="5" name="">
             <a:extLst xmlns:a="http://schemas.openxmlformats.org/drawingml/2006/main">
               <a:ext uri="{FF2B5EF4-FFF2-40B4-BE49-F238E27FC236}">
-                <a16:creationId xmlns:a16="http://schemas.microsoft.com/office/drawing/2014/main" id="{238F5FF6-E316-4A69-ADD1-BBF0E7B79DC8}"/>
+                <a16:creationId xmlns:a16="http://schemas.microsoft.com/office/drawing/2014/main" id="{9BDC3D8B-44B6-4D21-9792-BDF44243F0C2}"/>
               </a:ext>
             </a:extLst>
           </p:cNvPr>
@@ -10634,7 +10634,7 @@
           <p:cNvPr id="6" name="">
             <a:extLst xmlns:a="http://schemas.openxmlformats.org/drawingml/2006/main">
               <a:ext uri="{FF2B5EF4-FFF2-40B4-BE49-F238E27FC236}">
-                <a16:creationId xmlns:a16="http://schemas.microsoft.com/office/drawing/2014/main" id="{F9ABD449-A29B-4B3E-B892-C7391D32312C}"/>
+                <a16:creationId xmlns:a16="http://schemas.microsoft.com/office/drawing/2014/main" id="{89FFF7D4-796E-4428-A637-1D2C123144DA}"/>
               </a:ext>
             </a:extLst>
           </p:cNvPr>
@@ -10691,7 +10691,7 @@
           <p:cNvPr id="7" name="">
             <a:extLst xmlns:a="http://schemas.openxmlformats.org/drawingml/2006/main">
               <a:ext uri="{FF2B5EF4-FFF2-40B4-BE49-F238E27FC236}">
-                <a16:creationId xmlns:a16="http://schemas.microsoft.com/office/drawing/2014/main" id="{8DE7B870-ACDA-40C6-A952-20820B84B35D}"/>
+                <a16:creationId xmlns:a16="http://schemas.microsoft.com/office/drawing/2014/main" id="{5814AC38-8401-4B3E-94EF-53B734D1E50F}"/>
               </a:ext>
             </a:extLst>
           </p:cNvPr>
@@ -10748,7 +10748,7 @@
           <p:cNvPr id="8" name="">
             <a:extLst xmlns:a="http://schemas.openxmlformats.org/drawingml/2006/main">
               <a:ext uri="{FF2B5EF4-FFF2-40B4-BE49-F238E27FC236}">
-                <a16:creationId xmlns:a16="http://schemas.microsoft.com/office/drawing/2014/main" id="{2BE91839-4F94-42BA-B01F-C814A7B1C8A1}"/>
+                <a16:creationId xmlns:a16="http://schemas.microsoft.com/office/drawing/2014/main" id="{E58D55CB-E17A-4C2E-9324-CE4FE2BBA50E}"/>
               </a:ext>
             </a:extLst>
           </p:cNvPr>
@@ -10805,7 +10805,7 @@
           <p:cNvPr id="9" name="">
             <a:extLst xmlns:a="http://schemas.openxmlformats.org/drawingml/2006/main">
               <a:ext uri="{FF2B5EF4-FFF2-40B4-BE49-F238E27FC236}">
-                <a16:creationId xmlns:a16="http://schemas.microsoft.com/office/drawing/2014/main" id="{E27171E8-91EC-4CE4-8800-D0008D93A4AB}"/>
+                <a16:creationId xmlns:a16="http://schemas.microsoft.com/office/drawing/2014/main" id="{3953381C-A31F-43B6-9A28-774305449B02}"/>
               </a:ext>
             </a:extLst>
           </p:cNvPr>
@@ -10860,7 +10860,7 @@
     </p:spTree>
     <p:extLst>
       <p:ext uri="{BB962C8B-B14F-4D97-AF65-F5344CB8AC3E}">
-        <p14:creationId xmlns:p14="http://schemas.microsoft.com/office/powerpoint/2010/main" val="1075855510"/>
+        <p14:creationId xmlns:p14="http://schemas.microsoft.com/office/powerpoint/2010/main" val="648816914"/>
       </p:ext>
     </p:extLst>
   </p:cSld>
@@ -10891,7 +10891,7 @@
           <p:cNvPr id="9" name="">
             <a:extLst xmlns:a="http://schemas.openxmlformats.org/drawingml/2006/main">
               <a:ext uri="{FF2B5EF4-FFF2-40B4-BE49-F238E27FC236}">
-                <a16:creationId xmlns:a16="http://schemas.microsoft.com/office/drawing/2014/main" id="{78E60FF3-C255-4EB1-BAFD-B08DE19FF77F}"/>
+                <a16:creationId xmlns:a16="http://schemas.microsoft.com/office/drawing/2014/main" id="{1D7C682E-DBD3-4C02-A60E-E6F2032568AA}"/>
               </a:ext>
             </a:extLst>
           </p:cNvPr>
@@ -10948,7 +10948,7 @@
           <p:cNvPr id="2" name="">
             <a:extLst xmlns:a="http://schemas.openxmlformats.org/drawingml/2006/main">
               <a:ext uri="{FF2B5EF4-FFF2-40B4-BE49-F238E27FC236}">
-                <a16:creationId xmlns:a16="http://schemas.microsoft.com/office/drawing/2014/main" id="{1C8691B3-D35F-414F-A19B-28E523E39711}"/>
+                <a16:creationId xmlns:a16="http://schemas.microsoft.com/office/drawing/2014/main" id="{89CD4E0D-B9A5-4FB4-9C18-3A0EA9F283D6}"/>
               </a:ext>
             </a:extLst>
           </p:cNvPr>
@@ -11005,7 +11005,7 @@
           <p:cNvPr id="3" name="">
             <a:extLst xmlns:a="http://schemas.openxmlformats.org/drawingml/2006/main">
               <a:ext uri="{FF2B5EF4-FFF2-40B4-BE49-F238E27FC236}">
-                <a16:creationId xmlns:a16="http://schemas.microsoft.com/office/drawing/2014/main" id="{87598497-CA0E-492F-9BB4-B88D1800993A}"/>
+                <a16:creationId xmlns:a16="http://schemas.microsoft.com/office/drawing/2014/main" id="{59C2F57A-6A21-45F6-9F24-DDD92A9B4488}"/>
               </a:ext>
             </a:extLst>
           </p:cNvPr>
@@ -11062,7 +11062,7 @@
           <p:cNvPr id="4" name="">
             <a:extLst xmlns:a="http://schemas.openxmlformats.org/drawingml/2006/main">
               <a:ext uri="{FF2B5EF4-FFF2-40B4-BE49-F238E27FC236}">
-                <a16:creationId xmlns:a16="http://schemas.microsoft.com/office/drawing/2014/main" id="{241F5775-4767-4648-8B55-A82CF23579E4}"/>
+                <a16:creationId xmlns:a16="http://schemas.microsoft.com/office/drawing/2014/main" id="{C4CE89B9-F8DB-4776-A053-8DFBD6E7D20B}"/>
               </a:ext>
             </a:extLst>
           </p:cNvPr>
@@ -11119,7 +11119,7 @@
           <p:cNvPr id="5" name="">
             <a:extLst xmlns:a="http://schemas.openxmlformats.org/drawingml/2006/main">
               <a:ext uri="{FF2B5EF4-FFF2-40B4-BE49-F238E27FC236}">
-                <a16:creationId xmlns:a16="http://schemas.microsoft.com/office/drawing/2014/main" id="{D12AE20D-6644-44E9-BFBB-86322F2E36D4}"/>
+                <a16:creationId xmlns:a16="http://schemas.microsoft.com/office/drawing/2014/main" id="{9CD5AEC8-8F88-44DA-8478-9C7B5D245F8B}"/>
               </a:ext>
             </a:extLst>
           </p:cNvPr>
@@ -11176,7 +11176,7 @@
           <p:cNvPr id="6" name="">
             <a:extLst xmlns:a="http://schemas.openxmlformats.org/drawingml/2006/main">
               <a:ext uri="{FF2B5EF4-FFF2-40B4-BE49-F238E27FC236}">
-                <a16:creationId xmlns:a16="http://schemas.microsoft.com/office/drawing/2014/main" id="{CC42DA7D-4D3C-49EF-86B5-EF77B2E3649A}"/>
+                <a16:creationId xmlns:a16="http://schemas.microsoft.com/office/drawing/2014/main" id="{B4FA46DE-7327-4FD5-907D-BEF73E50C09E}"/>
               </a:ext>
             </a:extLst>
           </p:cNvPr>
@@ -11233,7 +11233,7 @@
           <p:cNvPr id="7" name="">
             <a:extLst xmlns:a="http://schemas.openxmlformats.org/drawingml/2006/main">
               <a:ext uri="{FF2B5EF4-FFF2-40B4-BE49-F238E27FC236}">
-                <a16:creationId xmlns:a16="http://schemas.microsoft.com/office/drawing/2014/main" id="{63B0571B-0B84-4733-BCA7-80ADC0A1DC57}"/>
+                <a16:creationId xmlns:a16="http://schemas.microsoft.com/office/drawing/2014/main" id="{7440651C-602D-4F51-81F1-FE8A0BA4871A}"/>
               </a:ext>
             </a:extLst>
           </p:cNvPr>
@@ -11290,7 +11290,7 @@
           <p:cNvPr id="8" name="">
             <a:extLst xmlns:a="http://schemas.openxmlformats.org/drawingml/2006/main">
               <a:ext uri="{FF2B5EF4-FFF2-40B4-BE49-F238E27FC236}">
-                <a16:creationId xmlns:a16="http://schemas.microsoft.com/office/drawing/2014/main" id="{CC58BCCA-1432-4583-9617-3CB3ACBA33DE}"/>
+                <a16:creationId xmlns:a16="http://schemas.microsoft.com/office/drawing/2014/main" id="{FB722C76-B640-4EDE-B999-9511987C0F27}"/>
               </a:ext>
             </a:extLst>
           </p:cNvPr>
@@ -11345,7 +11345,7 @@
     </p:spTree>
     <p:extLst>
       <p:ext uri="{BB962C8B-B14F-4D97-AF65-F5344CB8AC3E}">
-        <p14:creationId xmlns:p14="http://schemas.microsoft.com/office/powerpoint/2010/main" val="1009817009"/>
+        <p14:creationId xmlns:p14="http://schemas.microsoft.com/office/powerpoint/2010/main" val="688205702"/>
       </p:ext>
     </p:extLst>
   </p:cSld>
@@ -11376,7 +11376,7 @@
           <p:cNvPr id="12" name="">
             <a:extLst xmlns:a="http://schemas.openxmlformats.org/drawingml/2006/main">
               <a:ext uri="{FF2B5EF4-FFF2-40B4-BE49-F238E27FC236}">
-                <a16:creationId xmlns:a16="http://schemas.microsoft.com/office/drawing/2014/main" id="{DA28207E-42DC-4B6E-93B3-485FA7713D21}"/>
+                <a16:creationId xmlns:a16="http://schemas.microsoft.com/office/drawing/2014/main" id="{498B9BD4-84A8-4881-B5B8-E38AAF26FC2B}"/>
               </a:ext>
             </a:extLst>
           </p:cNvPr>
@@ -11433,7 +11433,7 @@
           <p:cNvPr id="2" name="">
             <a:extLst xmlns:a="http://schemas.openxmlformats.org/drawingml/2006/main">
               <a:ext uri="{FF2B5EF4-FFF2-40B4-BE49-F238E27FC236}">
-                <a16:creationId xmlns:a16="http://schemas.microsoft.com/office/drawing/2014/main" id="{21857B85-5FBB-4853-8BA0-1C2AAFA74E62}"/>
+                <a16:creationId xmlns:a16="http://schemas.microsoft.com/office/drawing/2014/main" id="{2600131A-6C02-4CAC-9B07-37054C5D2922}"/>
               </a:ext>
             </a:extLst>
           </p:cNvPr>
@@ -11490,7 +11490,7 @@
           <p:cNvPr id="3" name="">
             <a:extLst xmlns:a="http://schemas.openxmlformats.org/drawingml/2006/main">
               <a:ext uri="{FF2B5EF4-FFF2-40B4-BE49-F238E27FC236}">
-                <a16:creationId xmlns:a16="http://schemas.microsoft.com/office/drawing/2014/main" id="{67BEE84B-02DC-4B56-BF45-36284B5C5085}"/>
+                <a16:creationId xmlns:a16="http://schemas.microsoft.com/office/drawing/2014/main" id="{1F0C1C1B-37E9-413A-93D8-7284A644A6A2}"/>
               </a:ext>
             </a:extLst>
           </p:cNvPr>
@@ -11547,7 +11547,7 @@
           <p:cNvPr id="4" name="">
             <a:extLst xmlns:a="http://schemas.openxmlformats.org/drawingml/2006/main">
               <a:ext uri="{FF2B5EF4-FFF2-40B4-BE49-F238E27FC236}">
-                <a16:creationId xmlns:a16="http://schemas.microsoft.com/office/drawing/2014/main" id="{003E86F9-A20C-42C6-BF41-18EBB755FF05}"/>
+                <a16:creationId xmlns:a16="http://schemas.microsoft.com/office/drawing/2014/main" id="{1E59B898-6506-491D-A529-71E4CDDDE850}"/>
               </a:ext>
             </a:extLst>
           </p:cNvPr>
@@ -11604,7 +11604,7 @@
           <p:cNvPr id="5" name="">
             <a:extLst xmlns:a="http://schemas.openxmlformats.org/drawingml/2006/main">
               <a:ext uri="{FF2B5EF4-FFF2-40B4-BE49-F238E27FC236}">
-                <a16:creationId xmlns:a16="http://schemas.microsoft.com/office/drawing/2014/main" id="{70E55661-8941-45A0-BE55-BDC7E47F0000}"/>
+                <a16:creationId xmlns:a16="http://schemas.microsoft.com/office/drawing/2014/main" id="{BAC201FD-0383-4489-B280-F6AA8F993C5D}"/>
               </a:ext>
             </a:extLst>
           </p:cNvPr>
@@ -11661,7 +11661,7 @@
           <p:cNvPr id="6" name="">
             <a:extLst xmlns:a="http://schemas.openxmlformats.org/drawingml/2006/main">
               <a:ext uri="{FF2B5EF4-FFF2-40B4-BE49-F238E27FC236}">
-                <a16:creationId xmlns:a16="http://schemas.microsoft.com/office/drawing/2014/main" id="{ABC7052A-A048-4FFB-AE0B-36356B3543B1}"/>
+                <a16:creationId xmlns:a16="http://schemas.microsoft.com/office/drawing/2014/main" id="{015EAC2B-5D86-4DE5-9EFF-E293B5EA4923}"/>
               </a:ext>
             </a:extLst>
           </p:cNvPr>
@@ -11718,7 +11718,7 @@
           <p:cNvPr id="7" name="">
             <a:extLst xmlns:a="http://schemas.openxmlformats.org/drawingml/2006/main">
               <a:ext uri="{FF2B5EF4-FFF2-40B4-BE49-F238E27FC236}">
-                <a16:creationId xmlns:a16="http://schemas.microsoft.com/office/drawing/2014/main" id="{CF632093-C4EB-40A0-A96B-D35E49FFA3BF}"/>
+                <a16:creationId xmlns:a16="http://schemas.microsoft.com/office/drawing/2014/main" id="{6F5434F7-4249-4979-A658-50C934D8D1B5}"/>
               </a:ext>
             </a:extLst>
           </p:cNvPr>
@@ -11775,7 +11775,7 @@
           <p:cNvPr id="8" name="">
             <a:extLst xmlns:a="http://schemas.openxmlformats.org/drawingml/2006/main">
               <a:ext uri="{FF2B5EF4-FFF2-40B4-BE49-F238E27FC236}">
-                <a16:creationId xmlns:a16="http://schemas.microsoft.com/office/drawing/2014/main" id="{583F6DAF-AE14-480F-84AF-79677239AE16}"/>
+                <a16:creationId xmlns:a16="http://schemas.microsoft.com/office/drawing/2014/main" id="{0EBF68DF-3FCD-4052-9BC1-3B8B76E72A0B}"/>
               </a:ext>
             </a:extLst>
           </p:cNvPr>
@@ -11832,7 +11832,7 @@
           <p:cNvPr id="9" name="">
             <a:extLst xmlns:a="http://schemas.openxmlformats.org/drawingml/2006/main">
               <a:ext uri="{FF2B5EF4-FFF2-40B4-BE49-F238E27FC236}">
-                <a16:creationId xmlns:a16="http://schemas.microsoft.com/office/drawing/2014/main" id="{54D287C6-9FD0-42B0-856A-FF39B4F578FF}"/>
+                <a16:creationId xmlns:a16="http://schemas.microsoft.com/office/drawing/2014/main" id="{C7800FB5-330B-45F7-9004-48CDDE5FDB85}"/>
               </a:ext>
             </a:extLst>
           </p:cNvPr>
@@ -11889,7 +11889,7 @@
           <p:cNvPr id="10" name="">
             <a:extLst xmlns:a="http://schemas.openxmlformats.org/drawingml/2006/main">
               <a:ext uri="{FF2B5EF4-FFF2-40B4-BE49-F238E27FC236}">
-                <a16:creationId xmlns:a16="http://schemas.microsoft.com/office/drawing/2014/main" id="{091FF1F6-249D-4DE4-926B-78F3AB7BFF84}"/>
+                <a16:creationId xmlns:a16="http://schemas.microsoft.com/office/drawing/2014/main" id="{1042E2BE-6887-4D01-99BF-4390D9B10E79}"/>
               </a:ext>
             </a:extLst>
           </p:cNvPr>
@@ -11946,7 +11946,7 @@
           <p:cNvPr id="11" name="">
             <a:extLst xmlns:a="http://schemas.openxmlformats.org/drawingml/2006/main">
               <a:ext uri="{FF2B5EF4-FFF2-40B4-BE49-F238E27FC236}">
-                <a16:creationId xmlns:a16="http://schemas.microsoft.com/office/drawing/2014/main" id="{CF7E5CE1-6816-41AD-AA87-47E181CFF97C}"/>
+                <a16:creationId xmlns:a16="http://schemas.microsoft.com/office/drawing/2014/main" id="{BC941243-F050-4951-B93A-ED9E79673C90}"/>
               </a:ext>
             </a:extLst>
           </p:cNvPr>
@@ -12001,7 +12001,7 @@
     </p:spTree>
     <p:extLst>
       <p:ext uri="{BB962C8B-B14F-4D97-AF65-F5344CB8AC3E}">
-        <p14:creationId xmlns:p14="http://schemas.microsoft.com/office/powerpoint/2010/main" val="277995281"/>
+        <p14:creationId xmlns:p14="http://schemas.microsoft.com/office/powerpoint/2010/main" val="1401585329"/>
       </p:ext>
     </p:extLst>
   </p:cSld>
@@ -12032,7 +12032,7 @@
           <p:cNvPr id="13" name="">
             <a:extLst xmlns:a="http://schemas.openxmlformats.org/drawingml/2006/main">
               <a:ext uri="{FF2B5EF4-FFF2-40B4-BE49-F238E27FC236}">
-                <a16:creationId xmlns:a16="http://schemas.microsoft.com/office/drawing/2014/main" id="{313F78E2-8E79-4598-8E77-1834CF8A691F}"/>
+                <a16:creationId xmlns:a16="http://schemas.microsoft.com/office/drawing/2014/main" id="{32A11F37-9DD5-4F0A-AB9E-529CDB8855E6}"/>
               </a:ext>
             </a:extLst>
           </p:cNvPr>
@@ -12089,7 +12089,7 @@
           <p:cNvPr id="2" name="">
             <a:extLst xmlns:a="http://schemas.openxmlformats.org/drawingml/2006/main">
               <a:ext uri="{FF2B5EF4-FFF2-40B4-BE49-F238E27FC236}">
-                <a16:creationId xmlns:a16="http://schemas.microsoft.com/office/drawing/2014/main" id="{BDBDCBA7-15FB-46E7-B406-AB1430F322DE}"/>
+                <a16:creationId xmlns:a16="http://schemas.microsoft.com/office/drawing/2014/main" id="{73655EA4-DD8F-44AC-9F37-944A0E94B307}"/>
               </a:ext>
             </a:extLst>
           </p:cNvPr>
@@ -12146,7 +12146,7 @@
           <p:cNvPr id="3" name="">
             <a:extLst xmlns:a="http://schemas.openxmlformats.org/drawingml/2006/main">
               <a:ext uri="{FF2B5EF4-FFF2-40B4-BE49-F238E27FC236}">
-                <a16:creationId xmlns:a16="http://schemas.microsoft.com/office/drawing/2014/main" id="{13DA98CD-601F-44C0-85CF-33682CA07002}"/>
+                <a16:creationId xmlns:a16="http://schemas.microsoft.com/office/drawing/2014/main" id="{71C5346A-EFEB-4E58-A920-9B2A8A992E31}"/>
               </a:ext>
             </a:extLst>
           </p:cNvPr>
@@ -12230,7 +12230,7 @@
           <p:cNvPr id="4" name="">
             <a:extLst xmlns:a="http://schemas.openxmlformats.org/drawingml/2006/main">
               <a:ext uri="{FF2B5EF4-FFF2-40B4-BE49-F238E27FC236}">
-                <a16:creationId xmlns:a16="http://schemas.microsoft.com/office/drawing/2014/main" id="{28BA942F-349C-4BB2-B553-900328F60853}"/>
+                <a16:creationId xmlns:a16="http://schemas.microsoft.com/office/drawing/2014/main" id="{39113657-68BD-43C4-A5FD-C5C8919BD09C}"/>
               </a:ext>
             </a:extLst>
           </p:cNvPr>
@@ -12314,7 +12314,7 @@
           <p:cNvPr id="5" name="">
             <a:extLst xmlns:a="http://schemas.openxmlformats.org/drawingml/2006/main">
               <a:ext uri="{FF2B5EF4-FFF2-40B4-BE49-F238E27FC236}">
-                <a16:creationId xmlns:a16="http://schemas.microsoft.com/office/drawing/2014/main" id="{7BC0E091-E80F-46E7-8513-7FF953B5E534}"/>
+                <a16:creationId xmlns:a16="http://schemas.microsoft.com/office/drawing/2014/main" id="{6ACCB55C-135B-47DB-9DAB-A8CE15D17DFE}"/>
               </a:ext>
             </a:extLst>
           </p:cNvPr>
@@ -12448,7 +12448,7 @@
           <p:cNvPr id="8" name="">
             <a:extLst xmlns:a="http://schemas.openxmlformats.org/drawingml/2006/main">
               <a:ext uri="{FF2B5EF4-FFF2-40B4-BE49-F238E27FC236}">
-                <a16:creationId xmlns:a16="http://schemas.microsoft.com/office/drawing/2014/main" id="{A33987B0-82BE-4158-BB20-6F52D2A31756}"/>
+                <a16:creationId xmlns:a16="http://schemas.microsoft.com/office/drawing/2014/main" id="{63EA1F6D-02DD-45AE-B91A-37B7C58C9CE1}"/>
               </a:ext>
             </a:extLst>
           </p:cNvPr>
@@ -12505,7 +12505,7 @@
           <p:cNvPr id="9" name="">
             <a:extLst xmlns:a="http://schemas.openxmlformats.org/drawingml/2006/main">
               <a:ext uri="{FF2B5EF4-FFF2-40B4-BE49-F238E27FC236}">
-                <a16:creationId xmlns:a16="http://schemas.microsoft.com/office/drawing/2014/main" id="{B5AB3C06-9E8B-413C-97FC-588B614F1064}"/>
+                <a16:creationId xmlns:a16="http://schemas.microsoft.com/office/drawing/2014/main" id="{5830B2A1-4B58-4204-BCEF-A0DFEC2874AE}"/>
               </a:ext>
             </a:extLst>
           </p:cNvPr>
@@ -12562,7 +12562,7 @@
           <p:cNvPr id="10" name="">
             <a:extLst xmlns:a="http://schemas.openxmlformats.org/drawingml/2006/main">
               <a:ext uri="{FF2B5EF4-FFF2-40B4-BE49-F238E27FC236}">
-                <a16:creationId xmlns:a16="http://schemas.microsoft.com/office/drawing/2014/main" id="{6AC02642-CB79-4BEB-A9EC-674B5D7266FC}"/>
+                <a16:creationId xmlns:a16="http://schemas.microsoft.com/office/drawing/2014/main" id="{773E03F8-1AF4-4227-B6D8-140607A83B0B}"/>
               </a:ext>
             </a:extLst>
           </p:cNvPr>
@@ -12619,7 +12619,7 @@
           <p:cNvPr id="11" name="">
             <a:extLst xmlns:a="http://schemas.openxmlformats.org/drawingml/2006/main">
               <a:ext uri="{FF2B5EF4-FFF2-40B4-BE49-F238E27FC236}">
-                <a16:creationId xmlns:a16="http://schemas.microsoft.com/office/drawing/2014/main" id="{04714549-9361-4C3C-A95C-5EB532441B34}"/>
+                <a16:creationId xmlns:a16="http://schemas.microsoft.com/office/drawing/2014/main" id="{2999D157-120B-4226-984E-8F7604855F13}"/>
               </a:ext>
             </a:extLst>
           </p:cNvPr>
@@ -12676,7 +12676,7 @@
           <p:cNvPr id="12" name="">
             <a:extLst xmlns:a="http://schemas.openxmlformats.org/drawingml/2006/main">
               <a:ext uri="{FF2B5EF4-FFF2-40B4-BE49-F238E27FC236}">
-                <a16:creationId xmlns:a16="http://schemas.microsoft.com/office/drawing/2014/main" id="{3E1644A6-537B-404C-BBD5-D83302611930}"/>
+                <a16:creationId xmlns:a16="http://schemas.microsoft.com/office/drawing/2014/main" id="{53361239-1369-4CD5-894E-B9DBAB51805F}"/>
               </a:ext>
             </a:extLst>
           </p:cNvPr>
@@ -12731,7 +12731,7 @@
     </p:spTree>
     <p:extLst>
       <p:ext uri="{BB962C8B-B14F-4D97-AF65-F5344CB8AC3E}">
-        <p14:creationId xmlns:p14="http://schemas.microsoft.com/office/powerpoint/2010/main" val="115802964"/>
+        <p14:creationId xmlns:p14="http://schemas.microsoft.com/office/powerpoint/2010/main" val="239742953"/>
       </p:ext>
     </p:extLst>
   </p:cSld>
@@ -12762,7 +12762,7 @@
           <p:cNvPr id="12" name="">
             <a:extLst xmlns:a="http://schemas.openxmlformats.org/drawingml/2006/main">
               <a:ext uri="{FF2B5EF4-FFF2-40B4-BE49-F238E27FC236}">
-                <a16:creationId xmlns:a16="http://schemas.microsoft.com/office/drawing/2014/main" id="{BA9CDCC7-052F-403A-B61A-CA0702D42585}"/>
+                <a16:creationId xmlns:a16="http://schemas.microsoft.com/office/drawing/2014/main" id="{4F6E19B7-9592-4F33-9C60-9D2D70884AC5}"/>
               </a:ext>
             </a:extLst>
           </p:cNvPr>
@@ -12819,7 +12819,7 @@
           <p:cNvPr id="2" name="">
             <a:extLst xmlns:a="http://schemas.openxmlformats.org/drawingml/2006/main">
               <a:ext uri="{FF2B5EF4-FFF2-40B4-BE49-F238E27FC236}">
-                <a16:creationId xmlns:a16="http://schemas.microsoft.com/office/drawing/2014/main" id="{999F26E6-39F4-4FE5-9352-287D2D61165D}"/>
+                <a16:creationId xmlns:a16="http://schemas.microsoft.com/office/drawing/2014/main" id="{621E84CE-A21A-455F-BD32-39C116CFDC25}"/>
               </a:ext>
             </a:extLst>
           </p:cNvPr>
@@ -12876,7 +12876,7 @@
           <p:cNvPr id="3" name="">
             <a:extLst xmlns:a="http://schemas.openxmlformats.org/drawingml/2006/main">
               <a:ext uri="{FF2B5EF4-FFF2-40B4-BE49-F238E27FC236}">
-                <a16:creationId xmlns:a16="http://schemas.microsoft.com/office/drawing/2014/main" id="{3AF57612-5C57-43B8-86C0-98241D7A9C11}"/>
+                <a16:creationId xmlns:a16="http://schemas.microsoft.com/office/drawing/2014/main" id="{9575DDBD-02A9-4D78-A69D-40390834B575}"/>
               </a:ext>
             </a:extLst>
           </p:cNvPr>
@@ -12933,7 +12933,7 @@
           <p:cNvPr id="4" name="">
             <a:extLst xmlns:a="http://schemas.openxmlformats.org/drawingml/2006/main">
               <a:ext uri="{FF2B5EF4-FFF2-40B4-BE49-F238E27FC236}">
-                <a16:creationId xmlns:a16="http://schemas.microsoft.com/office/drawing/2014/main" id="{C9E099E8-E8A3-4B2F-87E3-2CAEBFE6AF42}"/>
+                <a16:creationId xmlns:a16="http://schemas.microsoft.com/office/drawing/2014/main" id="{34206FFE-8641-4501-B1C9-089EAD31E62B}"/>
               </a:ext>
             </a:extLst>
           </p:cNvPr>
@@ -12990,7 +12990,7 @@
           <p:cNvPr id="5" name="">
             <a:extLst xmlns:a="http://schemas.openxmlformats.org/drawingml/2006/main">
               <a:ext uri="{FF2B5EF4-FFF2-40B4-BE49-F238E27FC236}">
-                <a16:creationId xmlns:a16="http://schemas.microsoft.com/office/drawing/2014/main" id="{4A098857-F144-4329-ABC6-D7FE8944883B}"/>
+                <a16:creationId xmlns:a16="http://schemas.microsoft.com/office/drawing/2014/main" id="{3BBDB506-62B6-4492-B15F-2017F87F6288}"/>
               </a:ext>
             </a:extLst>
           </p:cNvPr>
@@ -13047,7 +13047,7 @@
           <p:cNvPr id="6" name="">
             <a:extLst xmlns:a="http://schemas.openxmlformats.org/drawingml/2006/main">
               <a:ext uri="{FF2B5EF4-FFF2-40B4-BE49-F238E27FC236}">
-                <a16:creationId xmlns:a16="http://schemas.microsoft.com/office/drawing/2014/main" id="{D9608042-52E1-4D82-A790-985F78E219D2}"/>
+                <a16:creationId xmlns:a16="http://schemas.microsoft.com/office/drawing/2014/main" id="{DBC617BE-5F1D-4488-AB6E-292DD875BCD3}"/>
               </a:ext>
             </a:extLst>
           </p:cNvPr>
@@ -13104,7 +13104,7 @@
           <p:cNvPr id="7" name="">
             <a:extLst xmlns:a="http://schemas.openxmlformats.org/drawingml/2006/main">
               <a:ext uri="{FF2B5EF4-FFF2-40B4-BE49-F238E27FC236}">
-                <a16:creationId xmlns:a16="http://schemas.microsoft.com/office/drawing/2014/main" id="{0A887DFF-8A75-4499-AD2F-5BFAA3BA9A70}"/>
+                <a16:creationId xmlns:a16="http://schemas.microsoft.com/office/drawing/2014/main" id="{D070E648-FB5A-4413-8477-ECD2DD4D3CA4}"/>
               </a:ext>
             </a:extLst>
           </p:cNvPr>
@@ -13161,7 +13161,7 @@
           <p:cNvPr id="8" name="">
             <a:extLst xmlns:a="http://schemas.openxmlformats.org/drawingml/2006/main">
               <a:ext uri="{FF2B5EF4-FFF2-40B4-BE49-F238E27FC236}">
-                <a16:creationId xmlns:a16="http://schemas.microsoft.com/office/drawing/2014/main" id="{AB091D03-5C1F-44C1-B3CE-7CC8CE055BBA}"/>
+                <a16:creationId xmlns:a16="http://schemas.microsoft.com/office/drawing/2014/main" id="{B8D4FE61-426A-4334-80C9-899AC7902CC1}"/>
               </a:ext>
             </a:extLst>
           </p:cNvPr>
@@ -13218,7 +13218,7 @@
           <p:cNvPr id="9" name="">
             <a:extLst xmlns:a="http://schemas.openxmlformats.org/drawingml/2006/main">
               <a:ext uri="{FF2B5EF4-FFF2-40B4-BE49-F238E27FC236}">
-                <a16:creationId xmlns:a16="http://schemas.microsoft.com/office/drawing/2014/main" id="{270D6887-2440-4F92-BBCA-ED923D9F89E4}"/>
+                <a16:creationId xmlns:a16="http://schemas.microsoft.com/office/drawing/2014/main" id="{FC1B139F-DD23-4046-B760-93E9807D5A42}"/>
               </a:ext>
             </a:extLst>
           </p:cNvPr>
@@ -13275,7 +13275,7 @@
           <p:cNvPr id="10" name="">
             <a:extLst xmlns:a="http://schemas.openxmlformats.org/drawingml/2006/main">
               <a:ext uri="{FF2B5EF4-FFF2-40B4-BE49-F238E27FC236}">
-                <a16:creationId xmlns:a16="http://schemas.microsoft.com/office/drawing/2014/main" id="{454A4085-E3A0-4EC1-BC5D-955FA41AFB2F}"/>
+                <a16:creationId xmlns:a16="http://schemas.microsoft.com/office/drawing/2014/main" id="{865D8B88-A6D1-4575-B67F-54ADF600DD63}"/>
               </a:ext>
             </a:extLst>
           </p:cNvPr>
@@ -13332,7 +13332,7 @@
           <p:cNvPr id="11" name="">
             <a:extLst xmlns:a="http://schemas.openxmlformats.org/drawingml/2006/main">
               <a:ext uri="{FF2B5EF4-FFF2-40B4-BE49-F238E27FC236}">
-                <a16:creationId xmlns:a16="http://schemas.microsoft.com/office/drawing/2014/main" id="{35556428-1618-4FE7-BA88-661450524868}"/>
+                <a16:creationId xmlns:a16="http://schemas.microsoft.com/office/drawing/2014/main" id="{6CD46320-AD74-4DEF-912A-AB601A59A3FE}"/>
               </a:ext>
             </a:extLst>
           </p:cNvPr>
@@ -13387,7 +13387,7 @@
     </p:spTree>
     <p:extLst>
       <p:ext uri="{BB962C8B-B14F-4D97-AF65-F5344CB8AC3E}">
-        <p14:creationId xmlns:p14="http://schemas.microsoft.com/office/powerpoint/2010/main" val="1799956473"/>
+        <p14:creationId xmlns:p14="http://schemas.microsoft.com/office/powerpoint/2010/main" val="2088577602"/>
       </p:ext>
     </p:extLst>
   </p:cSld>
@@ -13418,7 +13418,7 @@
           <p:cNvPr id="9" name="">
             <a:extLst xmlns:a="http://schemas.openxmlformats.org/drawingml/2006/main">
               <a:ext uri="{FF2B5EF4-FFF2-40B4-BE49-F238E27FC236}">
-                <a16:creationId xmlns:a16="http://schemas.microsoft.com/office/drawing/2014/main" id="{C2C602DF-884A-4EA1-A694-D50B79B60A84}"/>
+                <a16:creationId xmlns:a16="http://schemas.microsoft.com/office/drawing/2014/main" id="{FA3417D0-C3B9-4A80-BBB1-FF4AAB2EE04F}"/>
               </a:ext>
             </a:extLst>
           </p:cNvPr>
@@ -13475,7 +13475,7 @@
           <p:cNvPr id="2" name="">
             <a:extLst xmlns:a="http://schemas.openxmlformats.org/drawingml/2006/main">
               <a:ext uri="{FF2B5EF4-FFF2-40B4-BE49-F238E27FC236}">
-                <a16:creationId xmlns:a16="http://schemas.microsoft.com/office/drawing/2014/main" id="{6DD30F3C-34F7-4967-B801-00BE2A54167A}"/>
+                <a16:creationId xmlns:a16="http://schemas.microsoft.com/office/drawing/2014/main" id="{C74E7BA7-BA9F-4B2D-BF72-5FCA4556CF30}"/>
               </a:ext>
             </a:extLst>
           </p:cNvPr>
@@ -13532,7 +13532,7 @@
           <p:cNvPr id="3" name="">
             <a:extLst xmlns:a="http://schemas.openxmlformats.org/drawingml/2006/main">
               <a:ext uri="{FF2B5EF4-FFF2-40B4-BE49-F238E27FC236}">
-                <a16:creationId xmlns:a16="http://schemas.microsoft.com/office/drawing/2014/main" id="{3A18E9AE-43F5-41DE-B016-0604FE97D457}"/>
+                <a16:creationId xmlns:a16="http://schemas.microsoft.com/office/drawing/2014/main" id="{D0D0597F-0DE5-4A96-9B90-6252135E2FC3}"/>
               </a:ext>
             </a:extLst>
           </p:cNvPr>
@@ -13589,7 +13589,7 @@
           <p:cNvPr id="4" name="">
             <a:extLst xmlns:a="http://schemas.openxmlformats.org/drawingml/2006/main">
               <a:ext uri="{FF2B5EF4-FFF2-40B4-BE49-F238E27FC236}">
-                <a16:creationId xmlns:a16="http://schemas.microsoft.com/office/drawing/2014/main" id="{E62E640D-FF7D-4A6D-846B-45BCFC850859}"/>
+                <a16:creationId xmlns:a16="http://schemas.microsoft.com/office/drawing/2014/main" id="{3A12C686-CF73-4BA1-AF1F-457FD6832B4B}"/>
               </a:ext>
             </a:extLst>
           </p:cNvPr>
@@ -13646,7 +13646,7 @@
           <p:cNvPr id="5" name="">
             <a:extLst xmlns:a="http://schemas.openxmlformats.org/drawingml/2006/main">
               <a:ext uri="{FF2B5EF4-FFF2-40B4-BE49-F238E27FC236}">
-                <a16:creationId xmlns:a16="http://schemas.microsoft.com/office/drawing/2014/main" id="{62EAB3C7-1DD7-4C75-A173-0368925578AC}"/>
+                <a16:creationId xmlns:a16="http://schemas.microsoft.com/office/drawing/2014/main" id="{09A3DE33-E142-49A3-8AAB-D256CE31ECC2}"/>
               </a:ext>
             </a:extLst>
           </p:cNvPr>
@@ -13703,7 +13703,7 @@
           <p:cNvPr id="6" name="">
             <a:extLst xmlns:a="http://schemas.openxmlformats.org/drawingml/2006/main">
               <a:ext uri="{FF2B5EF4-FFF2-40B4-BE49-F238E27FC236}">
-                <a16:creationId xmlns:a16="http://schemas.microsoft.com/office/drawing/2014/main" id="{A70125DE-9AF0-430F-8853-81B8587DE842}"/>
+                <a16:creationId xmlns:a16="http://schemas.microsoft.com/office/drawing/2014/main" id="{94931672-D587-4701-B6C3-8EC06A91152C}"/>
               </a:ext>
             </a:extLst>
           </p:cNvPr>
@@ -13760,7 +13760,7 @@
           <p:cNvPr id="7" name="">
             <a:extLst xmlns:a="http://schemas.openxmlformats.org/drawingml/2006/main">
               <a:ext uri="{FF2B5EF4-FFF2-40B4-BE49-F238E27FC236}">
-                <a16:creationId xmlns:a16="http://schemas.microsoft.com/office/drawing/2014/main" id="{82FAD87D-5127-408D-9734-1FA8B0F62C2F}"/>
+                <a16:creationId xmlns:a16="http://schemas.microsoft.com/office/drawing/2014/main" id="{496A4B2D-1BB6-48E2-B43B-C87F0C9E6B28}"/>
               </a:ext>
             </a:extLst>
           </p:cNvPr>
@@ -13817,7 +13817,7 @@
           <p:cNvPr id="8" name="">
             <a:extLst xmlns:a="http://schemas.openxmlformats.org/drawingml/2006/main">
               <a:ext uri="{FF2B5EF4-FFF2-40B4-BE49-F238E27FC236}">
-                <a16:creationId xmlns:a16="http://schemas.microsoft.com/office/drawing/2014/main" id="{DFCE693C-4124-4A5E-8C52-A0C575C46E2F}"/>
+                <a16:creationId xmlns:a16="http://schemas.microsoft.com/office/drawing/2014/main" id="{396AB70C-C868-424F-BF84-AC97D6E7EAE4}"/>
               </a:ext>
             </a:extLst>
           </p:cNvPr>
@@ -13872,7 +13872,7 @@
     </p:spTree>
     <p:extLst>
       <p:ext uri="{BB962C8B-B14F-4D97-AF65-F5344CB8AC3E}">
-        <p14:creationId xmlns:p14="http://schemas.microsoft.com/office/powerpoint/2010/main" val="1415315827"/>
+        <p14:creationId xmlns:p14="http://schemas.microsoft.com/office/powerpoint/2010/main" val="1974109198"/>
       </p:ext>
     </p:extLst>
   </p:cSld>
@@ -13903,7 +13903,7 @@
           <p:cNvPr id="15" name="">
             <a:extLst xmlns:a="http://schemas.openxmlformats.org/drawingml/2006/main">
               <a:ext uri="{FF2B5EF4-FFF2-40B4-BE49-F238E27FC236}">
-                <a16:creationId xmlns:a16="http://schemas.microsoft.com/office/drawing/2014/main" id="{6254B6C7-1EE9-4592-B75A-5509503115C2}"/>
+                <a16:creationId xmlns:a16="http://schemas.microsoft.com/office/drawing/2014/main" id="{49BAAB83-14B4-45CD-9CED-4A2994A554B0}"/>
               </a:ext>
             </a:extLst>
           </p:cNvPr>
@@ -13960,7 +13960,7 @@
           <p:cNvPr id="2" name="">
             <a:extLst xmlns:a="http://schemas.openxmlformats.org/drawingml/2006/main">
               <a:ext uri="{FF2B5EF4-FFF2-40B4-BE49-F238E27FC236}">
-                <a16:creationId xmlns:a16="http://schemas.microsoft.com/office/drawing/2014/main" id="{7C30F7EE-0D1C-422C-9638-CAE05021DB2A}"/>
+                <a16:creationId xmlns:a16="http://schemas.microsoft.com/office/drawing/2014/main" id="{02F7BC0C-8451-41A1-A86C-23D61B9363A4}"/>
               </a:ext>
             </a:extLst>
           </p:cNvPr>
@@ -14017,7 +14017,7 @@
           <p:cNvPr id="3" name="">
             <a:extLst xmlns:a="http://schemas.openxmlformats.org/drawingml/2006/main">
               <a:ext uri="{FF2B5EF4-FFF2-40B4-BE49-F238E27FC236}">
-                <a16:creationId xmlns:a16="http://schemas.microsoft.com/office/drawing/2014/main" id="{1FDBA8DF-3C59-483B-9DEF-2BF62022755B}"/>
+                <a16:creationId xmlns:a16="http://schemas.microsoft.com/office/drawing/2014/main" id="{C02D51DF-417A-4359-B213-A57538F7E2B3}"/>
               </a:ext>
             </a:extLst>
           </p:cNvPr>
@@ -14078,7 +14078,7 @@
           <p:cNvPr id="4" name="">
             <a:extLst xmlns:a="http://schemas.openxmlformats.org/drawingml/2006/main">
               <a:ext uri="{FF2B5EF4-FFF2-40B4-BE49-F238E27FC236}">
-                <a16:creationId xmlns:a16="http://schemas.microsoft.com/office/drawing/2014/main" id="{0A404D08-413A-44BD-8780-C8BEA5F75B8E}"/>
+                <a16:creationId xmlns:a16="http://schemas.microsoft.com/office/drawing/2014/main" id="{4FD38EE6-37E9-44E0-AC11-994F7F427D1A}"/>
               </a:ext>
             </a:extLst>
           </p:cNvPr>
@@ -14139,7 +14139,7 @@
           <p:cNvPr id="5" name="">
             <a:extLst xmlns:a="http://schemas.openxmlformats.org/drawingml/2006/main">
               <a:ext uri="{FF2B5EF4-FFF2-40B4-BE49-F238E27FC236}">
-                <a16:creationId xmlns:a16="http://schemas.microsoft.com/office/drawing/2014/main" id="{9E4B80D9-8172-494B-B341-503C411296A8}"/>
+                <a16:creationId xmlns:a16="http://schemas.microsoft.com/office/drawing/2014/main" id="{158170BF-72E4-4CB8-A063-E8FB8FE3B660}"/>
               </a:ext>
             </a:extLst>
           </p:cNvPr>
@@ -14200,7 +14200,7 @@
           <p:cNvPr id="6" name="">
             <a:extLst xmlns:a="http://schemas.openxmlformats.org/drawingml/2006/main">
               <a:ext uri="{FF2B5EF4-FFF2-40B4-BE49-F238E27FC236}">
-                <a16:creationId xmlns:a16="http://schemas.microsoft.com/office/drawing/2014/main" id="{D3E9F556-EBA7-41B5-B472-9E4808C7DCAA}"/>
+                <a16:creationId xmlns:a16="http://schemas.microsoft.com/office/drawing/2014/main" id="{A77C227E-ACB9-4FD4-878C-D469F18E5CC5}"/>
               </a:ext>
             </a:extLst>
           </p:cNvPr>
@@ -14261,7 +14261,7 @@
           <p:cNvPr id="7" name="">
             <a:extLst xmlns:a="http://schemas.openxmlformats.org/drawingml/2006/main">
               <a:ext uri="{FF2B5EF4-FFF2-40B4-BE49-F238E27FC236}">
-                <a16:creationId xmlns:a16="http://schemas.microsoft.com/office/drawing/2014/main" id="{25069AE5-F69F-46CF-B951-E1AE4699006D}"/>
+                <a16:creationId xmlns:a16="http://schemas.microsoft.com/office/drawing/2014/main" id="{50A7618E-B3AF-45B4-AA42-4018020C881E}"/>
               </a:ext>
             </a:extLst>
           </p:cNvPr>
@@ -14322,7 +14322,7 @@
           <p:cNvPr id="8" name="">
             <a:extLst xmlns:a="http://schemas.openxmlformats.org/drawingml/2006/main">
               <a:ext uri="{FF2B5EF4-FFF2-40B4-BE49-F238E27FC236}">
-                <a16:creationId xmlns:a16="http://schemas.microsoft.com/office/drawing/2014/main" id="{5FF9DB41-0083-4AF9-842F-63B9BEB79D6B}"/>
+                <a16:creationId xmlns:a16="http://schemas.microsoft.com/office/drawing/2014/main" id="{9EE9C374-D55D-47C5-BF98-8A32120BC8C0}"/>
               </a:ext>
             </a:extLst>
           </p:cNvPr>
@@ -14508,7 +14508,7 @@
           <p:cNvPr id="14" name="">
             <a:extLst xmlns:a="http://schemas.openxmlformats.org/drawingml/2006/main">
               <a:ext uri="{FF2B5EF4-FFF2-40B4-BE49-F238E27FC236}">
-                <a16:creationId xmlns:a16="http://schemas.microsoft.com/office/drawing/2014/main" id="{E54AF0F9-E209-46D0-AEF8-11C4BE557453}"/>
+                <a16:creationId xmlns:a16="http://schemas.microsoft.com/office/drawing/2014/main" id="{28795569-1C73-45C8-873A-F7178BEF7BBA}"/>
               </a:ext>
             </a:extLst>
           </p:cNvPr>
@@ -14563,7 +14563,7 @@
     </p:spTree>
     <p:extLst>
       <p:ext uri="{BB962C8B-B14F-4D97-AF65-F5344CB8AC3E}">
-        <p14:creationId xmlns:p14="http://schemas.microsoft.com/office/powerpoint/2010/main" val="732585769"/>
+        <p14:creationId xmlns:p14="http://schemas.microsoft.com/office/powerpoint/2010/main" val="1719884253"/>
       </p:ext>
     </p:extLst>
   </p:cSld>
@@ -14594,7 +14594,7 @@
           <p:cNvPr id="10" name="">
             <a:extLst xmlns:a="http://schemas.openxmlformats.org/drawingml/2006/main">
               <a:ext uri="{FF2B5EF4-FFF2-40B4-BE49-F238E27FC236}">
-                <a16:creationId xmlns:a16="http://schemas.microsoft.com/office/drawing/2014/main" id="{9F04109B-6726-46ED-9075-FF617C73156F}"/>
+                <a16:creationId xmlns:a16="http://schemas.microsoft.com/office/drawing/2014/main" id="{51B36FFF-2B54-466B-ACEE-2FD7737463B1}"/>
               </a:ext>
             </a:extLst>
           </p:cNvPr>
@@ -14651,7 +14651,7 @@
           <p:cNvPr id="2" name="">
             <a:extLst xmlns:a="http://schemas.openxmlformats.org/drawingml/2006/main">
               <a:ext uri="{FF2B5EF4-FFF2-40B4-BE49-F238E27FC236}">
-                <a16:creationId xmlns:a16="http://schemas.microsoft.com/office/drawing/2014/main" id="{5FC55807-20E6-4919-9E8A-4B732EA57CC5}"/>
+                <a16:creationId xmlns:a16="http://schemas.microsoft.com/office/drawing/2014/main" id="{B9D9F977-0068-459C-BA96-88E9CE00212E}"/>
               </a:ext>
             </a:extLst>
           </p:cNvPr>
@@ -14708,7 +14708,7 @@
           <p:cNvPr id="3" name="">
             <a:extLst xmlns:a="http://schemas.openxmlformats.org/drawingml/2006/main">
               <a:ext uri="{FF2B5EF4-FFF2-40B4-BE49-F238E27FC236}">
-                <a16:creationId xmlns:a16="http://schemas.microsoft.com/office/drawing/2014/main" id="{2D052471-0ABA-47E1-AAE8-D43CE8BD0C6D}"/>
+                <a16:creationId xmlns:a16="http://schemas.microsoft.com/office/drawing/2014/main" id="{F8654DE3-D4B0-49DD-AC31-7E7B6104E1DC}"/>
               </a:ext>
             </a:extLst>
           </p:cNvPr>
@@ -14765,7 +14765,7 @@
           <p:cNvPr id="4" name="">
             <a:extLst xmlns:a="http://schemas.openxmlformats.org/drawingml/2006/main">
               <a:ext uri="{FF2B5EF4-FFF2-40B4-BE49-F238E27FC236}">
-                <a16:creationId xmlns:a16="http://schemas.microsoft.com/office/drawing/2014/main" id="{93F01721-8CFC-4C9C-A2C3-866478B0B384}"/>
+                <a16:creationId xmlns:a16="http://schemas.microsoft.com/office/drawing/2014/main" id="{BD37BAA0-CBBA-4EB4-A547-C6240A818927}"/>
               </a:ext>
             </a:extLst>
           </p:cNvPr>
@@ -14822,7 +14822,7 @@
           <p:cNvPr id="5" name="">
             <a:extLst xmlns:a="http://schemas.openxmlformats.org/drawingml/2006/main">
               <a:ext uri="{FF2B5EF4-FFF2-40B4-BE49-F238E27FC236}">
-                <a16:creationId xmlns:a16="http://schemas.microsoft.com/office/drawing/2014/main" id="{59BCA9BA-C7A0-45E1-8713-7E1FA22D4153}"/>
+                <a16:creationId xmlns:a16="http://schemas.microsoft.com/office/drawing/2014/main" id="{BE4AA7DC-2020-4B34-80D9-31442ED86D94}"/>
               </a:ext>
             </a:extLst>
           </p:cNvPr>
@@ -14925,7 +14925,7 @@
           <p:cNvPr id="6" name="">
             <a:extLst xmlns:a="http://schemas.openxmlformats.org/drawingml/2006/main">
               <a:ext uri="{FF2B5EF4-FFF2-40B4-BE49-F238E27FC236}">
-                <a16:creationId xmlns:a16="http://schemas.microsoft.com/office/drawing/2014/main" id="{E4BE6238-9C72-4F71-8BC3-EC8CBE2D146D}"/>
+                <a16:creationId xmlns:a16="http://schemas.microsoft.com/office/drawing/2014/main" id="{13FE5295-0B09-49E8-9FB4-7B03F9FACB8A}"/>
               </a:ext>
             </a:extLst>
           </p:cNvPr>
@@ -14971,7 +14971,7 @@
                 <a:latin typeface="Helvetica Neue"/>
                 <a:ea typeface="Helvetica Neue"/>
                 <a:cs typeface="Helvetica Neue"/>
-                <a:hlinkClick xmlns:r="http://schemas.openxmlformats.org/officeDocument/2006/relationships" r:id="R9631d41ce1b84b59"/>
+                <a:hlinkClick xmlns:r="http://schemas.openxmlformats.org/officeDocument/2006/relationships" r:id="Re815a5a9696e49c6"/>
               </a:rPr>
               <a:t>Open verification record</a:t>
             </a:r>
@@ -14987,7 +14987,7 @@
           <p:nvPr/>
         </p:nvPicPr>
         <p:blipFill>
-          <a:blip xmlns:r="http://schemas.openxmlformats.org/officeDocument/2006/relationships" xmlns:a="http://schemas.openxmlformats.org/drawingml/2006/main" r:embed="R89a031982c144e2e"/>
+          <a:blip xmlns:r="http://schemas.openxmlformats.org/officeDocument/2006/relationships" xmlns:a="http://schemas.openxmlformats.org/drawingml/2006/main" r:embed="Rf5c82e14aacb4d89"/>
           <a:stretch xmlns:a="http://schemas.openxmlformats.org/drawingml/2006/main"/>
         </p:blipFill>
         <p:spPr>
@@ -15005,7 +15005,7 @@
           <p:cNvPr id="8" name="">
             <a:extLst xmlns:a="http://schemas.openxmlformats.org/drawingml/2006/main">
               <a:ext uri="{FF2B5EF4-FFF2-40B4-BE49-F238E27FC236}">
-                <a16:creationId xmlns:a16="http://schemas.microsoft.com/office/drawing/2014/main" id="{38E03FA3-B6CE-4F3F-8336-DA4946E16F53}"/>
+                <a16:creationId xmlns:a16="http://schemas.microsoft.com/office/drawing/2014/main" id="{4AC30E97-E027-40D8-A3D0-35029C85CC53}"/>
               </a:ext>
             </a:extLst>
           </p:cNvPr>
@@ -15062,7 +15062,7 @@
           <p:cNvPr id="9" name="">
             <a:extLst xmlns:a="http://schemas.openxmlformats.org/drawingml/2006/main">
               <a:ext uri="{FF2B5EF4-FFF2-40B4-BE49-F238E27FC236}">
-                <a16:creationId xmlns:a16="http://schemas.microsoft.com/office/drawing/2014/main" id="{A330977B-8E02-451D-8B81-B2E0FADBE93F}"/>
+                <a16:creationId xmlns:a16="http://schemas.microsoft.com/office/drawing/2014/main" id="{B20DFD4D-CD5B-4F85-9271-FF7A44EC1FAA}"/>
               </a:ext>
             </a:extLst>
           </p:cNvPr>
@@ -15140,7 +15140,7 @@
     </p:spTree>
     <p:extLst>
       <p:ext uri="{BB962C8B-B14F-4D97-AF65-F5344CB8AC3E}">
-        <p14:creationId xmlns:p14="http://schemas.microsoft.com/office/powerpoint/2010/main" val="654677425"/>
+        <p14:creationId xmlns:p14="http://schemas.microsoft.com/office/powerpoint/2010/main" val="1496073107"/>
       </p:ext>
     </p:extLst>
   </p:cSld>
@@ -15171,7 +15171,7 @@
           <p:cNvPr id="5" name="">
             <a:extLst xmlns:a="http://schemas.openxmlformats.org/drawingml/2006/main">
               <a:ext uri="{FF2B5EF4-FFF2-40B4-BE49-F238E27FC236}">
-                <a16:creationId xmlns:a16="http://schemas.microsoft.com/office/drawing/2014/main" id="{1DD40852-727A-4A29-93F9-1BE62CD5981F}"/>
+                <a16:creationId xmlns:a16="http://schemas.microsoft.com/office/drawing/2014/main" id="{0F054285-081D-41F6-8632-8EE07849A998}"/>
               </a:ext>
             </a:extLst>
           </p:cNvPr>
@@ -15228,7 +15228,7 @@
           <p:cNvPr id="2" name="">
             <a:extLst xmlns:a="http://schemas.openxmlformats.org/drawingml/2006/main">
               <a:ext uri="{FF2B5EF4-FFF2-40B4-BE49-F238E27FC236}">
-                <a16:creationId xmlns:a16="http://schemas.microsoft.com/office/drawing/2014/main" id="{FE692320-8005-4345-AF8A-1AA1B1D5D052}"/>
+                <a16:creationId xmlns:a16="http://schemas.microsoft.com/office/drawing/2014/main" id="{BC1D762F-DF07-45B9-AB19-4CBC7E2A9FBE}"/>
               </a:ext>
             </a:extLst>
           </p:cNvPr>
@@ -15788,7 +15788,7 @@
           <p:cNvPr id="4" name="">
             <a:extLst xmlns:a="http://schemas.openxmlformats.org/drawingml/2006/main">
               <a:ext uri="{FF2B5EF4-FFF2-40B4-BE49-F238E27FC236}">
-                <a16:creationId xmlns:a16="http://schemas.microsoft.com/office/drawing/2014/main" id="{6631C39E-9E6E-42F7-A0BA-385E969D30FF}"/>
+                <a16:creationId xmlns:a16="http://schemas.microsoft.com/office/drawing/2014/main" id="{DE1A2600-DDC9-46E9-BF55-0C78A397BB0C}"/>
               </a:ext>
             </a:extLst>
           </p:cNvPr>
@@ -15843,7 +15843,7 @@
     </p:spTree>
     <p:extLst>
       <p:ext uri="{BB962C8B-B14F-4D97-AF65-F5344CB8AC3E}">
-        <p14:creationId xmlns:p14="http://schemas.microsoft.com/office/powerpoint/2010/main" val="1909333497"/>
+        <p14:creationId xmlns:p14="http://schemas.microsoft.com/office/powerpoint/2010/main" val="2021387150"/>
       </p:ext>
     </p:extLst>
   </p:cSld>
@@ -15874,7 +15874,7 @@
           <p:cNvPr id="7" name="">
             <a:extLst xmlns:a="http://schemas.openxmlformats.org/drawingml/2006/main">
               <a:ext uri="{FF2B5EF4-FFF2-40B4-BE49-F238E27FC236}">
-                <a16:creationId xmlns:a16="http://schemas.microsoft.com/office/drawing/2014/main" id="{98EF8573-734E-4CAF-AF00-CBBA06C9A653}"/>
+                <a16:creationId xmlns:a16="http://schemas.microsoft.com/office/drawing/2014/main" id="{EAF1ABEB-794E-481A-9796-A7F5FD1E12C1}"/>
               </a:ext>
             </a:extLst>
           </p:cNvPr>
@@ -15931,7 +15931,7 @@
           <p:cNvPr id="2" name="">
             <a:extLst xmlns:a="http://schemas.openxmlformats.org/drawingml/2006/main">
               <a:ext uri="{FF2B5EF4-FFF2-40B4-BE49-F238E27FC236}">
-                <a16:creationId xmlns:a16="http://schemas.microsoft.com/office/drawing/2014/main" id="{1E091FBE-B1E4-485D-AB8C-E4C60E01A2AF}"/>
+                <a16:creationId xmlns:a16="http://schemas.microsoft.com/office/drawing/2014/main" id="{42CC0373-A19C-4300-A2C0-3990636F94AC}"/>
               </a:ext>
             </a:extLst>
           </p:cNvPr>
@@ -15988,7 +15988,7 @@
           <p:cNvPr id="3" name="">
             <a:extLst xmlns:a="http://schemas.openxmlformats.org/drawingml/2006/main">
               <a:ext uri="{FF2B5EF4-FFF2-40B4-BE49-F238E27FC236}">
-                <a16:creationId xmlns:a16="http://schemas.microsoft.com/office/drawing/2014/main" id="{937E1275-4770-4172-9F64-AFAFF5AFCEDB}"/>
+                <a16:creationId xmlns:a16="http://schemas.microsoft.com/office/drawing/2014/main" id="{37D4403D-384E-4889-9223-85965F4AD087}"/>
               </a:ext>
             </a:extLst>
           </p:cNvPr>
@@ -16045,7 +16045,7 @@
           <p:cNvPr id="4" name="">
             <a:extLst xmlns:a="http://schemas.openxmlformats.org/drawingml/2006/main">
               <a:ext uri="{FF2B5EF4-FFF2-40B4-BE49-F238E27FC236}">
-                <a16:creationId xmlns:a16="http://schemas.microsoft.com/office/drawing/2014/main" id="{6D9FCB70-2060-4A8D-A561-E1A350D7C0A0}"/>
+                <a16:creationId xmlns:a16="http://schemas.microsoft.com/office/drawing/2014/main" id="{1DA6AFB6-8333-479C-AADB-FD7ECE2D23E6}"/>
               </a:ext>
             </a:extLst>
           </p:cNvPr>
@@ -16102,7 +16102,7 @@
           <p:cNvPr id="5" name="">
             <a:extLst xmlns:a="http://schemas.openxmlformats.org/drawingml/2006/main">
               <a:ext uri="{FF2B5EF4-FFF2-40B4-BE49-F238E27FC236}">
-                <a16:creationId xmlns:a16="http://schemas.microsoft.com/office/drawing/2014/main" id="{1CA98A73-E5CB-4D0B-BDCA-2F56F357CE25}"/>
+                <a16:creationId xmlns:a16="http://schemas.microsoft.com/office/drawing/2014/main" id="{7C2486EE-4D4C-4F99-9B2D-4167483E797A}"/>
               </a:ext>
             </a:extLst>
           </p:cNvPr>
@@ -16159,7 +16159,7 @@
           <p:cNvPr id="6" name="">
             <a:extLst xmlns:a="http://schemas.openxmlformats.org/drawingml/2006/main">
               <a:ext uri="{FF2B5EF4-FFF2-40B4-BE49-F238E27FC236}">
-                <a16:creationId xmlns:a16="http://schemas.microsoft.com/office/drawing/2014/main" id="{826D3AD6-42F3-4D1F-BE84-B6D387E32960}"/>
+                <a16:creationId xmlns:a16="http://schemas.microsoft.com/office/drawing/2014/main" id="{E0FA5490-DA0C-4DF9-A39A-82BC552339C8}"/>
               </a:ext>
             </a:extLst>
           </p:cNvPr>
@@ -16214,7 +16214,7 @@
     </p:spTree>
     <p:extLst>
       <p:ext uri="{BB962C8B-B14F-4D97-AF65-F5344CB8AC3E}">
-        <p14:creationId xmlns:p14="http://schemas.microsoft.com/office/powerpoint/2010/main" val="1401112841"/>
+        <p14:creationId xmlns:p14="http://schemas.microsoft.com/office/powerpoint/2010/main" val="1688082314"/>
       </p:ext>
     </p:extLst>
   </p:cSld>
@@ -16245,7 +16245,7 @@
           <p:cNvPr id="5" name="">
             <a:extLst xmlns:a="http://schemas.openxmlformats.org/drawingml/2006/main">
               <a:ext uri="{FF2B5EF4-FFF2-40B4-BE49-F238E27FC236}">
-                <a16:creationId xmlns:a16="http://schemas.microsoft.com/office/drawing/2014/main" id="{F33DD028-5E7F-444E-B18B-B648850B649D}"/>
+                <a16:creationId xmlns:a16="http://schemas.microsoft.com/office/drawing/2014/main" id="{2A4244F4-5A36-4472-BAF4-FE6F1413F8C2}"/>
               </a:ext>
             </a:extLst>
           </p:cNvPr>
@@ -16302,7 +16302,7 @@
           <p:cNvPr id="2" name="">
             <a:extLst xmlns:a="http://schemas.openxmlformats.org/drawingml/2006/main">
               <a:ext uri="{FF2B5EF4-FFF2-40B4-BE49-F238E27FC236}">
-                <a16:creationId xmlns:a16="http://schemas.microsoft.com/office/drawing/2014/main" id="{E94DC77A-527F-41BC-B22C-ABBB7AF29C7D}"/>
+                <a16:creationId xmlns:a16="http://schemas.microsoft.com/office/drawing/2014/main" id="{FA40F763-B0D2-4E44-9674-A9D9CF4F3931}"/>
               </a:ext>
             </a:extLst>
           </p:cNvPr>
@@ -16782,7 +16782,7 @@
           <p:cNvPr id="4" name="">
             <a:extLst xmlns:a="http://schemas.openxmlformats.org/drawingml/2006/main">
               <a:ext uri="{FF2B5EF4-FFF2-40B4-BE49-F238E27FC236}">
-                <a16:creationId xmlns:a16="http://schemas.microsoft.com/office/drawing/2014/main" id="{E9E7ACED-64DC-4F28-A9B2-05DEA33EAD1A}"/>
+                <a16:creationId xmlns:a16="http://schemas.microsoft.com/office/drawing/2014/main" id="{35AB7522-3D7F-47D2-BBAC-565AA0C50944}"/>
               </a:ext>
             </a:extLst>
           </p:cNvPr>
@@ -16837,7 +16837,7 @@
     </p:spTree>
     <p:extLst>
       <p:ext uri="{BB962C8B-B14F-4D97-AF65-F5344CB8AC3E}">
-        <p14:creationId xmlns:p14="http://schemas.microsoft.com/office/powerpoint/2010/main" val="332515171"/>
+        <p14:creationId xmlns:p14="http://schemas.microsoft.com/office/powerpoint/2010/main" val="1068509766"/>
       </p:ext>
     </p:extLst>
   </p:cSld>
@@ -16868,7 +16868,7 @@
           <p:cNvPr id="10" name="">
             <a:extLst xmlns:a="http://schemas.openxmlformats.org/drawingml/2006/main">
               <a:ext uri="{FF2B5EF4-FFF2-40B4-BE49-F238E27FC236}">
-                <a16:creationId xmlns:a16="http://schemas.microsoft.com/office/drawing/2014/main" id="{39688E86-399B-4B64-A380-766AE833ADF5}"/>
+                <a16:creationId xmlns:a16="http://schemas.microsoft.com/office/drawing/2014/main" id="{3A4B26ED-A791-4DA6-89D1-F71D32243A3A}"/>
               </a:ext>
             </a:extLst>
           </p:cNvPr>
@@ -16925,7 +16925,7 @@
           <p:cNvPr id="2" name="">
             <a:extLst xmlns:a="http://schemas.openxmlformats.org/drawingml/2006/main">
               <a:ext uri="{FF2B5EF4-FFF2-40B4-BE49-F238E27FC236}">
-                <a16:creationId xmlns:a16="http://schemas.microsoft.com/office/drawing/2014/main" id="{7A645232-33E5-4D03-B4D5-51E4229560AF}"/>
+                <a16:creationId xmlns:a16="http://schemas.microsoft.com/office/drawing/2014/main" id="{58F3DB5E-A781-437D-95B0-90F8DB06DC5D}"/>
               </a:ext>
             </a:extLst>
           </p:cNvPr>
@@ -16982,7 +16982,7 @@
           <p:cNvPr id="3" name="">
             <a:extLst xmlns:a="http://schemas.openxmlformats.org/drawingml/2006/main">
               <a:ext uri="{FF2B5EF4-FFF2-40B4-BE49-F238E27FC236}">
-                <a16:creationId xmlns:a16="http://schemas.microsoft.com/office/drawing/2014/main" id="{06EDDE6C-790F-4CC7-AD30-D0A82C567150}"/>
+                <a16:creationId xmlns:a16="http://schemas.microsoft.com/office/drawing/2014/main" id="{8AD5227C-677D-41D0-8410-C1AF64C58BED}"/>
               </a:ext>
             </a:extLst>
           </p:cNvPr>
@@ -17039,7 +17039,7 @@
           <p:cNvPr id="4" name="">
             <a:extLst xmlns:a="http://schemas.openxmlformats.org/drawingml/2006/main">
               <a:ext uri="{FF2B5EF4-FFF2-40B4-BE49-F238E27FC236}">
-                <a16:creationId xmlns:a16="http://schemas.microsoft.com/office/drawing/2014/main" id="{8E55A0DF-795C-4994-B0BF-C3C8D46AA7A7}"/>
+                <a16:creationId xmlns:a16="http://schemas.microsoft.com/office/drawing/2014/main" id="{86043E4F-8B5D-4004-933A-E6E6886A9840}"/>
               </a:ext>
             </a:extLst>
           </p:cNvPr>
@@ -17096,7 +17096,7 @@
           <p:cNvPr id="5" name="">
             <a:extLst xmlns:a="http://schemas.openxmlformats.org/drawingml/2006/main">
               <a:ext uri="{FF2B5EF4-FFF2-40B4-BE49-F238E27FC236}">
-                <a16:creationId xmlns:a16="http://schemas.microsoft.com/office/drawing/2014/main" id="{4EB3F814-6F0B-448D-BDC4-C9877C2AC5D5}"/>
+                <a16:creationId xmlns:a16="http://schemas.microsoft.com/office/drawing/2014/main" id="{297C0105-121F-448B-A19A-D7D8B089EA47}"/>
               </a:ext>
             </a:extLst>
           </p:cNvPr>
@@ -17153,7 +17153,7 @@
           <p:cNvPr id="6" name="">
             <a:extLst xmlns:a="http://schemas.openxmlformats.org/drawingml/2006/main">
               <a:ext uri="{FF2B5EF4-FFF2-40B4-BE49-F238E27FC236}">
-                <a16:creationId xmlns:a16="http://schemas.microsoft.com/office/drawing/2014/main" id="{CC9D17A9-9761-4A49-9848-81D75A1B8A0A}"/>
+                <a16:creationId xmlns:a16="http://schemas.microsoft.com/office/drawing/2014/main" id="{EEBE1690-27DC-4B84-BE5C-B4718588E159}"/>
               </a:ext>
             </a:extLst>
           </p:cNvPr>
@@ -17210,7 +17210,7 @@
           <p:cNvPr id="7" name="">
             <a:extLst xmlns:a="http://schemas.openxmlformats.org/drawingml/2006/main">
               <a:ext uri="{FF2B5EF4-FFF2-40B4-BE49-F238E27FC236}">
-                <a16:creationId xmlns:a16="http://schemas.microsoft.com/office/drawing/2014/main" id="{5B8B26CA-B98E-4AD5-9B36-A22459AE0787}"/>
+                <a16:creationId xmlns:a16="http://schemas.microsoft.com/office/drawing/2014/main" id="{B1DC1BC8-5280-4637-83E4-FD10593A6766}"/>
               </a:ext>
             </a:extLst>
           </p:cNvPr>
@@ -17267,7 +17267,7 @@
           <p:cNvPr id="8" name="">
             <a:extLst xmlns:a="http://schemas.openxmlformats.org/drawingml/2006/main">
               <a:ext uri="{FF2B5EF4-FFF2-40B4-BE49-F238E27FC236}">
-                <a16:creationId xmlns:a16="http://schemas.microsoft.com/office/drawing/2014/main" id="{F4784EAE-FDAF-412B-805B-F49427D261E9}"/>
+                <a16:creationId xmlns:a16="http://schemas.microsoft.com/office/drawing/2014/main" id="{3E9B91B8-71CA-4250-BF9A-484155EBA2AD}"/>
               </a:ext>
             </a:extLst>
           </p:cNvPr>
@@ -17324,7 +17324,7 @@
           <p:cNvPr id="9" name="">
             <a:extLst xmlns:a="http://schemas.openxmlformats.org/drawingml/2006/main">
               <a:ext uri="{FF2B5EF4-FFF2-40B4-BE49-F238E27FC236}">
-                <a16:creationId xmlns:a16="http://schemas.microsoft.com/office/drawing/2014/main" id="{A92C3771-12A9-489A-853F-9A6CB1D12BBD}"/>
+                <a16:creationId xmlns:a16="http://schemas.microsoft.com/office/drawing/2014/main" id="{A828D045-C5C2-46FD-9A1A-F6C3821E6AF5}"/>
               </a:ext>
             </a:extLst>
           </p:cNvPr>
@@ -17425,7 +17425,7 @@
     </p:spTree>
     <p:extLst>
       <p:ext uri="{BB962C8B-B14F-4D97-AF65-F5344CB8AC3E}">
-        <p14:creationId xmlns:p14="http://schemas.microsoft.com/office/powerpoint/2010/main" val="1893459331"/>
+        <p14:creationId xmlns:p14="http://schemas.microsoft.com/office/powerpoint/2010/main" val="816211649"/>
       </p:ext>
     </p:extLst>
   </p:cSld>
@@ -17456,7 +17456,7 @@
           <p:cNvPr id="11" name="">
             <a:extLst xmlns:a="http://schemas.openxmlformats.org/drawingml/2006/main">
               <a:ext uri="{FF2B5EF4-FFF2-40B4-BE49-F238E27FC236}">
-                <a16:creationId xmlns:a16="http://schemas.microsoft.com/office/drawing/2014/main" id="{EDDC2E84-217F-47C4-BC3E-2AADFF2CA488}"/>
+                <a16:creationId xmlns:a16="http://schemas.microsoft.com/office/drawing/2014/main" id="{321E5868-74E5-4B85-BA41-D065BE494EC2}"/>
               </a:ext>
             </a:extLst>
           </p:cNvPr>
@@ -17513,7 +17513,7 @@
           <p:cNvPr id="2" name="">
             <a:extLst xmlns:a="http://schemas.openxmlformats.org/drawingml/2006/main">
               <a:ext uri="{FF2B5EF4-FFF2-40B4-BE49-F238E27FC236}">
-                <a16:creationId xmlns:a16="http://schemas.microsoft.com/office/drawing/2014/main" id="{F44ABAAA-48E4-42CC-B052-02A09EA2A359}"/>
+                <a16:creationId xmlns:a16="http://schemas.microsoft.com/office/drawing/2014/main" id="{4F6E6EDF-AE98-454D-AF6E-5285AF73A9A0}"/>
               </a:ext>
             </a:extLst>
           </p:cNvPr>
@@ -17570,7 +17570,7 @@
           <p:cNvPr id="3" name="">
             <a:extLst xmlns:a="http://schemas.openxmlformats.org/drawingml/2006/main">
               <a:ext uri="{FF2B5EF4-FFF2-40B4-BE49-F238E27FC236}">
-                <a16:creationId xmlns:a16="http://schemas.microsoft.com/office/drawing/2014/main" id="{6850263F-32F4-47D2-BBA6-D3FC664B0EE4}"/>
+                <a16:creationId xmlns:a16="http://schemas.microsoft.com/office/drawing/2014/main" id="{C9672CA6-5BB5-4F73-A3C4-B315CAD06846}"/>
               </a:ext>
             </a:extLst>
           </p:cNvPr>
@@ -17627,7 +17627,7 @@
           <p:cNvPr id="4" name="">
             <a:extLst xmlns:a="http://schemas.openxmlformats.org/drawingml/2006/main">
               <a:ext uri="{FF2B5EF4-FFF2-40B4-BE49-F238E27FC236}">
-                <a16:creationId xmlns:a16="http://schemas.microsoft.com/office/drawing/2014/main" id="{B998CFED-420E-4B42-BCFA-134A65114011}"/>
+                <a16:creationId xmlns:a16="http://schemas.microsoft.com/office/drawing/2014/main" id="{9DCF1243-4E6C-4646-8FF9-3B3F3BCCD82E}"/>
               </a:ext>
             </a:extLst>
           </p:cNvPr>
@@ -17684,7 +17684,7 @@
           <p:cNvPr id="5" name="">
             <a:extLst xmlns:a="http://schemas.openxmlformats.org/drawingml/2006/main">
               <a:ext uri="{FF2B5EF4-FFF2-40B4-BE49-F238E27FC236}">
-                <a16:creationId xmlns:a16="http://schemas.microsoft.com/office/drawing/2014/main" id="{400F6CC5-887A-477A-A52D-7D45B358ACA1}"/>
+                <a16:creationId xmlns:a16="http://schemas.microsoft.com/office/drawing/2014/main" id="{2A56DEA8-4C6E-48BC-B1B6-083611956C74}"/>
               </a:ext>
             </a:extLst>
           </p:cNvPr>
@@ -17741,7 +17741,7 @@
           <p:cNvPr id="6" name="">
             <a:extLst xmlns:a="http://schemas.openxmlformats.org/drawingml/2006/main">
               <a:ext uri="{FF2B5EF4-FFF2-40B4-BE49-F238E27FC236}">
-                <a16:creationId xmlns:a16="http://schemas.microsoft.com/office/drawing/2014/main" id="{70CA976B-7C23-4BFF-9C1B-EE5E6D99E5A3}"/>
+                <a16:creationId xmlns:a16="http://schemas.microsoft.com/office/drawing/2014/main" id="{CE0D1AAB-9CB4-4B3F-8DF7-BBB4774628DD}"/>
               </a:ext>
             </a:extLst>
           </p:cNvPr>
@@ -17798,7 +17798,7 @@
           <p:cNvPr id="7" name="">
             <a:extLst xmlns:a="http://schemas.openxmlformats.org/drawingml/2006/main">
               <a:ext uri="{FF2B5EF4-FFF2-40B4-BE49-F238E27FC236}">
-                <a16:creationId xmlns:a16="http://schemas.microsoft.com/office/drawing/2014/main" id="{91444817-8979-4C2B-8DA0-EF03A071BFA5}"/>
+                <a16:creationId xmlns:a16="http://schemas.microsoft.com/office/drawing/2014/main" id="{8AD519A7-01CC-4EF9-8B32-AABD8F30A977}"/>
               </a:ext>
             </a:extLst>
           </p:cNvPr>
@@ -17855,7 +17855,7 @@
           <p:cNvPr id="8" name="">
             <a:extLst xmlns:a="http://schemas.openxmlformats.org/drawingml/2006/main">
               <a:ext uri="{FF2B5EF4-FFF2-40B4-BE49-F238E27FC236}">
-                <a16:creationId xmlns:a16="http://schemas.microsoft.com/office/drawing/2014/main" id="{05AC053E-DC7F-466A-B908-7E078C88FD5E}"/>
+                <a16:creationId xmlns:a16="http://schemas.microsoft.com/office/drawing/2014/main" id="{DFDE743D-0509-412C-BE3B-2D66FF4FD469}"/>
               </a:ext>
             </a:extLst>
           </p:cNvPr>
@@ -17912,7 +17912,7 @@
           <p:cNvPr id="9" name="">
             <a:extLst xmlns:a="http://schemas.openxmlformats.org/drawingml/2006/main">
               <a:ext uri="{FF2B5EF4-FFF2-40B4-BE49-F238E27FC236}">
-                <a16:creationId xmlns:a16="http://schemas.microsoft.com/office/drawing/2014/main" id="{D9B344B8-1B8C-43A0-A875-FC77BAF164F1}"/>
+                <a16:creationId xmlns:a16="http://schemas.microsoft.com/office/drawing/2014/main" id="{7A688221-6EC5-4249-A0B1-BD336A7A1A01}"/>
               </a:ext>
             </a:extLst>
           </p:cNvPr>
@@ -17969,7 +17969,7 @@
           <p:cNvPr id="10" name="">
             <a:extLst xmlns:a="http://schemas.openxmlformats.org/drawingml/2006/main">
               <a:ext uri="{FF2B5EF4-FFF2-40B4-BE49-F238E27FC236}">
-                <a16:creationId xmlns:a16="http://schemas.microsoft.com/office/drawing/2014/main" id="{5A285A66-CF52-4A36-854D-4577166A8B1E}"/>
+                <a16:creationId xmlns:a16="http://schemas.microsoft.com/office/drawing/2014/main" id="{4BE85657-0166-491F-9D37-73255261DD74}"/>
               </a:ext>
             </a:extLst>
           </p:cNvPr>
@@ -18024,7 +18024,7 @@
     </p:spTree>
     <p:extLst>
       <p:ext uri="{BB962C8B-B14F-4D97-AF65-F5344CB8AC3E}">
-        <p14:creationId xmlns:p14="http://schemas.microsoft.com/office/powerpoint/2010/main" val="1502334770"/>
+        <p14:creationId xmlns:p14="http://schemas.microsoft.com/office/powerpoint/2010/main" val="1751996261"/>
       </p:ext>
     </p:extLst>
   </p:cSld>
@@ -18055,7 +18055,7 @@
           <p:cNvPr id="9" name="">
             <a:extLst xmlns:a="http://schemas.openxmlformats.org/drawingml/2006/main">
               <a:ext uri="{FF2B5EF4-FFF2-40B4-BE49-F238E27FC236}">
-                <a16:creationId xmlns:a16="http://schemas.microsoft.com/office/drawing/2014/main" id="{3E8681BC-DC66-454C-9D5D-9829AE2E4065}"/>
+                <a16:creationId xmlns:a16="http://schemas.microsoft.com/office/drawing/2014/main" id="{1278040F-12C8-49F0-B2EC-A907A68512F4}"/>
               </a:ext>
             </a:extLst>
           </p:cNvPr>
@@ -18112,7 +18112,7 @@
           <p:cNvPr id="2" name="">
             <a:extLst xmlns:a="http://schemas.openxmlformats.org/drawingml/2006/main">
               <a:ext uri="{FF2B5EF4-FFF2-40B4-BE49-F238E27FC236}">
-                <a16:creationId xmlns:a16="http://schemas.microsoft.com/office/drawing/2014/main" id="{4E7D29C9-5C8E-49BA-B67A-968E92EFE654}"/>
+                <a16:creationId xmlns:a16="http://schemas.microsoft.com/office/drawing/2014/main" id="{BC082043-AC24-46F1-A63A-6090AEFF7D6A}"/>
               </a:ext>
             </a:extLst>
           </p:cNvPr>
@@ -18169,7 +18169,7 @@
           <p:cNvPr id="3" name="">
             <a:extLst xmlns:a="http://schemas.openxmlformats.org/drawingml/2006/main">
               <a:ext uri="{FF2B5EF4-FFF2-40B4-BE49-F238E27FC236}">
-                <a16:creationId xmlns:a16="http://schemas.microsoft.com/office/drawing/2014/main" id="{65AD64ED-98F2-4907-82A3-D70B5D60DD8C}"/>
+                <a16:creationId xmlns:a16="http://schemas.microsoft.com/office/drawing/2014/main" id="{7AC0F43E-85E9-4C8D-9D38-122E36FCB55E}"/>
               </a:ext>
             </a:extLst>
           </p:cNvPr>
@@ -18226,7 +18226,7 @@
           <p:cNvPr id="4" name="">
             <a:extLst xmlns:a="http://schemas.openxmlformats.org/drawingml/2006/main">
               <a:ext uri="{FF2B5EF4-FFF2-40B4-BE49-F238E27FC236}">
-                <a16:creationId xmlns:a16="http://schemas.microsoft.com/office/drawing/2014/main" id="{F2127C83-26A1-45EA-B286-1E0DA66EDD0D}"/>
+                <a16:creationId xmlns:a16="http://schemas.microsoft.com/office/drawing/2014/main" id="{69284B0C-03CE-4F3D-A0F6-2F0DD3656003}"/>
               </a:ext>
             </a:extLst>
           </p:cNvPr>
@@ -18283,7 +18283,7 @@
           <p:cNvPr id="5" name="">
             <a:extLst xmlns:a="http://schemas.openxmlformats.org/drawingml/2006/main">
               <a:ext uri="{FF2B5EF4-FFF2-40B4-BE49-F238E27FC236}">
-                <a16:creationId xmlns:a16="http://schemas.microsoft.com/office/drawing/2014/main" id="{340B001C-1EFD-4195-81A2-479CEDF6BBF7}"/>
+                <a16:creationId xmlns:a16="http://schemas.microsoft.com/office/drawing/2014/main" id="{F10E3310-25ED-406D-A840-45CB71563A61}"/>
               </a:ext>
             </a:extLst>
           </p:cNvPr>
@@ -18340,7 +18340,7 @@
           <p:cNvPr id="6" name="">
             <a:extLst xmlns:a="http://schemas.openxmlformats.org/drawingml/2006/main">
               <a:ext uri="{FF2B5EF4-FFF2-40B4-BE49-F238E27FC236}">
-                <a16:creationId xmlns:a16="http://schemas.microsoft.com/office/drawing/2014/main" id="{1D125778-CAF4-4630-978B-068FAC37A849}"/>
+                <a16:creationId xmlns:a16="http://schemas.microsoft.com/office/drawing/2014/main" id="{29B6DEC8-C41D-4051-B4D2-8B41AC4252EA}"/>
               </a:ext>
             </a:extLst>
           </p:cNvPr>
@@ -18397,7 +18397,7 @@
           <p:cNvPr id="7" name="">
             <a:extLst xmlns:a="http://schemas.openxmlformats.org/drawingml/2006/main">
               <a:ext uri="{FF2B5EF4-FFF2-40B4-BE49-F238E27FC236}">
-                <a16:creationId xmlns:a16="http://schemas.microsoft.com/office/drawing/2014/main" id="{A50E898A-2FA4-4C6D-9E0A-EAE27E8A0BC7}"/>
+                <a16:creationId xmlns:a16="http://schemas.microsoft.com/office/drawing/2014/main" id="{2B3AB7DF-24E9-4A31-BE8A-3657AFB92EB7}"/>
               </a:ext>
             </a:extLst>
           </p:cNvPr>
@@ -18454,7 +18454,7 @@
           <p:cNvPr id="8" name="">
             <a:extLst xmlns:a="http://schemas.openxmlformats.org/drawingml/2006/main">
               <a:ext uri="{FF2B5EF4-FFF2-40B4-BE49-F238E27FC236}">
-                <a16:creationId xmlns:a16="http://schemas.microsoft.com/office/drawing/2014/main" id="{9DE439BA-C0FF-4A4E-A746-6C6C2A75CA4C}"/>
+                <a16:creationId xmlns:a16="http://schemas.microsoft.com/office/drawing/2014/main" id="{41BB27EF-FB81-4B0C-B7ED-250F10C5D053}"/>
               </a:ext>
             </a:extLst>
           </p:cNvPr>
@@ -18509,7 +18509,7 @@
     </p:spTree>
     <p:extLst>
       <p:ext uri="{BB962C8B-B14F-4D97-AF65-F5344CB8AC3E}">
-        <p14:creationId xmlns:p14="http://schemas.microsoft.com/office/powerpoint/2010/main" val="405204388"/>
+        <p14:creationId xmlns:p14="http://schemas.microsoft.com/office/powerpoint/2010/main" val="1431401988"/>
       </p:ext>
     </p:extLst>
   </p:cSld>
@@ -18540,7 +18540,7 @@
           <p:cNvPr id="5" name="">
             <a:extLst xmlns:a="http://schemas.openxmlformats.org/drawingml/2006/main">
               <a:ext uri="{FF2B5EF4-FFF2-40B4-BE49-F238E27FC236}">
-                <a16:creationId xmlns:a16="http://schemas.microsoft.com/office/drawing/2014/main" id="{F8633735-9B4F-474D-8A1F-F29FFB6263EF}"/>
+                <a16:creationId xmlns:a16="http://schemas.microsoft.com/office/drawing/2014/main" id="{C5DBFB49-37DE-4E47-A832-439C0DF16B94}"/>
               </a:ext>
             </a:extLst>
           </p:cNvPr>
@@ -18597,7 +18597,7 @@
           <p:cNvPr id="2" name="">
             <a:extLst xmlns:a="http://schemas.openxmlformats.org/drawingml/2006/main">
               <a:ext uri="{FF2B5EF4-FFF2-40B4-BE49-F238E27FC236}">
-                <a16:creationId xmlns:a16="http://schemas.microsoft.com/office/drawing/2014/main" id="{5A3DC04E-6F6A-4A13-B2A0-47EA855A8F68}"/>
+                <a16:creationId xmlns:a16="http://schemas.microsoft.com/office/drawing/2014/main" id="{82B1DD1B-BC23-499A-96E4-48C82FBDC913}"/>
               </a:ext>
             </a:extLst>
           </p:cNvPr>
@@ -19077,7 +19077,7 @@
           <p:cNvPr id="4" name="">
             <a:extLst xmlns:a="http://schemas.openxmlformats.org/drawingml/2006/main">
               <a:ext uri="{FF2B5EF4-FFF2-40B4-BE49-F238E27FC236}">
-                <a16:creationId xmlns:a16="http://schemas.microsoft.com/office/drawing/2014/main" id="{6BED2E17-D067-488C-B94D-D21DB6EFD3B2}"/>
+                <a16:creationId xmlns:a16="http://schemas.microsoft.com/office/drawing/2014/main" id="{9B5175EB-DD93-41E5-83E4-393D50F6CBC0}"/>
               </a:ext>
             </a:extLst>
           </p:cNvPr>
@@ -19132,7 +19132,7 @@
     </p:spTree>
     <p:extLst>
       <p:ext uri="{BB962C8B-B14F-4D97-AF65-F5344CB8AC3E}">
-        <p14:creationId xmlns:p14="http://schemas.microsoft.com/office/powerpoint/2010/main" val="472362938"/>
+        <p14:creationId xmlns:p14="http://schemas.microsoft.com/office/powerpoint/2010/main" val="1120161023"/>
       </p:ext>
     </p:extLst>
   </p:cSld>
@@ -19163,7 +19163,7 @@
           <p:cNvPr id="7" name="">
             <a:extLst xmlns:a="http://schemas.openxmlformats.org/drawingml/2006/main">
               <a:ext uri="{FF2B5EF4-FFF2-40B4-BE49-F238E27FC236}">
-                <a16:creationId xmlns:a16="http://schemas.microsoft.com/office/drawing/2014/main" id="{E4324BD1-0732-41BF-89F7-52C3323D2E1F}"/>
+                <a16:creationId xmlns:a16="http://schemas.microsoft.com/office/drawing/2014/main" id="{F01D750D-2A9A-44C3-BF43-B5EF953B7009}"/>
               </a:ext>
             </a:extLst>
           </p:cNvPr>
@@ -19220,7 +19220,7 @@
           <p:cNvPr id="2" name="">
             <a:extLst xmlns:a="http://schemas.openxmlformats.org/drawingml/2006/main">
               <a:ext uri="{FF2B5EF4-FFF2-40B4-BE49-F238E27FC236}">
-                <a16:creationId xmlns:a16="http://schemas.microsoft.com/office/drawing/2014/main" id="{BA8958EF-23D7-48FD-B1AD-82531B16C80E}"/>
+                <a16:creationId xmlns:a16="http://schemas.microsoft.com/office/drawing/2014/main" id="{E09331B7-6145-4020-B11D-022ED22050E9}"/>
               </a:ext>
             </a:extLst>
           </p:cNvPr>
@@ -19893,7 +19893,7 @@
           <p:cNvPr id="4" name="">
             <a:extLst xmlns:a="http://schemas.openxmlformats.org/drawingml/2006/main">
               <a:ext uri="{FF2B5EF4-FFF2-40B4-BE49-F238E27FC236}">
-                <a16:creationId xmlns:a16="http://schemas.microsoft.com/office/drawing/2014/main" id="{5FD1A0E4-35FE-4EE7-BE3E-5E589211680B}"/>
+                <a16:creationId xmlns:a16="http://schemas.microsoft.com/office/drawing/2014/main" id="{7AE0D751-EBE2-4B74-A40F-71C46CD5A88D}"/>
               </a:ext>
             </a:extLst>
           </p:cNvPr>
@@ -19950,7 +19950,7 @@
           <p:cNvPr id="5" name="">
             <a:extLst xmlns:a="http://schemas.openxmlformats.org/drawingml/2006/main">
               <a:ext uri="{FF2B5EF4-FFF2-40B4-BE49-F238E27FC236}">
-                <a16:creationId xmlns:a16="http://schemas.microsoft.com/office/drawing/2014/main" id="{10BE5BCC-143C-443F-89A7-56F7A84D55C1}"/>
+                <a16:creationId xmlns:a16="http://schemas.microsoft.com/office/drawing/2014/main" id="{0D516997-CA27-43FF-AAF6-7BC3A0E6EFBD}"/>
               </a:ext>
             </a:extLst>
           </p:cNvPr>
@@ -20063,7 +20063,7 @@
           <p:cNvPr id="6" name="">
             <a:extLst xmlns:a="http://schemas.openxmlformats.org/drawingml/2006/main">
               <a:ext uri="{FF2B5EF4-FFF2-40B4-BE49-F238E27FC236}">
-                <a16:creationId xmlns:a16="http://schemas.microsoft.com/office/drawing/2014/main" id="{82556686-1F1E-4D24-BED2-4BD39125EEC7}"/>
+                <a16:creationId xmlns:a16="http://schemas.microsoft.com/office/drawing/2014/main" id="{5435321B-9738-4B16-9261-4054491F1E97}"/>
               </a:ext>
             </a:extLst>
           </p:cNvPr>
@@ -20118,7 +20118,7 @@
     </p:spTree>
     <p:extLst>
       <p:ext uri="{BB962C8B-B14F-4D97-AF65-F5344CB8AC3E}">
-        <p14:creationId xmlns:p14="http://schemas.microsoft.com/office/powerpoint/2010/main" val="1658683084"/>
+        <p14:creationId xmlns:p14="http://schemas.microsoft.com/office/powerpoint/2010/main" val="863912777"/>
       </p:ext>
     </p:extLst>
   </p:cSld>
@@ -20149,7 +20149,7 @@
           <p:cNvPr id="11" name="">
             <a:extLst xmlns:a="http://schemas.openxmlformats.org/drawingml/2006/main">
               <a:ext uri="{FF2B5EF4-FFF2-40B4-BE49-F238E27FC236}">
-                <a16:creationId xmlns:a16="http://schemas.microsoft.com/office/drawing/2014/main" id="{C76FF3B9-4F45-47A2-A1B4-A5C26B4C6257}"/>
+                <a16:creationId xmlns:a16="http://schemas.microsoft.com/office/drawing/2014/main" id="{23F7281D-8F87-4FF9-AD51-03919DAEA0B8}"/>
               </a:ext>
             </a:extLst>
           </p:cNvPr>
@@ -20206,7 +20206,7 @@
           <p:cNvPr id="2" name="">
             <a:extLst xmlns:a="http://schemas.openxmlformats.org/drawingml/2006/main">
               <a:ext uri="{FF2B5EF4-FFF2-40B4-BE49-F238E27FC236}">
-                <a16:creationId xmlns:a16="http://schemas.microsoft.com/office/drawing/2014/main" id="{5782E19E-EAB0-4E93-B8DD-B44CD022480F}"/>
+                <a16:creationId xmlns:a16="http://schemas.microsoft.com/office/drawing/2014/main" id="{81FAAC83-743E-436D-B58F-555F9F10230C}"/>
               </a:ext>
             </a:extLst>
           </p:cNvPr>
@@ -20263,7 +20263,7 @@
           <p:cNvPr id="3" name="">
             <a:extLst xmlns:a="http://schemas.openxmlformats.org/drawingml/2006/main">
               <a:ext uri="{FF2B5EF4-FFF2-40B4-BE49-F238E27FC236}">
-                <a16:creationId xmlns:a16="http://schemas.microsoft.com/office/drawing/2014/main" id="{AF74DC04-8257-46CE-9A9A-D0EA0164E085}"/>
+                <a16:creationId xmlns:a16="http://schemas.microsoft.com/office/drawing/2014/main" id="{EEE9F445-26D2-4FB7-B5CA-6FF8C7A84142}"/>
               </a:ext>
             </a:extLst>
           </p:cNvPr>
@@ -20320,7 +20320,7 @@
           <p:cNvPr id="4" name="">
             <a:extLst xmlns:a="http://schemas.openxmlformats.org/drawingml/2006/main">
               <a:ext uri="{FF2B5EF4-FFF2-40B4-BE49-F238E27FC236}">
-                <a16:creationId xmlns:a16="http://schemas.microsoft.com/office/drawing/2014/main" id="{C97DD02B-8F6E-4199-94B7-1976D439AA32}"/>
+                <a16:creationId xmlns:a16="http://schemas.microsoft.com/office/drawing/2014/main" id="{F897F9CF-E9A3-4A34-8CB6-C14CDF8F0226}"/>
               </a:ext>
             </a:extLst>
           </p:cNvPr>
@@ -20377,7 +20377,7 @@
           <p:cNvPr id="5" name="">
             <a:extLst xmlns:a="http://schemas.openxmlformats.org/drawingml/2006/main">
               <a:ext uri="{FF2B5EF4-FFF2-40B4-BE49-F238E27FC236}">
-                <a16:creationId xmlns:a16="http://schemas.microsoft.com/office/drawing/2014/main" id="{0752C081-588D-46F7-B086-00F576665016}"/>
+                <a16:creationId xmlns:a16="http://schemas.microsoft.com/office/drawing/2014/main" id="{C325C692-EA16-4BDD-9F30-21A223F765EB}"/>
               </a:ext>
             </a:extLst>
           </p:cNvPr>
@@ -20434,7 +20434,7 @@
           <p:cNvPr id="6" name="">
             <a:extLst xmlns:a="http://schemas.openxmlformats.org/drawingml/2006/main">
               <a:ext uri="{FF2B5EF4-FFF2-40B4-BE49-F238E27FC236}">
-                <a16:creationId xmlns:a16="http://schemas.microsoft.com/office/drawing/2014/main" id="{9A656FF0-D475-40E4-A825-A6922AA87ADD}"/>
+                <a16:creationId xmlns:a16="http://schemas.microsoft.com/office/drawing/2014/main" id="{33076B4C-12CD-408E-B4A5-106617F12001}"/>
               </a:ext>
             </a:extLst>
           </p:cNvPr>
@@ -20491,7 +20491,7 @@
           <p:cNvPr id="7" name="">
             <a:extLst xmlns:a="http://schemas.openxmlformats.org/drawingml/2006/main">
               <a:ext uri="{FF2B5EF4-FFF2-40B4-BE49-F238E27FC236}">
-                <a16:creationId xmlns:a16="http://schemas.microsoft.com/office/drawing/2014/main" id="{6FA339F4-E815-4B2B-BE5C-A14F99B2E56D}"/>
+                <a16:creationId xmlns:a16="http://schemas.microsoft.com/office/drawing/2014/main" id="{F1C03736-B663-4217-B7DA-A0F3A4D66DD8}"/>
               </a:ext>
             </a:extLst>
           </p:cNvPr>
@@ -20548,7 +20548,7 @@
           <p:cNvPr id="8" name="">
             <a:extLst xmlns:a="http://schemas.openxmlformats.org/drawingml/2006/main">
               <a:ext uri="{FF2B5EF4-FFF2-40B4-BE49-F238E27FC236}">
-                <a16:creationId xmlns:a16="http://schemas.microsoft.com/office/drawing/2014/main" id="{21645497-B414-415A-B982-92D9B5C5367B}"/>
+                <a16:creationId xmlns:a16="http://schemas.microsoft.com/office/drawing/2014/main" id="{F084D53A-EAB7-44DF-ACCE-F0303BBEC38E}"/>
               </a:ext>
             </a:extLst>
           </p:cNvPr>
@@ -20605,7 +20605,7 @@
           <p:cNvPr id="9" name="">
             <a:extLst xmlns:a="http://schemas.openxmlformats.org/drawingml/2006/main">
               <a:ext uri="{FF2B5EF4-FFF2-40B4-BE49-F238E27FC236}">
-                <a16:creationId xmlns:a16="http://schemas.microsoft.com/office/drawing/2014/main" id="{C9C0B61F-DB17-4C13-9A79-BFDE56176B0E}"/>
+                <a16:creationId xmlns:a16="http://schemas.microsoft.com/office/drawing/2014/main" id="{A97B206A-DBAB-4540-B29A-3A1495C85051}"/>
               </a:ext>
             </a:extLst>
           </p:cNvPr>
@@ -20662,7 +20662,7 @@
           <p:cNvPr id="10" name="">
             <a:extLst xmlns:a="http://schemas.openxmlformats.org/drawingml/2006/main">
               <a:ext uri="{FF2B5EF4-FFF2-40B4-BE49-F238E27FC236}">
-                <a16:creationId xmlns:a16="http://schemas.microsoft.com/office/drawing/2014/main" id="{43E13929-9CF3-43A5-8C82-B5903BA3D5A4}"/>
+                <a16:creationId xmlns:a16="http://schemas.microsoft.com/office/drawing/2014/main" id="{65768E63-2F24-47EC-91CC-9C37F9D1CDC4}"/>
               </a:ext>
             </a:extLst>
           </p:cNvPr>
@@ -20717,7 +20717,7 @@
     </p:spTree>
     <p:extLst>
       <p:ext uri="{BB962C8B-B14F-4D97-AF65-F5344CB8AC3E}">
-        <p14:creationId xmlns:p14="http://schemas.microsoft.com/office/powerpoint/2010/main" val="1655453239"/>
+        <p14:creationId xmlns:p14="http://schemas.microsoft.com/office/powerpoint/2010/main" val="898320263"/>
       </p:ext>
     </p:extLst>
   </p:cSld>
@@ -20748,7 +20748,7 @@
           <p:cNvPr id="11" name="">
             <a:extLst xmlns:a="http://schemas.openxmlformats.org/drawingml/2006/main">
               <a:ext uri="{FF2B5EF4-FFF2-40B4-BE49-F238E27FC236}">
-                <a16:creationId xmlns:a16="http://schemas.microsoft.com/office/drawing/2014/main" id="{3FAB4588-1399-448D-BF1E-B8D0DF124CC6}"/>
+                <a16:creationId xmlns:a16="http://schemas.microsoft.com/office/drawing/2014/main" id="{FADF3BDF-9820-4AB5-BC95-4E86D6349479}"/>
               </a:ext>
             </a:extLst>
           </p:cNvPr>
@@ -20805,7 +20805,7 @@
           <p:cNvPr id="2" name="">
             <a:extLst xmlns:a="http://schemas.openxmlformats.org/drawingml/2006/main">
               <a:ext uri="{FF2B5EF4-FFF2-40B4-BE49-F238E27FC236}">
-                <a16:creationId xmlns:a16="http://schemas.microsoft.com/office/drawing/2014/main" id="{F68C9CFD-0622-4F8F-907E-E880C0E0A0B5}"/>
+                <a16:creationId xmlns:a16="http://schemas.microsoft.com/office/drawing/2014/main" id="{6DE09453-F502-4E07-A8A9-0D653546FB94}"/>
               </a:ext>
             </a:extLst>
           </p:cNvPr>
@@ -20862,7 +20862,7 @@
           <p:cNvPr id="3" name="">
             <a:extLst xmlns:a="http://schemas.openxmlformats.org/drawingml/2006/main">
               <a:ext uri="{FF2B5EF4-FFF2-40B4-BE49-F238E27FC236}">
-                <a16:creationId xmlns:a16="http://schemas.microsoft.com/office/drawing/2014/main" id="{80FA2B86-0A69-4432-9A03-6AF2CAF6698C}"/>
+                <a16:creationId xmlns:a16="http://schemas.microsoft.com/office/drawing/2014/main" id="{3088B271-3270-4B22-AE8E-9F8D87EBE83E}"/>
               </a:ext>
             </a:extLst>
           </p:cNvPr>
@@ -20919,7 +20919,7 @@
           <p:cNvPr id="4" name="">
             <a:extLst xmlns:a="http://schemas.openxmlformats.org/drawingml/2006/main">
               <a:ext uri="{FF2B5EF4-FFF2-40B4-BE49-F238E27FC236}">
-                <a16:creationId xmlns:a16="http://schemas.microsoft.com/office/drawing/2014/main" id="{087480A9-F5A5-466A-8959-A3D742A03ACE}"/>
+                <a16:creationId xmlns:a16="http://schemas.microsoft.com/office/drawing/2014/main" id="{229835C2-9B86-424C-8692-E44973C4D09B}"/>
               </a:ext>
             </a:extLst>
           </p:cNvPr>
@@ -20976,7 +20976,7 @@
           <p:cNvPr id="5" name="">
             <a:extLst xmlns:a="http://schemas.openxmlformats.org/drawingml/2006/main">
               <a:ext uri="{FF2B5EF4-FFF2-40B4-BE49-F238E27FC236}">
-                <a16:creationId xmlns:a16="http://schemas.microsoft.com/office/drawing/2014/main" id="{52408504-C5DF-492A-A7C3-CB8AC514A5B8}"/>
+                <a16:creationId xmlns:a16="http://schemas.microsoft.com/office/drawing/2014/main" id="{66E41CC2-DD03-4FAB-B684-884D3AD0EC32}"/>
               </a:ext>
             </a:extLst>
           </p:cNvPr>
@@ -21033,7 +21033,7 @@
           <p:cNvPr id="6" name="">
             <a:extLst xmlns:a="http://schemas.openxmlformats.org/drawingml/2006/main">
               <a:ext uri="{FF2B5EF4-FFF2-40B4-BE49-F238E27FC236}">
-                <a16:creationId xmlns:a16="http://schemas.microsoft.com/office/drawing/2014/main" id="{24DCCEBA-2856-4169-ACDB-01791C511B72}"/>
+                <a16:creationId xmlns:a16="http://schemas.microsoft.com/office/drawing/2014/main" id="{2537ED93-E6BE-4BB3-B0B5-E7135137B814}"/>
               </a:ext>
             </a:extLst>
           </p:cNvPr>
@@ -21090,7 +21090,7 @@
           <p:cNvPr id="7" name="">
             <a:extLst xmlns:a="http://schemas.openxmlformats.org/drawingml/2006/main">
               <a:ext uri="{FF2B5EF4-FFF2-40B4-BE49-F238E27FC236}">
-                <a16:creationId xmlns:a16="http://schemas.microsoft.com/office/drawing/2014/main" id="{09304CD9-BF5E-4D05-93D8-56C8FDDD6105}"/>
+                <a16:creationId xmlns:a16="http://schemas.microsoft.com/office/drawing/2014/main" id="{AEB7D1F3-A465-4B64-8364-6DB1F89E625A}"/>
               </a:ext>
             </a:extLst>
           </p:cNvPr>
@@ -21147,7 +21147,7 @@
           <p:cNvPr id="8" name="">
             <a:extLst xmlns:a="http://schemas.openxmlformats.org/drawingml/2006/main">
               <a:ext uri="{FF2B5EF4-FFF2-40B4-BE49-F238E27FC236}">
-                <a16:creationId xmlns:a16="http://schemas.microsoft.com/office/drawing/2014/main" id="{41DC650A-2139-4207-BE4F-09CC51AF20AA}"/>
+                <a16:creationId xmlns:a16="http://schemas.microsoft.com/office/drawing/2014/main" id="{B2A325B5-1267-4049-B4F4-2A7A2C140FDC}"/>
               </a:ext>
             </a:extLst>
           </p:cNvPr>
@@ -21193,7 +21193,7 @@
                 <a:latin typeface="Helvetica Neue"/>
                 <a:ea typeface="Helvetica Neue"/>
                 <a:cs typeface="Helvetica Neue"/>
-                <a:hlinkClick xmlns:r="http://schemas.openxmlformats.org/officeDocument/2006/relationships" r:id="R66cce8a46bda43a2"/>
+                <a:hlinkClick xmlns:r="http://schemas.openxmlformats.org/officeDocument/2006/relationships" r:id="R9304901a93284d63"/>
               </a:rPr>
               <a:t>Public source and demo evidence</a:t>
             </a:r>
@@ -21205,7 +21205,7 @@
           <p:cNvPr id="9" name="">
             <a:extLst xmlns:a="http://schemas.openxmlformats.org/drawingml/2006/main">
               <a:ext uri="{FF2B5EF4-FFF2-40B4-BE49-F238E27FC236}">
-                <a16:creationId xmlns:a16="http://schemas.microsoft.com/office/drawing/2014/main" id="{2E2D3867-B2DF-4DAC-9159-34C581D726D9}"/>
+                <a16:creationId xmlns:a16="http://schemas.microsoft.com/office/drawing/2014/main" id="{C57EBADA-D817-4D18-9B45-8E09BA4F50FF}"/>
               </a:ext>
             </a:extLst>
           </p:cNvPr>
@@ -21251,7 +21251,7 @@
                 <a:latin typeface="Helvetica Neue"/>
                 <a:ea typeface="Helvetica Neue"/>
                 <a:cs typeface="Helvetica Neue"/>
-                <a:hlinkClick xmlns:r="http://schemas.openxmlformats.org/officeDocument/2006/relationships" r:id="Rc1f3cb4d6e344d47"/>
+                <a:hlinkClick xmlns:r="http://schemas.openxmlformats.org/officeDocument/2006/relationships" r:id="R061d23533dc04f6a"/>
               </a:rPr>
               <a:t>Founder LinkedIn</a:t>
             </a:r>
@@ -21263,7 +21263,7 @@
           <p:cNvPr id="10" name="">
             <a:extLst xmlns:a="http://schemas.openxmlformats.org/drawingml/2006/main">
               <a:ext uri="{FF2B5EF4-FFF2-40B4-BE49-F238E27FC236}">
-                <a16:creationId xmlns:a16="http://schemas.microsoft.com/office/drawing/2014/main" id="{C85ACB8D-F6B6-4C7A-A850-820657C9BB10}"/>
+                <a16:creationId xmlns:a16="http://schemas.microsoft.com/office/drawing/2014/main" id="{464B2C42-8196-48CB-9DE4-05A5480D3D34}"/>
               </a:ext>
             </a:extLst>
           </p:cNvPr>
@@ -21318,7 +21318,7 @@
     </p:spTree>
     <p:extLst>
       <p:ext uri="{BB962C8B-B14F-4D97-AF65-F5344CB8AC3E}">
-        <p14:creationId xmlns:p14="http://schemas.microsoft.com/office/powerpoint/2010/main" val="1430085033"/>
+        <p14:creationId xmlns:p14="http://schemas.microsoft.com/office/powerpoint/2010/main" val="749977684"/>
       </p:ext>
     </p:extLst>
   </p:cSld>
@@ -21349,7 +21349,7 @@
           <p:cNvPr id="9" name="">
             <a:extLst xmlns:a="http://schemas.openxmlformats.org/drawingml/2006/main">
               <a:ext uri="{FF2B5EF4-FFF2-40B4-BE49-F238E27FC236}">
-                <a16:creationId xmlns:a16="http://schemas.microsoft.com/office/drawing/2014/main" id="{DC3245B4-B5F3-4B2F-B948-66244009E71B}"/>
+                <a16:creationId xmlns:a16="http://schemas.microsoft.com/office/drawing/2014/main" id="{437F3121-3661-40F0-AD92-5B77DBCB1486}"/>
               </a:ext>
             </a:extLst>
           </p:cNvPr>
@@ -21406,7 +21406,7 @@
           <p:cNvPr id="2" name="">
             <a:extLst xmlns:a="http://schemas.openxmlformats.org/drawingml/2006/main">
               <a:ext uri="{FF2B5EF4-FFF2-40B4-BE49-F238E27FC236}">
-                <a16:creationId xmlns:a16="http://schemas.microsoft.com/office/drawing/2014/main" id="{2B3D2EFC-B6F8-4E3B-9B2A-28770D02754F}"/>
+                <a16:creationId xmlns:a16="http://schemas.microsoft.com/office/drawing/2014/main" id="{B0CAD016-175B-45C8-BC3A-E3BFE266AB23}"/>
               </a:ext>
             </a:extLst>
           </p:cNvPr>
@@ -21463,7 +21463,7 @@
           <p:cNvPr id="3" name="">
             <a:extLst xmlns:a="http://schemas.openxmlformats.org/drawingml/2006/main">
               <a:ext uri="{FF2B5EF4-FFF2-40B4-BE49-F238E27FC236}">
-                <a16:creationId xmlns:a16="http://schemas.microsoft.com/office/drawing/2014/main" id="{3C571798-00AD-4907-8A66-DA03BFB03F6F}"/>
+                <a16:creationId xmlns:a16="http://schemas.microsoft.com/office/drawing/2014/main" id="{AB7EF3AC-9F9E-4BE9-A4F0-7941B7990B11}"/>
               </a:ext>
             </a:extLst>
           </p:cNvPr>
@@ -21509,7 +21509,7 @@
                 <a:latin typeface="Helvetica Neue"/>
                 <a:ea typeface="Helvetica Neue"/>
                 <a:cs typeface="Helvetica Neue"/>
-                <a:hlinkClick xmlns:r="http://schemas.openxmlformats.org/officeDocument/2006/relationships" r:id="R6809472a04db475e"/>
+                <a:hlinkClick xmlns:r="http://schemas.openxmlformats.org/officeDocument/2006/relationships" r:id="Rb6bf178852da4567"/>
               </a:rPr>
               <a:t>Public blockchain source and marketplace</a:t>
             </a:r>
@@ -21521,7 +21521,7 @@
           <p:cNvPr id="4" name="">
             <a:extLst xmlns:a="http://schemas.openxmlformats.org/drawingml/2006/main">
               <a:ext uri="{FF2B5EF4-FFF2-40B4-BE49-F238E27FC236}">
-                <a16:creationId xmlns:a16="http://schemas.microsoft.com/office/drawing/2014/main" id="{C1DAE1D0-820A-492F-9CCA-60BE38937E2F}"/>
+                <a16:creationId xmlns:a16="http://schemas.microsoft.com/office/drawing/2014/main" id="{DA95B57D-FBBB-4AD2-A96B-01E337CA6BA1}"/>
               </a:ext>
             </a:extLst>
           </p:cNvPr>
@@ -21567,7 +21567,7 @@
                 <a:latin typeface="Helvetica Neue"/>
                 <a:ea typeface="Helvetica Neue"/>
                 <a:cs typeface="Helvetica Neue"/>
-                <a:hlinkClick xmlns:r="http://schemas.openxmlformats.org/officeDocument/2006/relationships" r:id="Rbd0740c68e944ad1"/>
+                <a:hlinkClick xmlns:r="http://schemas.openxmlformats.org/officeDocument/2006/relationships" r:id="Rfabeb4fcfa734294"/>
               </a:rPr>
               <a:t>Verification: 176 passing tests</a:t>
             </a:r>
@@ -21579,7 +21579,7 @@
           <p:cNvPr id="5" name="">
             <a:extLst xmlns:a="http://schemas.openxmlformats.org/drawingml/2006/main">
               <a:ext uri="{FF2B5EF4-FFF2-40B4-BE49-F238E27FC236}">
-                <a16:creationId xmlns:a16="http://schemas.microsoft.com/office/drawing/2014/main" id="{78D4E5ED-EAD9-46BA-B027-EA7C65128FF1}"/>
+                <a16:creationId xmlns:a16="http://schemas.microsoft.com/office/drawing/2014/main" id="{C9B7250A-DC6E-4FB7-BCB0-9F3FCA9F0D0D}"/>
               </a:ext>
             </a:extLst>
           </p:cNvPr>
@@ -21625,7 +21625,7 @@
                 <a:latin typeface="Helvetica Neue"/>
                 <a:ea typeface="Helvetica Neue"/>
                 <a:cs typeface="Helvetica Neue"/>
-                <a:hlinkClick xmlns:r="http://schemas.openxmlformats.org/officeDocument/2006/relationships" r:id="Rc18349b279f74bf2"/>
+                <a:hlinkClick xmlns:r="http://schemas.openxmlformats.org/officeDocument/2006/relationships" r:id="Rf919ac3ea1ef4007"/>
               </a:rPr>
               <a:t>Demo record and transaction references</a:t>
             </a:r>
@@ -21637,7 +21637,7 @@
           <p:cNvPr id="6" name="">
             <a:extLst xmlns:a="http://schemas.openxmlformats.org/drawingml/2006/main">
               <a:ext uri="{FF2B5EF4-FFF2-40B4-BE49-F238E27FC236}">
-                <a16:creationId xmlns:a16="http://schemas.microsoft.com/office/drawing/2014/main" id="{D1D572D4-7843-4170-9E06-550C0DC6F607}"/>
+                <a16:creationId xmlns:a16="http://schemas.microsoft.com/office/drawing/2014/main" id="{91282931-7C84-4B5C-B358-C88AC0390D80}"/>
               </a:ext>
             </a:extLst>
           </p:cNvPr>
@@ -21683,7 +21683,7 @@
                 <a:latin typeface="Helvetica Neue"/>
                 <a:ea typeface="Helvetica Neue"/>
                 <a:cs typeface="Helvetica Neue"/>
-                <a:hlinkClick xmlns:r="http://schemas.openxmlformats.org/officeDocument/2006/relationships" r:id="Reb55d366bb6d4f8f"/>
+                <a:hlinkClick xmlns:r="http://schemas.openxmlformats.org/officeDocument/2006/relationships" r:id="R55335c7f9577449b"/>
               </a:rPr>
               <a:t>Recorded MetaMask purchase and digital delivery</a:t>
             </a:r>
@@ -21695,7 +21695,7 @@
           <p:cNvPr id="7" name="">
             <a:extLst xmlns:a="http://schemas.openxmlformats.org/drawingml/2006/main">
               <a:ext uri="{FF2B5EF4-FFF2-40B4-BE49-F238E27FC236}">
-                <a16:creationId xmlns:a16="http://schemas.microsoft.com/office/drawing/2014/main" id="{D30FC787-F2EE-42D7-B41F-A62BD11C1D66}"/>
+                <a16:creationId xmlns:a16="http://schemas.microsoft.com/office/drawing/2014/main" id="{AB01FE59-8959-4301-A4FD-E0CE03BD8F6D}"/>
               </a:ext>
             </a:extLst>
           </p:cNvPr>
@@ -21741,7 +21741,7 @@
                 <a:latin typeface="Helvetica Neue"/>
                 <a:ea typeface="Helvetica Neue"/>
                 <a:cs typeface="Helvetica Neue"/>
-                <a:hlinkClick xmlns:r="http://schemas.openxmlformats.org/officeDocument/2006/relationships" r:id="R3ccfad618edd4e30"/>
+                <a:hlinkClick xmlns:r="http://schemas.openxmlformats.org/officeDocument/2006/relationships" r:id="R2297e50056894df7"/>
               </a:rPr>
               <a:t>Founder: Vitalii Pavlichuk</a:t>
             </a:r>
@@ -21753,7 +21753,7 @@
           <p:cNvPr id="8" name="">
             <a:extLst xmlns:a="http://schemas.openxmlformats.org/drawingml/2006/main">
               <a:ext uri="{FF2B5EF4-FFF2-40B4-BE49-F238E27FC236}">
-                <a16:creationId xmlns:a16="http://schemas.microsoft.com/office/drawing/2014/main" id="{EF043A0D-3413-46F8-A27E-065547B1DDA3}"/>
+                <a16:creationId xmlns:a16="http://schemas.microsoft.com/office/drawing/2014/main" id="{F17A4151-B2D4-4028-9B28-022C304DC04F}"/>
               </a:ext>
             </a:extLst>
           </p:cNvPr>
@@ -21808,7 +21808,7 @@
     </p:spTree>
     <p:extLst>
       <p:ext uri="{BB962C8B-B14F-4D97-AF65-F5344CB8AC3E}">
-        <p14:creationId xmlns:p14="http://schemas.microsoft.com/office/powerpoint/2010/main" val="413525342"/>
+        <p14:creationId xmlns:p14="http://schemas.microsoft.com/office/powerpoint/2010/main" val="1339561645"/>
       </p:ext>
     </p:extLst>
   </p:cSld>
@@ -21839,7 +21839,7 @@
           <p:cNvPr id="9" name="">
             <a:extLst xmlns:a="http://schemas.openxmlformats.org/drawingml/2006/main">
               <a:ext uri="{FF2B5EF4-FFF2-40B4-BE49-F238E27FC236}">
-                <a16:creationId xmlns:a16="http://schemas.microsoft.com/office/drawing/2014/main" id="{206FCE22-D9B2-4A5B-B59E-9B63B8F971E6}"/>
+                <a16:creationId xmlns:a16="http://schemas.microsoft.com/office/drawing/2014/main" id="{E04F94F0-3E3C-4904-B51C-CAFA52C7A1A6}"/>
               </a:ext>
             </a:extLst>
           </p:cNvPr>
@@ -21896,7 +21896,7 @@
           <p:cNvPr id="2" name="">
             <a:extLst xmlns:a="http://schemas.openxmlformats.org/drawingml/2006/main">
               <a:ext uri="{FF2B5EF4-FFF2-40B4-BE49-F238E27FC236}">
-                <a16:creationId xmlns:a16="http://schemas.microsoft.com/office/drawing/2014/main" id="{9E0FB635-41DD-4E75-A3DF-59772EE86078}"/>
+                <a16:creationId xmlns:a16="http://schemas.microsoft.com/office/drawing/2014/main" id="{0CD95E0B-00BA-40F7-9863-3EC4FE2E7016}"/>
               </a:ext>
             </a:extLst>
           </p:cNvPr>
@@ -21953,7 +21953,7 @@
           <p:cNvPr id="3" name="">
             <a:extLst xmlns:a="http://schemas.openxmlformats.org/drawingml/2006/main">
               <a:ext uri="{FF2B5EF4-FFF2-40B4-BE49-F238E27FC236}">
-                <a16:creationId xmlns:a16="http://schemas.microsoft.com/office/drawing/2014/main" id="{DA580CD5-C115-42D3-8464-274CEB914894}"/>
+                <a16:creationId xmlns:a16="http://schemas.microsoft.com/office/drawing/2014/main" id="{FBB2D9BA-B546-40A5-BBC3-334372A0F4B6}"/>
               </a:ext>
             </a:extLst>
           </p:cNvPr>
@@ -22010,7 +22010,7 @@
           <p:cNvPr id="4" name="">
             <a:extLst xmlns:a="http://schemas.openxmlformats.org/drawingml/2006/main">
               <a:ext uri="{FF2B5EF4-FFF2-40B4-BE49-F238E27FC236}">
-                <a16:creationId xmlns:a16="http://schemas.microsoft.com/office/drawing/2014/main" id="{6A1A5B57-8865-4979-B8CB-2F8B7BC48537}"/>
+                <a16:creationId xmlns:a16="http://schemas.microsoft.com/office/drawing/2014/main" id="{3A8BEFAA-4259-4FB4-8F72-6EE4E96875E9}"/>
               </a:ext>
             </a:extLst>
           </p:cNvPr>
@@ -22067,7 +22067,7 @@
           <p:cNvPr id="5" name="">
             <a:extLst xmlns:a="http://schemas.openxmlformats.org/drawingml/2006/main">
               <a:ext uri="{FF2B5EF4-FFF2-40B4-BE49-F238E27FC236}">
-                <a16:creationId xmlns:a16="http://schemas.microsoft.com/office/drawing/2014/main" id="{8F8D728C-ADE4-41C5-AD5A-0E99CF9275A7}"/>
+                <a16:creationId xmlns:a16="http://schemas.microsoft.com/office/drawing/2014/main" id="{54911CBE-C914-43DE-805D-5EBC497AB5F6}"/>
               </a:ext>
             </a:extLst>
           </p:cNvPr>
@@ -22124,7 +22124,7 @@
           <p:cNvPr id="6" name="">
             <a:extLst xmlns:a="http://schemas.openxmlformats.org/drawingml/2006/main">
               <a:ext uri="{FF2B5EF4-FFF2-40B4-BE49-F238E27FC236}">
-                <a16:creationId xmlns:a16="http://schemas.microsoft.com/office/drawing/2014/main" id="{AC6D3A1E-0170-47CD-A15E-F22ED6AC1D62}"/>
+                <a16:creationId xmlns:a16="http://schemas.microsoft.com/office/drawing/2014/main" id="{D2657BAE-A255-4104-B81D-BA5D8847DEAB}"/>
               </a:ext>
             </a:extLst>
           </p:cNvPr>
@@ -22181,7 +22181,7 @@
           <p:cNvPr id="7" name="">
             <a:extLst xmlns:a="http://schemas.openxmlformats.org/drawingml/2006/main">
               <a:ext uri="{FF2B5EF4-FFF2-40B4-BE49-F238E27FC236}">
-                <a16:creationId xmlns:a16="http://schemas.microsoft.com/office/drawing/2014/main" id="{A907880E-F9C8-4A4A-A7BB-E0D18BC5AB58}"/>
+                <a16:creationId xmlns:a16="http://schemas.microsoft.com/office/drawing/2014/main" id="{053B58CE-D429-4835-BF47-910FE1A53466}"/>
               </a:ext>
             </a:extLst>
           </p:cNvPr>
@@ -22238,7 +22238,7 @@
           <p:cNvPr id="8" name="">
             <a:extLst xmlns:a="http://schemas.openxmlformats.org/drawingml/2006/main">
               <a:ext uri="{FF2B5EF4-FFF2-40B4-BE49-F238E27FC236}">
-                <a16:creationId xmlns:a16="http://schemas.microsoft.com/office/drawing/2014/main" id="{2E7D8A6E-A309-45AE-8CE2-3A9D895C1E4E}"/>
+                <a16:creationId xmlns:a16="http://schemas.microsoft.com/office/drawing/2014/main" id="{69049B07-3AB3-409A-BC66-FCFCE6512A73}"/>
               </a:ext>
             </a:extLst>
           </p:cNvPr>
@@ -22284,7 +22284,7 @@
                 <a:latin typeface="Helvetica Neue"/>
                 <a:ea typeface="Helvetica Neue"/>
                 <a:cs typeface="Helvetica Neue"/>
-                <a:hlinkClick xmlns:r="http://schemas.openxmlformats.org/officeDocument/2006/relationships" r:id="R8b13d22abdb145fd"/>
+                <a:hlinkClick xmlns:r="http://schemas.openxmlformats.org/officeDocument/2006/relationships" r:id="R36f13f516b6b45ab"/>
               </a:rPr>
               <a:t>Reference: @anabology’s production example</a:t>
             </a:r>
@@ -22294,7 +22294,7 @@
     </p:spTree>
     <p:extLst>
       <p:ext uri="{BB962C8B-B14F-4D97-AF65-F5344CB8AC3E}">
-        <p14:creationId xmlns:p14="http://schemas.microsoft.com/office/powerpoint/2010/main" val="291159363"/>
+        <p14:creationId xmlns:p14="http://schemas.microsoft.com/office/powerpoint/2010/main" val="433348127"/>
       </p:ext>
     </p:extLst>
   </p:cSld>
@@ -22325,7 +22325,7 @@
           <p:cNvPr id="11" name="">
             <a:extLst xmlns:a="http://schemas.openxmlformats.org/drawingml/2006/main">
               <a:ext uri="{FF2B5EF4-FFF2-40B4-BE49-F238E27FC236}">
-                <a16:creationId xmlns:a16="http://schemas.microsoft.com/office/drawing/2014/main" id="{2067FA32-CDF5-4DE7-A531-8038F37F019F}"/>
+                <a16:creationId xmlns:a16="http://schemas.microsoft.com/office/drawing/2014/main" id="{C7FF4D94-F0C6-41D9-8ECC-0CCF357FB97E}"/>
               </a:ext>
             </a:extLst>
           </p:cNvPr>
@@ -22382,7 +22382,7 @@
           <p:cNvPr id="2" name="">
             <a:extLst xmlns:a="http://schemas.openxmlformats.org/drawingml/2006/main">
               <a:ext uri="{FF2B5EF4-FFF2-40B4-BE49-F238E27FC236}">
-                <a16:creationId xmlns:a16="http://schemas.microsoft.com/office/drawing/2014/main" id="{A002FD14-DB2D-4C45-A6CD-F08227A8BC88}"/>
+                <a16:creationId xmlns:a16="http://schemas.microsoft.com/office/drawing/2014/main" id="{27C6CBD0-57D3-4B4D-B0C4-E399B372F103}"/>
               </a:ext>
             </a:extLst>
           </p:cNvPr>
@@ -22439,7 +22439,7 @@
           <p:cNvPr id="3" name="">
             <a:extLst xmlns:a="http://schemas.openxmlformats.org/drawingml/2006/main">
               <a:ext uri="{FF2B5EF4-FFF2-40B4-BE49-F238E27FC236}">
-                <a16:creationId xmlns:a16="http://schemas.microsoft.com/office/drawing/2014/main" id="{5C4D6A84-EADE-4FB2-8D43-BFAB52A426D0}"/>
+                <a16:creationId xmlns:a16="http://schemas.microsoft.com/office/drawing/2014/main" id="{0C1A4AEC-E4DE-43FC-8081-6E2DF592FBDA}"/>
               </a:ext>
             </a:extLst>
           </p:cNvPr>
@@ -22496,7 +22496,7 @@
           <p:cNvPr id="4" name="">
             <a:extLst xmlns:a="http://schemas.openxmlformats.org/drawingml/2006/main">
               <a:ext uri="{FF2B5EF4-FFF2-40B4-BE49-F238E27FC236}">
-                <a16:creationId xmlns:a16="http://schemas.microsoft.com/office/drawing/2014/main" id="{1070C1A2-6E00-4D19-8DFC-68614D63AD63}"/>
+                <a16:creationId xmlns:a16="http://schemas.microsoft.com/office/drawing/2014/main" id="{F62B308B-B725-44A8-9FD6-AC0BAF9D6B80}"/>
               </a:ext>
             </a:extLst>
           </p:cNvPr>
@@ -22553,7 +22553,7 @@
           <p:cNvPr id="5" name="">
             <a:extLst xmlns:a="http://schemas.openxmlformats.org/drawingml/2006/main">
               <a:ext uri="{FF2B5EF4-FFF2-40B4-BE49-F238E27FC236}">
-                <a16:creationId xmlns:a16="http://schemas.microsoft.com/office/drawing/2014/main" id="{C0C5BC61-3696-4A1F-A72A-6AE2D68B9919}"/>
+                <a16:creationId xmlns:a16="http://schemas.microsoft.com/office/drawing/2014/main" id="{3C5E4E76-46BB-4EB0-B64F-B14C99F516FE}"/>
               </a:ext>
             </a:extLst>
           </p:cNvPr>
@@ -22610,7 +22610,7 @@
           <p:cNvPr id="6" name="">
             <a:extLst xmlns:a="http://schemas.openxmlformats.org/drawingml/2006/main">
               <a:ext uri="{FF2B5EF4-FFF2-40B4-BE49-F238E27FC236}">
-                <a16:creationId xmlns:a16="http://schemas.microsoft.com/office/drawing/2014/main" id="{4E242727-10F5-4432-BCC3-AA9E12F84E42}"/>
+                <a16:creationId xmlns:a16="http://schemas.microsoft.com/office/drawing/2014/main" id="{3F0E6F1C-CCF7-443B-B43D-6F9C5E8DE320}"/>
               </a:ext>
             </a:extLst>
           </p:cNvPr>
@@ -22667,7 +22667,7 @@
           <p:cNvPr id="7" name="">
             <a:extLst xmlns:a="http://schemas.openxmlformats.org/drawingml/2006/main">
               <a:ext uri="{FF2B5EF4-FFF2-40B4-BE49-F238E27FC236}">
-                <a16:creationId xmlns:a16="http://schemas.microsoft.com/office/drawing/2014/main" id="{689291D5-388D-4C09-A864-4F89E9F074AF}"/>
+                <a16:creationId xmlns:a16="http://schemas.microsoft.com/office/drawing/2014/main" id="{A971C0D1-2453-4AAE-987C-CDC136A4D59A}"/>
               </a:ext>
             </a:extLst>
           </p:cNvPr>
@@ -22724,7 +22724,7 @@
           <p:cNvPr id="8" name="">
             <a:extLst xmlns:a="http://schemas.openxmlformats.org/drawingml/2006/main">
               <a:ext uri="{FF2B5EF4-FFF2-40B4-BE49-F238E27FC236}">
-                <a16:creationId xmlns:a16="http://schemas.microsoft.com/office/drawing/2014/main" id="{3604AECB-30DB-4586-8F0E-94A803BADCD2}"/>
+                <a16:creationId xmlns:a16="http://schemas.microsoft.com/office/drawing/2014/main" id="{15FB1326-260D-4DD6-98FB-96F2509BF68D}"/>
               </a:ext>
             </a:extLst>
           </p:cNvPr>
@@ -22781,7 +22781,7 @@
           <p:cNvPr id="9" name="">
             <a:extLst xmlns:a="http://schemas.openxmlformats.org/drawingml/2006/main">
               <a:ext uri="{FF2B5EF4-FFF2-40B4-BE49-F238E27FC236}">
-                <a16:creationId xmlns:a16="http://schemas.microsoft.com/office/drawing/2014/main" id="{5857A2DF-616B-48C3-B249-19B959E202A7}"/>
+                <a16:creationId xmlns:a16="http://schemas.microsoft.com/office/drawing/2014/main" id="{E186E3F0-83FE-42D1-AE4E-943F3EC6711B}"/>
               </a:ext>
             </a:extLst>
           </p:cNvPr>
@@ -22838,7 +22838,7 @@
           <p:cNvPr id="10" name="">
             <a:extLst xmlns:a="http://schemas.openxmlformats.org/drawingml/2006/main">
               <a:ext uri="{FF2B5EF4-FFF2-40B4-BE49-F238E27FC236}">
-                <a16:creationId xmlns:a16="http://schemas.microsoft.com/office/drawing/2014/main" id="{FB433618-EF09-4419-B51D-691C588123E1}"/>
+                <a16:creationId xmlns:a16="http://schemas.microsoft.com/office/drawing/2014/main" id="{DF70B5B5-ADF1-4903-A0CD-F273EE733314}"/>
               </a:ext>
             </a:extLst>
           </p:cNvPr>
@@ -22893,7 +22893,7 @@
     </p:spTree>
     <p:extLst>
       <p:ext uri="{BB962C8B-B14F-4D97-AF65-F5344CB8AC3E}">
-        <p14:creationId xmlns:p14="http://schemas.microsoft.com/office/powerpoint/2010/main" val="136118227"/>
+        <p14:creationId xmlns:p14="http://schemas.microsoft.com/office/powerpoint/2010/main" val="2125940654"/>
       </p:ext>
     </p:extLst>
   </p:cSld>
@@ -22924,7 +22924,7 @@
           <p:cNvPr id="16" name="">
             <a:extLst xmlns:a="http://schemas.openxmlformats.org/drawingml/2006/main">
               <a:ext uri="{FF2B5EF4-FFF2-40B4-BE49-F238E27FC236}">
-                <a16:creationId xmlns:a16="http://schemas.microsoft.com/office/drawing/2014/main" id="{C21BA277-F6DF-4F66-AE6E-33AAA959970C}"/>
+                <a16:creationId xmlns:a16="http://schemas.microsoft.com/office/drawing/2014/main" id="{9FAD9429-81DD-4D0C-B26A-C35F2D868EE1}"/>
               </a:ext>
             </a:extLst>
           </p:cNvPr>
@@ -22981,7 +22981,7 @@
           <p:cNvPr id="2" name="">
             <a:extLst xmlns:a="http://schemas.openxmlformats.org/drawingml/2006/main">
               <a:ext uri="{FF2B5EF4-FFF2-40B4-BE49-F238E27FC236}">
-                <a16:creationId xmlns:a16="http://schemas.microsoft.com/office/drawing/2014/main" id="{71807085-4F0A-4235-A3A4-81EC22861A61}"/>
+                <a16:creationId xmlns:a16="http://schemas.microsoft.com/office/drawing/2014/main" id="{F9131257-8158-493F-9BE4-6D9B77CDBEF6}"/>
               </a:ext>
             </a:extLst>
           </p:cNvPr>
@@ -23038,7 +23038,7 @@
           <p:cNvPr id="3" name="">
             <a:extLst xmlns:a="http://schemas.openxmlformats.org/drawingml/2006/main">
               <a:ext uri="{FF2B5EF4-FFF2-40B4-BE49-F238E27FC236}">
-                <a16:creationId xmlns:a16="http://schemas.microsoft.com/office/drawing/2014/main" id="{080C4BFB-C14F-4F62-B394-3DB3FBBF8172}"/>
+                <a16:creationId xmlns:a16="http://schemas.microsoft.com/office/drawing/2014/main" id="{91C3E161-DABF-494B-877F-BFFDC477D88D}"/>
               </a:ext>
             </a:extLst>
           </p:cNvPr>
@@ -23099,7 +23099,7 @@
           <p:cNvPr id="4" name="">
             <a:extLst xmlns:a="http://schemas.openxmlformats.org/drawingml/2006/main">
               <a:ext uri="{FF2B5EF4-FFF2-40B4-BE49-F238E27FC236}">
-                <a16:creationId xmlns:a16="http://schemas.microsoft.com/office/drawing/2014/main" id="{AA332E96-D4A0-4C6A-B9A7-167668B7EBB2}"/>
+                <a16:creationId xmlns:a16="http://schemas.microsoft.com/office/drawing/2014/main" id="{FF7637E9-BC82-40E1-BE20-D0321E7D9172}"/>
               </a:ext>
             </a:extLst>
           </p:cNvPr>
@@ -23160,7 +23160,7 @@
           <p:cNvPr id="5" name="">
             <a:extLst xmlns:a="http://schemas.openxmlformats.org/drawingml/2006/main">
               <a:ext uri="{FF2B5EF4-FFF2-40B4-BE49-F238E27FC236}">
-                <a16:creationId xmlns:a16="http://schemas.microsoft.com/office/drawing/2014/main" id="{27B606DC-AFC2-40DE-9837-0932895EB2BA}"/>
+                <a16:creationId xmlns:a16="http://schemas.microsoft.com/office/drawing/2014/main" id="{0EB8EA88-1EC8-4B81-85E0-C4D4A5F14893}"/>
               </a:ext>
             </a:extLst>
           </p:cNvPr>
@@ -23221,7 +23221,7 @@
           <p:cNvPr id="6" name="">
             <a:extLst xmlns:a="http://schemas.openxmlformats.org/drawingml/2006/main">
               <a:ext uri="{FF2B5EF4-FFF2-40B4-BE49-F238E27FC236}">
-                <a16:creationId xmlns:a16="http://schemas.microsoft.com/office/drawing/2014/main" id="{EDA83D1F-8FA0-4471-93B2-1F4D506EB8A6}"/>
+                <a16:creationId xmlns:a16="http://schemas.microsoft.com/office/drawing/2014/main" id="{77C580AF-E6A5-49E2-9C0D-E998662C063B}"/>
               </a:ext>
             </a:extLst>
           </p:cNvPr>
@@ -23282,7 +23282,7 @@
           <p:cNvPr id="7" name="">
             <a:extLst xmlns:a="http://schemas.openxmlformats.org/drawingml/2006/main">
               <a:ext uri="{FF2B5EF4-FFF2-40B4-BE49-F238E27FC236}">
-                <a16:creationId xmlns:a16="http://schemas.microsoft.com/office/drawing/2014/main" id="{3784BF7E-FFF5-41C8-961A-E09A53C61092}"/>
+                <a16:creationId xmlns:a16="http://schemas.microsoft.com/office/drawing/2014/main" id="{534DFBBB-40BC-45A0-BDC3-2DC6A9BB3235}"/>
               </a:ext>
             </a:extLst>
           </p:cNvPr>
@@ -23343,7 +23343,7 @@
           <p:cNvPr id="8" name="">
             <a:extLst xmlns:a="http://schemas.openxmlformats.org/drawingml/2006/main">
               <a:ext uri="{FF2B5EF4-FFF2-40B4-BE49-F238E27FC236}">
-                <a16:creationId xmlns:a16="http://schemas.microsoft.com/office/drawing/2014/main" id="{E4E17BEE-2818-4B61-AEC5-0A25B54FD6C9}"/>
+                <a16:creationId xmlns:a16="http://schemas.microsoft.com/office/drawing/2014/main" id="{8E0A0D4E-AB82-44C6-8ED6-205971B57C25}"/>
               </a:ext>
             </a:extLst>
           </p:cNvPr>
@@ -23554,7 +23554,7 @@
           <p:cNvPr id="15" name="">
             <a:extLst xmlns:a="http://schemas.openxmlformats.org/drawingml/2006/main">
               <a:ext uri="{FF2B5EF4-FFF2-40B4-BE49-F238E27FC236}">
-                <a16:creationId xmlns:a16="http://schemas.microsoft.com/office/drawing/2014/main" id="{CAD173FE-7BA1-4629-A721-7FBA766CC2B2}"/>
+                <a16:creationId xmlns:a16="http://schemas.microsoft.com/office/drawing/2014/main" id="{94F81ACB-A560-46B9-BF19-038C27444D56}"/>
               </a:ext>
             </a:extLst>
           </p:cNvPr>
@@ -23609,7 +23609,7 @@
     </p:spTree>
     <p:extLst>
       <p:ext uri="{BB962C8B-B14F-4D97-AF65-F5344CB8AC3E}">
-        <p14:creationId xmlns:p14="http://schemas.microsoft.com/office/powerpoint/2010/main" val="663153277"/>
+        <p14:creationId xmlns:p14="http://schemas.microsoft.com/office/powerpoint/2010/main" val="1457312866"/>
       </p:ext>
     </p:extLst>
   </p:cSld>
@@ -23640,7 +23640,7 @@
           <p:cNvPr id="14" name="">
             <a:extLst xmlns:a="http://schemas.openxmlformats.org/drawingml/2006/main">
               <a:ext uri="{FF2B5EF4-FFF2-40B4-BE49-F238E27FC236}">
-                <a16:creationId xmlns:a16="http://schemas.microsoft.com/office/drawing/2014/main" id="{06A29FE0-15AE-43AE-8EE1-3EB8A2D1661C}"/>
+                <a16:creationId xmlns:a16="http://schemas.microsoft.com/office/drawing/2014/main" id="{419DEA1A-768E-42B2-A53F-92CBDD3D397B}"/>
               </a:ext>
             </a:extLst>
           </p:cNvPr>
@@ -23697,7 +23697,7 @@
           <p:cNvPr id="2" name="">
             <a:extLst xmlns:a="http://schemas.openxmlformats.org/drawingml/2006/main">
               <a:ext uri="{FF2B5EF4-FFF2-40B4-BE49-F238E27FC236}">
-                <a16:creationId xmlns:a16="http://schemas.microsoft.com/office/drawing/2014/main" id="{59F50698-2B8A-4B9B-B062-732D35CB2B4A}"/>
+                <a16:creationId xmlns:a16="http://schemas.microsoft.com/office/drawing/2014/main" id="{1AC21A92-8CC9-46C4-8C5B-CE0C7769F20C}"/>
               </a:ext>
             </a:extLst>
           </p:cNvPr>
@@ -23754,7 +23754,7 @@
           <p:cNvPr id="3" name="">
             <a:extLst xmlns:a="http://schemas.openxmlformats.org/drawingml/2006/main">
               <a:ext uri="{FF2B5EF4-FFF2-40B4-BE49-F238E27FC236}">
-                <a16:creationId xmlns:a16="http://schemas.microsoft.com/office/drawing/2014/main" id="{25BE5856-E27F-43E1-BA14-4C1753D1DA09}"/>
+                <a16:creationId xmlns:a16="http://schemas.microsoft.com/office/drawing/2014/main" id="{76033C2A-A13F-4848-911F-DBC5A5BDBFEC}"/>
               </a:ext>
             </a:extLst>
           </p:cNvPr>
@@ -23815,7 +23815,7 @@
           <p:cNvPr id="4" name="">
             <a:extLst xmlns:a="http://schemas.openxmlformats.org/drawingml/2006/main">
               <a:ext uri="{FF2B5EF4-FFF2-40B4-BE49-F238E27FC236}">
-                <a16:creationId xmlns:a16="http://schemas.microsoft.com/office/drawing/2014/main" id="{98374F0A-51A7-4900-B5C4-4CAAD69159C3}"/>
+                <a16:creationId xmlns:a16="http://schemas.microsoft.com/office/drawing/2014/main" id="{89721182-B0F8-47EA-B7A8-68972DB5E06F}"/>
               </a:ext>
             </a:extLst>
           </p:cNvPr>
@@ -23876,7 +23876,7 @@
           <p:cNvPr id="5" name="">
             <a:extLst xmlns:a="http://schemas.openxmlformats.org/drawingml/2006/main">
               <a:ext uri="{FF2B5EF4-FFF2-40B4-BE49-F238E27FC236}">
-                <a16:creationId xmlns:a16="http://schemas.microsoft.com/office/drawing/2014/main" id="{FE2CC96C-3711-4BAE-8079-4C5F396A4685}"/>
+                <a16:creationId xmlns:a16="http://schemas.microsoft.com/office/drawing/2014/main" id="{48FAACAC-7ACC-48A3-B9A2-6A0ACB23EF86}"/>
               </a:ext>
             </a:extLst>
           </p:cNvPr>
@@ -23960,7 +23960,7 @@
           <p:cNvPr id="6" name="">
             <a:extLst xmlns:a="http://schemas.openxmlformats.org/drawingml/2006/main">
               <a:ext uri="{FF2B5EF4-FFF2-40B4-BE49-F238E27FC236}">
-                <a16:creationId xmlns:a16="http://schemas.microsoft.com/office/drawing/2014/main" id="{BCD4AEAC-8D2C-4E03-B25F-9C5C74C3D2DB}"/>
+                <a16:creationId xmlns:a16="http://schemas.microsoft.com/office/drawing/2014/main" id="{41A5A348-6CA7-4164-927E-5DF68923D7EA}"/>
               </a:ext>
             </a:extLst>
           </p:cNvPr>
@@ -24044,7 +24044,7 @@
           <p:cNvPr id="7" name="">
             <a:extLst xmlns:a="http://schemas.openxmlformats.org/drawingml/2006/main">
               <a:ext uri="{FF2B5EF4-FFF2-40B4-BE49-F238E27FC236}">
-                <a16:creationId xmlns:a16="http://schemas.microsoft.com/office/drawing/2014/main" id="{6610AC47-68F7-43D4-80CD-B37D9E4BC38B}"/>
+                <a16:creationId xmlns:a16="http://schemas.microsoft.com/office/drawing/2014/main" id="{51E752C2-F722-40EE-9988-F8EF091E6330}"/>
               </a:ext>
             </a:extLst>
           </p:cNvPr>
@@ -24234,7 +24234,7 @@
           <p:cNvPr id="12" name="">
             <a:extLst xmlns:a="http://schemas.openxmlformats.org/drawingml/2006/main">
               <a:ext uri="{FF2B5EF4-FFF2-40B4-BE49-F238E27FC236}">
-                <a16:creationId xmlns:a16="http://schemas.microsoft.com/office/drawing/2014/main" id="{CA98E4D0-11B0-449C-928E-0B04162696AE}"/>
+                <a16:creationId xmlns:a16="http://schemas.microsoft.com/office/drawing/2014/main" id="{1D9DE401-B4FD-4E45-9E10-06D9E117D414}"/>
               </a:ext>
             </a:extLst>
           </p:cNvPr>
@@ -24291,7 +24291,7 @@
           <p:cNvPr id="13" name="">
             <a:extLst xmlns:a="http://schemas.openxmlformats.org/drawingml/2006/main">
               <a:ext uri="{FF2B5EF4-FFF2-40B4-BE49-F238E27FC236}">
-                <a16:creationId xmlns:a16="http://schemas.microsoft.com/office/drawing/2014/main" id="{39306D71-9AE7-47DD-8365-313BD5A59ACF}"/>
+                <a16:creationId xmlns:a16="http://schemas.microsoft.com/office/drawing/2014/main" id="{E11717F6-F36A-4A9F-A417-88EF96469EC5}"/>
               </a:ext>
             </a:extLst>
           </p:cNvPr>
@@ -24346,7 +24346,7 @@
     </p:spTree>
     <p:extLst>
       <p:ext uri="{BB962C8B-B14F-4D97-AF65-F5344CB8AC3E}">
-        <p14:creationId xmlns:p14="http://schemas.microsoft.com/office/powerpoint/2010/main" val="940439086"/>
+        <p14:creationId xmlns:p14="http://schemas.microsoft.com/office/powerpoint/2010/main" val="1375196146"/>
       </p:ext>
     </p:extLst>
   </p:cSld>
@@ -24377,7 +24377,7 @@
           <p:cNvPr id="12" name="">
             <a:extLst xmlns:a="http://schemas.openxmlformats.org/drawingml/2006/main">
               <a:ext uri="{FF2B5EF4-FFF2-40B4-BE49-F238E27FC236}">
-                <a16:creationId xmlns:a16="http://schemas.microsoft.com/office/drawing/2014/main" id="{630C30F3-1A6E-48DE-8614-BAC1A3A2E676}"/>
+                <a16:creationId xmlns:a16="http://schemas.microsoft.com/office/drawing/2014/main" id="{41C2C2EB-BD52-460F-AB3A-F5C87F816EED}"/>
               </a:ext>
             </a:extLst>
           </p:cNvPr>
@@ -24434,7 +24434,7 @@
           <p:cNvPr id="2" name="">
             <a:extLst xmlns:a="http://schemas.openxmlformats.org/drawingml/2006/main">
               <a:ext uri="{FF2B5EF4-FFF2-40B4-BE49-F238E27FC236}">
-                <a16:creationId xmlns:a16="http://schemas.microsoft.com/office/drawing/2014/main" id="{D051287A-FD62-4C48-A37D-D297CB8951F3}"/>
+                <a16:creationId xmlns:a16="http://schemas.microsoft.com/office/drawing/2014/main" id="{11387C3D-92CC-497E-BFD2-099C0089D424}"/>
               </a:ext>
             </a:extLst>
           </p:cNvPr>
@@ -24491,7 +24491,7 @@
           <p:cNvPr id="3" name="">
             <a:extLst xmlns:a="http://schemas.openxmlformats.org/drawingml/2006/main">
               <a:ext uri="{FF2B5EF4-FFF2-40B4-BE49-F238E27FC236}">
-                <a16:creationId xmlns:a16="http://schemas.microsoft.com/office/drawing/2014/main" id="{8D05D75C-FE15-4367-9993-3C98603448E7}"/>
+                <a16:creationId xmlns:a16="http://schemas.microsoft.com/office/drawing/2014/main" id="{C1D754A7-E242-4CD4-BF59-5C21C1FEEC6D}"/>
               </a:ext>
             </a:extLst>
           </p:cNvPr>
@@ -24548,7 +24548,7 @@
           <p:cNvPr id="4" name="">
             <a:extLst xmlns:a="http://schemas.openxmlformats.org/drawingml/2006/main">
               <a:ext uri="{FF2B5EF4-FFF2-40B4-BE49-F238E27FC236}">
-                <a16:creationId xmlns:a16="http://schemas.microsoft.com/office/drawing/2014/main" id="{DE5AB117-391B-4908-9732-BBE68ADF991C}"/>
+                <a16:creationId xmlns:a16="http://schemas.microsoft.com/office/drawing/2014/main" id="{D2470759-CB3F-47C7-A0EF-D18A9EDBFD5D}"/>
               </a:ext>
             </a:extLst>
           </p:cNvPr>
@@ -24605,7 +24605,7 @@
           <p:cNvPr id="5" name="">
             <a:extLst xmlns:a="http://schemas.openxmlformats.org/drawingml/2006/main">
               <a:ext uri="{FF2B5EF4-FFF2-40B4-BE49-F238E27FC236}">
-                <a16:creationId xmlns:a16="http://schemas.microsoft.com/office/drawing/2014/main" id="{6D504F7F-B543-4B41-9AAF-75E54D035125}"/>
+                <a16:creationId xmlns:a16="http://schemas.microsoft.com/office/drawing/2014/main" id="{76C997FF-AB63-4B29-BFD8-73807F54E9AC}"/>
               </a:ext>
             </a:extLst>
           </p:cNvPr>
@@ -24662,7 +24662,7 @@
           <p:cNvPr id="6" name="">
             <a:extLst xmlns:a="http://schemas.openxmlformats.org/drawingml/2006/main">
               <a:ext uri="{FF2B5EF4-FFF2-40B4-BE49-F238E27FC236}">
-                <a16:creationId xmlns:a16="http://schemas.microsoft.com/office/drawing/2014/main" id="{00D8E1AC-4B49-4053-B3C3-4DD879845EE5}"/>
+                <a16:creationId xmlns:a16="http://schemas.microsoft.com/office/drawing/2014/main" id="{C2B99C74-414D-4D14-B22D-6176C8F22899}"/>
               </a:ext>
             </a:extLst>
           </p:cNvPr>
@@ -24719,7 +24719,7 @@
           <p:cNvPr id="7" name="">
             <a:extLst xmlns:a="http://schemas.openxmlformats.org/drawingml/2006/main">
               <a:ext uri="{FF2B5EF4-FFF2-40B4-BE49-F238E27FC236}">
-                <a16:creationId xmlns:a16="http://schemas.microsoft.com/office/drawing/2014/main" id="{C31F8F20-F96F-48C0-8659-E8322040CCFA}"/>
+                <a16:creationId xmlns:a16="http://schemas.microsoft.com/office/drawing/2014/main" id="{3D0DB5ED-7509-4F9D-BE03-9689CA79019A}"/>
               </a:ext>
             </a:extLst>
           </p:cNvPr>
@@ -24776,7 +24776,7 @@
           <p:cNvPr id="8" name="">
             <a:extLst xmlns:a="http://schemas.openxmlformats.org/drawingml/2006/main">
               <a:ext uri="{FF2B5EF4-FFF2-40B4-BE49-F238E27FC236}">
-                <a16:creationId xmlns:a16="http://schemas.microsoft.com/office/drawing/2014/main" id="{3208CB73-C3FB-4FA0-850F-200315311619}"/>
+                <a16:creationId xmlns:a16="http://schemas.microsoft.com/office/drawing/2014/main" id="{805D2D7D-9C40-4263-8543-EAB6F5D2427F}"/>
               </a:ext>
             </a:extLst>
           </p:cNvPr>
@@ -24833,7 +24833,7 @@
           <p:cNvPr id="9" name="">
             <a:extLst xmlns:a="http://schemas.openxmlformats.org/drawingml/2006/main">
               <a:ext uri="{FF2B5EF4-FFF2-40B4-BE49-F238E27FC236}">
-                <a16:creationId xmlns:a16="http://schemas.microsoft.com/office/drawing/2014/main" id="{AB7C66F6-F35E-4C62-87E0-47D2B3AF0B2A}"/>
+                <a16:creationId xmlns:a16="http://schemas.microsoft.com/office/drawing/2014/main" id="{549745AA-99D0-4BA9-BB8F-7F2021E1CD15}"/>
               </a:ext>
             </a:extLst>
           </p:cNvPr>
@@ -24890,7 +24890,7 @@
           <p:cNvPr id="10" name="">
             <a:extLst xmlns:a="http://schemas.openxmlformats.org/drawingml/2006/main">
               <a:ext uri="{FF2B5EF4-FFF2-40B4-BE49-F238E27FC236}">
-                <a16:creationId xmlns:a16="http://schemas.microsoft.com/office/drawing/2014/main" id="{12ABA486-6EAA-47D1-9B17-681FEDC03F17}"/>
+                <a16:creationId xmlns:a16="http://schemas.microsoft.com/office/drawing/2014/main" id="{FA72EEE3-F1FA-43B8-B9A9-72384137B374}"/>
               </a:ext>
             </a:extLst>
           </p:cNvPr>
@@ -24947,7 +24947,7 @@
           <p:cNvPr id="11" name="">
             <a:extLst xmlns:a="http://schemas.openxmlformats.org/drawingml/2006/main">
               <a:ext uri="{FF2B5EF4-FFF2-40B4-BE49-F238E27FC236}">
-                <a16:creationId xmlns:a16="http://schemas.microsoft.com/office/drawing/2014/main" id="{47C594E3-A867-4C66-8672-DC0B936A31CE}"/>
+                <a16:creationId xmlns:a16="http://schemas.microsoft.com/office/drawing/2014/main" id="{E534E20B-2515-4A28-9ED4-64403573DBE1}"/>
               </a:ext>
             </a:extLst>
           </p:cNvPr>
@@ -25002,7 +25002,7 @@
     </p:spTree>
     <p:extLst>
       <p:ext uri="{BB962C8B-B14F-4D97-AF65-F5344CB8AC3E}">
-        <p14:creationId xmlns:p14="http://schemas.microsoft.com/office/powerpoint/2010/main" val="297761564"/>
+        <p14:creationId xmlns:p14="http://schemas.microsoft.com/office/powerpoint/2010/main" val="917868642"/>
       </p:ext>
     </p:extLst>
   </p:cSld>
@@ -25033,7 +25033,7 @@
           <p:cNvPr id="11" name="">
             <a:extLst xmlns:a="http://schemas.openxmlformats.org/drawingml/2006/main">
               <a:ext uri="{FF2B5EF4-FFF2-40B4-BE49-F238E27FC236}">
-                <a16:creationId xmlns:a16="http://schemas.microsoft.com/office/drawing/2014/main" id="{8A19A3D1-E890-46F5-B95E-1CC016B9B726}"/>
+                <a16:creationId xmlns:a16="http://schemas.microsoft.com/office/drawing/2014/main" id="{9D72CB68-92D6-439B-9ECA-0783B6316063}"/>
               </a:ext>
             </a:extLst>
           </p:cNvPr>
@@ -25090,7 +25090,7 @@
           <p:cNvPr id="2" name="">
             <a:extLst xmlns:a="http://schemas.openxmlformats.org/drawingml/2006/main">
               <a:ext uri="{FF2B5EF4-FFF2-40B4-BE49-F238E27FC236}">
-                <a16:creationId xmlns:a16="http://schemas.microsoft.com/office/drawing/2014/main" id="{5E921232-DB94-47C1-B735-EB772D247CBB}"/>
+                <a16:creationId xmlns:a16="http://schemas.microsoft.com/office/drawing/2014/main" id="{E33139A4-FA7A-4418-B920-12DD28ED3159}"/>
               </a:ext>
             </a:extLst>
           </p:cNvPr>
@@ -25147,7 +25147,7 @@
           <p:cNvPr id="3" name="">
             <a:extLst xmlns:a="http://schemas.openxmlformats.org/drawingml/2006/main">
               <a:ext uri="{FF2B5EF4-FFF2-40B4-BE49-F238E27FC236}">
-                <a16:creationId xmlns:a16="http://schemas.microsoft.com/office/drawing/2014/main" id="{EA9E1FD7-1EA1-49E6-83C0-79C471566039}"/>
+                <a16:creationId xmlns:a16="http://schemas.microsoft.com/office/drawing/2014/main" id="{7E4BB92D-4C1D-4D84-8BC4-CA8C40CE5818}"/>
               </a:ext>
             </a:extLst>
           </p:cNvPr>
@@ -25204,7 +25204,7 @@
           <p:cNvPr id="4" name="">
             <a:extLst xmlns:a="http://schemas.openxmlformats.org/drawingml/2006/main">
               <a:ext uri="{FF2B5EF4-FFF2-40B4-BE49-F238E27FC236}">
-                <a16:creationId xmlns:a16="http://schemas.microsoft.com/office/drawing/2014/main" id="{7B7D0F41-D758-4C6D-8C57-1EA345EBA2AC}"/>
+                <a16:creationId xmlns:a16="http://schemas.microsoft.com/office/drawing/2014/main" id="{166B32CF-553F-4C36-86FB-DB351691F696}"/>
               </a:ext>
             </a:extLst>
           </p:cNvPr>
@@ -25261,7 +25261,7 @@
           <p:cNvPr id="5" name="">
             <a:extLst xmlns:a="http://schemas.openxmlformats.org/drawingml/2006/main">
               <a:ext uri="{FF2B5EF4-FFF2-40B4-BE49-F238E27FC236}">
-                <a16:creationId xmlns:a16="http://schemas.microsoft.com/office/drawing/2014/main" id="{9DAB27C0-51CB-4E93-AF38-16E00651CB33}"/>
+                <a16:creationId xmlns:a16="http://schemas.microsoft.com/office/drawing/2014/main" id="{F68F3245-5543-448F-B8C5-EADD462A08B4}"/>
               </a:ext>
             </a:extLst>
           </p:cNvPr>
@@ -25318,7 +25318,7 @@
           <p:cNvPr id="6" name="">
             <a:extLst xmlns:a="http://schemas.openxmlformats.org/drawingml/2006/main">
               <a:ext uri="{FF2B5EF4-FFF2-40B4-BE49-F238E27FC236}">
-                <a16:creationId xmlns:a16="http://schemas.microsoft.com/office/drawing/2014/main" id="{56BC8E8A-0D34-42F1-ABFE-689B0DBE269F}"/>
+                <a16:creationId xmlns:a16="http://schemas.microsoft.com/office/drawing/2014/main" id="{12A0C0D3-E0E1-42B1-A493-A1E3DC807D8E}"/>
               </a:ext>
             </a:extLst>
           </p:cNvPr>
@@ -25375,7 +25375,7 @@
           <p:cNvPr id="7" name="">
             <a:extLst xmlns:a="http://schemas.openxmlformats.org/drawingml/2006/main">
               <a:ext uri="{FF2B5EF4-FFF2-40B4-BE49-F238E27FC236}">
-                <a16:creationId xmlns:a16="http://schemas.microsoft.com/office/drawing/2014/main" id="{6D24E036-69DC-40D3-8A3E-06ACF920FF71}"/>
+                <a16:creationId xmlns:a16="http://schemas.microsoft.com/office/drawing/2014/main" id="{B6479CEE-E534-413F-B874-B7994516925B}"/>
               </a:ext>
             </a:extLst>
           </p:cNvPr>
@@ -25432,7 +25432,7 @@
           <p:cNvPr id="8" name="">
             <a:extLst xmlns:a="http://schemas.openxmlformats.org/drawingml/2006/main">
               <a:ext uri="{FF2B5EF4-FFF2-40B4-BE49-F238E27FC236}">
-                <a16:creationId xmlns:a16="http://schemas.microsoft.com/office/drawing/2014/main" id="{100DF17F-1970-4D53-8A7E-F8FB5BEF33E9}"/>
+                <a16:creationId xmlns:a16="http://schemas.microsoft.com/office/drawing/2014/main" id="{CEC8FA7A-3A4D-4BAF-BC2B-F7DFC0D5B57C}"/>
               </a:ext>
             </a:extLst>
           </p:cNvPr>
@@ -25489,7 +25489,7 @@
           <p:cNvPr id="9" name="">
             <a:extLst xmlns:a="http://schemas.openxmlformats.org/drawingml/2006/main">
               <a:ext uri="{FF2B5EF4-FFF2-40B4-BE49-F238E27FC236}">
-                <a16:creationId xmlns:a16="http://schemas.microsoft.com/office/drawing/2014/main" id="{84EB8A05-2961-4139-8F5C-FA99AB792993}"/>
+                <a16:creationId xmlns:a16="http://schemas.microsoft.com/office/drawing/2014/main" id="{88138C33-B4B3-4CA9-815B-213701AF7F4D}"/>
               </a:ext>
             </a:extLst>
           </p:cNvPr>
@@ -25546,7 +25546,7 @@
           <p:cNvPr id="10" name="">
             <a:extLst xmlns:a="http://schemas.openxmlformats.org/drawingml/2006/main">
               <a:ext uri="{FF2B5EF4-FFF2-40B4-BE49-F238E27FC236}">
-                <a16:creationId xmlns:a16="http://schemas.microsoft.com/office/drawing/2014/main" id="{833F7742-998B-4E16-B2E3-FE7631F6EBE9}"/>
+                <a16:creationId xmlns:a16="http://schemas.microsoft.com/office/drawing/2014/main" id="{3BAD1645-F7D7-474A-964A-A5505E1FD581}"/>
               </a:ext>
             </a:extLst>
           </p:cNvPr>
@@ -25601,7 +25601,7 @@
     </p:spTree>
     <p:extLst>
       <p:ext uri="{BB962C8B-B14F-4D97-AF65-F5344CB8AC3E}">
-        <p14:creationId xmlns:p14="http://schemas.microsoft.com/office/powerpoint/2010/main" val="1138291156"/>
+        <p14:creationId xmlns:p14="http://schemas.microsoft.com/office/powerpoint/2010/main" val="1538846073"/>
       </p:ext>
     </p:extLst>
   </p:cSld>

</xml_diff>

<commit_message>
Sync pitch with resident Qwen and audio stack
</commit_message>
<xml_diff>
--- a/docs/pitch/Vantemio_Presentation_2026-10-05.pptx
+++ b/docs/pitch/Vantemio_Presentation_2026-10-05.pptx
@@ -2,51 +2,51 @@
 <file path=ppt/presentation.xml><?xml version="1.0" encoding="utf-8"?>
 <p:presentation xmlns:p="http://schemas.openxmlformats.org/presentationml/2006/main">
   <p:sldMasterIdLst>
-    <p:sldMasterId xmlns:r="http://schemas.openxmlformats.org/officeDocument/2006/relationships" id="2147483648" r:id="R7e1061816ba54ae9"/>
+    <p:sldMasterId xmlns:r="http://schemas.openxmlformats.org/officeDocument/2006/relationships" id="2147483648" r:id="R83f9cfc57952411a"/>
   </p:sldMasterIdLst>
   <p:notesMasterIdLst>
-    <p:notesMasterId xmlns:r="http://schemas.openxmlformats.org/officeDocument/2006/relationships" r:id="Rf6c38c16b6f846c9"/>
+    <p:notesMasterId xmlns:r="http://schemas.openxmlformats.org/officeDocument/2006/relationships" r:id="R3f172132c0744595"/>
   </p:notesMasterIdLst>
   <p:sldIdLst>
-    <p:sldId xmlns:r="http://schemas.openxmlformats.org/officeDocument/2006/relationships" id="256" r:id="R500d854b88834223"/>
-    <p:sldId xmlns:r="http://schemas.openxmlformats.org/officeDocument/2006/relationships" id="257" r:id="R234616e2ec9240e7"/>
-    <p:sldId xmlns:r="http://schemas.openxmlformats.org/officeDocument/2006/relationships" id="258" r:id="R166793dbda654c35"/>
-    <p:sldId xmlns:r="http://schemas.openxmlformats.org/officeDocument/2006/relationships" id="259" r:id="Re4ef996e74444037"/>
-    <p:sldId xmlns:r="http://schemas.openxmlformats.org/officeDocument/2006/relationships" id="260" r:id="R0d916221078f482b"/>
-    <p:sldId xmlns:r="http://schemas.openxmlformats.org/officeDocument/2006/relationships" id="261" r:id="Re60440c0fffe4a12"/>
-    <p:sldId xmlns:r="http://schemas.openxmlformats.org/officeDocument/2006/relationships" id="262" r:id="R4c0a102195d64a4a"/>
-    <p:sldId xmlns:r="http://schemas.openxmlformats.org/officeDocument/2006/relationships" id="263" r:id="R525e9a481b0b426c"/>
-    <p:sldId xmlns:r="http://schemas.openxmlformats.org/officeDocument/2006/relationships" id="264" r:id="R74353ea22ebb4386"/>
-    <p:sldId xmlns:r="http://schemas.openxmlformats.org/officeDocument/2006/relationships" id="265" r:id="Rcd632884a18341c6"/>
-    <p:sldId xmlns:r="http://schemas.openxmlformats.org/officeDocument/2006/relationships" id="266" r:id="R827cda0dab7e4c8e"/>
-    <p:sldId xmlns:r="http://schemas.openxmlformats.org/officeDocument/2006/relationships" id="267" r:id="R1d9f1482970a4175"/>
-    <p:sldId xmlns:r="http://schemas.openxmlformats.org/officeDocument/2006/relationships" id="268" r:id="R68f0b9aaaa0c4e8b"/>
-    <p:sldId xmlns:r="http://schemas.openxmlformats.org/officeDocument/2006/relationships" id="269" r:id="R4c97b1c1dc894bac"/>
-    <p:sldId xmlns:r="http://schemas.openxmlformats.org/officeDocument/2006/relationships" id="270" r:id="R9938e031a87b4a89"/>
-    <p:sldId xmlns:r="http://schemas.openxmlformats.org/officeDocument/2006/relationships" id="271" r:id="R8226465017ab4640"/>
-    <p:sldId xmlns:r="http://schemas.openxmlformats.org/officeDocument/2006/relationships" id="272" r:id="Rdb98b10f923b4fa9"/>
-    <p:sldId xmlns:r="http://schemas.openxmlformats.org/officeDocument/2006/relationships" id="273" r:id="Rbb2fe68779174e52"/>
-    <p:sldId xmlns:r="http://schemas.openxmlformats.org/officeDocument/2006/relationships" id="274" r:id="Raeb23837942d4230"/>
-    <p:sldId xmlns:r="http://schemas.openxmlformats.org/officeDocument/2006/relationships" id="275" r:id="Rbbdcdc0c230548bb"/>
-    <p:sldId xmlns:r="http://schemas.openxmlformats.org/officeDocument/2006/relationships" id="276" r:id="R60d817bad7e84eb3"/>
-    <p:sldId xmlns:r="http://schemas.openxmlformats.org/officeDocument/2006/relationships" id="277" r:id="R0b5aa16841e14f18"/>
-    <p:sldId xmlns:r="http://schemas.openxmlformats.org/officeDocument/2006/relationships" id="278" r:id="R95f77f5240be4d5b"/>
-    <p:sldId xmlns:r="http://schemas.openxmlformats.org/officeDocument/2006/relationships" id="279" r:id="R785f20da6b9245f3"/>
-    <p:sldId xmlns:r="http://schemas.openxmlformats.org/officeDocument/2006/relationships" id="280" r:id="Ra6e37ef3fd6d49a6"/>
-    <p:sldId xmlns:r="http://schemas.openxmlformats.org/officeDocument/2006/relationships" id="281" r:id="R7e510d10262f494e"/>
-    <p:sldId xmlns:r="http://schemas.openxmlformats.org/officeDocument/2006/relationships" id="282" r:id="Rd354b9d0871744b9"/>
-    <p:sldId xmlns:r="http://schemas.openxmlformats.org/officeDocument/2006/relationships" id="283" r:id="R056c645302e74c94"/>
-    <p:sldId xmlns:r="http://schemas.openxmlformats.org/officeDocument/2006/relationships" id="284" r:id="R1818fb75e1484819"/>
-    <p:sldId xmlns:r="http://schemas.openxmlformats.org/officeDocument/2006/relationships" id="285" r:id="R410d9386d394490c"/>
-    <p:sldId xmlns:r="http://schemas.openxmlformats.org/officeDocument/2006/relationships" id="286" r:id="Rbcaae547110e415e"/>
-    <p:sldId xmlns:r="http://schemas.openxmlformats.org/officeDocument/2006/relationships" id="287" r:id="Rf17834f61cfe4b92"/>
-    <p:sldId xmlns:r="http://schemas.openxmlformats.org/officeDocument/2006/relationships" id="288" r:id="R448c6186545b48d5"/>
-    <p:sldId xmlns:r="http://schemas.openxmlformats.org/officeDocument/2006/relationships" id="289" r:id="R75491b986ad047b1"/>
-    <p:sldId xmlns:r="http://schemas.openxmlformats.org/officeDocument/2006/relationships" id="290" r:id="R02f199a8ebc54e37"/>
-    <p:sldId xmlns:r="http://schemas.openxmlformats.org/officeDocument/2006/relationships" id="291" r:id="Ra8c2b0662e55499f"/>
-    <p:sldId xmlns:r="http://schemas.openxmlformats.org/officeDocument/2006/relationships" id="292" r:id="R3832b43bc07e4f89"/>
-    <p:sldId xmlns:r="http://schemas.openxmlformats.org/officeDocument/2006/relationships" id="293" r:id="Re4bf6ce14ea6430d"/>
-    <p:sldId xmlns:r="http://schemas.openxmlformats.org/officeDocument/2006/relationships" id="294" r:id="Rd7447eab138e4b39"/>
+    <p:sldId xmlns:r="http://schemas.openxmlformats.org/officeDocument/2006/relationships" id="256" r:id="R674ad9c8c0f041bc"/>
+    <p:sldId xmlns:r="http://schemas.openxmlformats.org/officeDocument/2006/relationships" id="257" r:id="R3882980f6a9b4f96"/>
+    <p:sldId xmlns:r="http://schemas.openxmlformats.org/officeDocument/2006/relationships" id="258" r:id="R926fb0f43664480a"/>
+    <p:sldId xmlns:r="http://schemas.openxmlformats.org/officeDocument/2006/relationships" id="259" r:id="R801f57b77c1e422d"/>
+    <p:sldId xmlns:r="http://schemas.openxmlformats.org/officeDocument/2006/relationships" id="260" r:id="Ra1a1047ae55c47a6"/>
+    <p:sldId xmlns:r="http://schemas.openxmlformats.org/officeDocument/2006/relationships" id="261" r:id="R0c0479ea9e844494"/>
+    <p:sldId xmlns:r="http://schemas.openxmlformats.org/officeDocument/2006/relationships" id="262" r:id="Rc36fd91f725d4871"/>
+    <p:sldId xmlns:r="http://schemas.openxmlformats.org/officeDocument/2006/relationships" id="263" r:id="R00b89ae1cdca4370"/>
+    <p:sldId xmlns:r="http://schemas.openxmlformats.org/officeDocument/2006/relationships" id="264" r:id="R9eec08d322254f56"/>
+    <p:sldId xmlns:r="http://schemas.openxmlformats.org/officeDocument/2006/relationships" id="265" r:id="Rc03e90bd6c764964"/>
+    <p:sldId xmlns:r="http://schemas.openxmlformats.org/officeDocument/2006/relationships" id="266" r:id="Re86ceb8ec02f4a0c"/>
+    <p:sldId xmlns:r="http://schemas.openxmlformats.org/officeDocument/2006/relationships" id="267" r:id="Rdc24ad3fc1434792"/>
+    <p:sldId xmlns:r="http://schemas.openxmlformats.org/officeDocument/2006/relationships" id="268" r:id="R76854dcec42c4cd2"/>
+    <p:sldId xmlns:r="http://schemas.openxmlformats.org/officeDocument/2006/relationships" id="269" r:id="Rff798e697e134ba4"/>
+    <p:sldId xmlns:r="http://schemas.openxmlformats.org/officeDocument/2006/relationships" id="270" r:id="R01ce6e7017794c32"/>
+    <p:sldId xmlns:r="http://schemas.openxmlformats.org/officeDocument/2006/relationships" id="271" r:id="Rc5d062ba07e04513"/>
+    <p:sldId xmlns:r="http://schemas.openxmlformats.org/officeDocument/2006/relationships" id="272" r:id="Red3ed8f4b5c045b0"/>
+    <p:sldId xmlns:r="http://schemas.openxmlformats.org/officeDocument/2006/relationships" id="273" r:id="Re0de5a822bb34db2"/>
+    <p:sldId xmlns:r="http://schemas.openxmlformats.org/officeDocument/2006/relationships" id="274" r:id="R9122fcf82f3c46c7"/>
+    <p:sldId xmlns:r="http://schemas.openxmlformats.org/officeDocument/2006/relationships" id="275" r:id="Rfa136cf0c5444c70"/>
+    <p:sldId xmlns:r="http://schemas.openxmlformats.org/officeDocument/2006/relationships" id="276" r:id="Rcaf93a75e91a47a2"/>
+    <p:sldId xmlns:r="http://schemas.openxmlformats.org/officeDocument/2006/relationships" id="277" r:id="Rcd82d4e53c4f4507"/>
+    <p:sldId xmlns:r="http://schemas.openxmlformats.org/officeDocument/2006/relationships" id="278" r:id="R9572961151ae4e66"/>
+    <p:sldId xmlns:r="http://schemas.openxmlformats.org/officeDocument/2006/relationships" id="279" r:id="Ra50321466cd04c17"/>
+    <p:sldId xmlns:r="http://schemas.openxmlformats.org/officeDocument/2006/relationships" id="280" r:id="Rba03ae52afcd404c"/>
+    <p:sldId xmlns:r="http://schemas.openxmlformats.org/officeDocument/2006/relationships" id="281" r:id="R3fa7b7fca3fe4571"/>
+    <p:sldId xmlns:r="http://schemas.openxmlformats.org/officeDocument/2006/relationships" id="282" r:id="R2dcfb699dc954e92"/>
+    <p:sldId xmlns:r="http://schemas.openxmlformats.org/officeDocument/2006/relationships" id="283" r:id="R39fa4ef19d344073"/>
+    <p:sldId xmlns:r="http://schemas.openxmlformats.org/officeDocument/2006/relationships" id="284" r:id="Rf66922f125ec4023"/>
+    <p:sldId xmlns:r="http://schemas.openxmlformats.org/officeDocument/2006/relationships" id="285" r:id="Ra9a08027d7f74dd1"/>
+    <p:sldId xmlns:r="http://schemas.openxmlformats.org/officeDocument/2006/relationships" id="286" r:id="Rd6f5d14428bf44df"/>
+    <p:sldId xmlns:r="http://schemas.openxmlformats.org/officeDocument/2006/relationships" id="287" r:id="R3c1ce8da5d3e48a9"/>
+    <p:sldId xmlns:r="http://schemas.openxmlformats.org/officeDocument/2006/relationships" id="288" r:id="R0d1fa832fb7345a1"/>
+    <p:sldId xmlns:r="http://schemas.openxmlformats.org/officeDocument/2006/relationships" id="289" r:id="R3252b9b666ea4e89"/>
+    <p:sldId xmlns:r="http://schemas.openxmlformats.org/officeDocument/2006/relationships" id="290" r:id="Rc7f5cf5fa00543ba"/>
+    <p:sldId xmlns:r="http://schemas.openxmlformats.org/officeDocument/2006/relationships" id="291" r:id="R5da5430ce6a14f17"/>
+    <p:sldId xmlns:r="http://schemas.openxmlformats.org/officeDocument/2006/relationships" id="292" r:id="R91594ead666a42ec"/>
+    <p:sldId xmlns:r="http://schemas.openxmlformats.org/officeDocument/2006/relationships" id="293" r:id="Raca1b36a285a4c9f"/>
+    <p:sldId xmlns:r="http://schemas.openxmlformats.org/officeDocument/2006/relationships" id="294" r:id="Ref0202cf9aaa4566"/>
   </p:sldIdLst>
   <p:sldSz cx="12192000" cy="6858000"/>
   <p:notesSz cx="6858000" cy="9144000"/>
@@ -2510,7 +2510,7 @@
           <a:lstStyle xmlns:a="http://schemas.openxmlformats.org/drawingml/2006/main"/>
           <a:p xmlns:a="http://schemas.openxmlformats.org/drawingml/2006/main">
             <a:r>
-              <a:t>Latest founder-authorized proposal, 8 October 2026. Solo total = 100,000 + 50,000 = 150,000. Team total = 100,000 + 50,000 + 240,000 + 10,000 = 400,000. Development resource amount is an envelope, not a verified itemized cost estimate. Existing public investor material contains a separate older scenario; this deck follows the current application. DGX Spark cost is included, not added twice. Two developers are proposed, not hired.</a:t>
+              <a:t>Latest founder-authorized proposal, 8 October 2026. Solo total = 100,000 + 50,000 = 150,000. Team total = 100,000 + 50,000 + 240,000 + 10,000 = 400,000. Development resource amount is an envelope, not a verified itemized cost estimate. Website and public investor documents use the same USD150k / USD400k scenarios. DGX Spark cost is included, not added twice. Two developers are proposed, not hired.</a:t>
             </a:r>
           </a:p>
         </p:txBody>
@@ -2580,7 +2580,7 @@
           <a:lstStyle xmlns:a="http://schemas.openxmlformats.org/drawingml/2006/main"/>
           <a:p xmlns:a="http://schemas.openxmlformats.org/drawingml/2006/main">
             <a:r>
-              <a:t>Price/specifications checked 8 October 2026: https://marketplace.nvidia.com/en-us/enterprise/personal-ai-supercomputers/dgx-spark/ . NVIDIA lists USD 6,950, 128 GB coherent unified system memory and 4 TB NVMe. Direct store listed out of stock at verification. https://docs.nvidia.com/dgx/dgx-spark/hardware.html specifies 128 GB LPDDR5X shared CPU/GPU memory and 273 GB/s, not a discrete 128 GB VRAM card. Founder wants to offload Qwen 27B or a compatible larger model and suitable local specialists, preserving Station authority and freeing its graphics/render capacity. Always-resident concurrent serving is a workload-validation target. Supplier availability, tax/shipping, ARM compatibility and measured memory/throughput require procurement and acceptance checks.</a:t>
+              <a:t>Price/specifications checked 8 October 2026: https://marketplace.nvidia.com/en-us/enterprise/personal-ai-supercomputers/dgx-spark/ . NVIDIA lists USD 6,950, 128 GB coherent unified system memory and 4 TB NVMe. Direct store listed out of stock at verification. https://docs.nvidia.com/dgx/dgx-spark/hardware.html specifies 128 GB LPDDR5X shared CPU/GPU memory and 273 GB/s, not a discrete 128 GB VRAM card. Founder wants to offload Qwen 27B or a compatible larger model and suitable local specialists, preserving Station authority and freeing its graphics/render capacity. After installation, the intended normal operating mode is resident Qwen 27B alongside TTS and audio tools. Additional models load on demand; the main model remains replaceable. Supplier availability, tax/shipping, ARM compatibility and measured memory/throughput require procurement and acceptance checks.</a:t>
             </a:r>
           </a:p>
         </p:txBody>
@@ -3208,7 +3208,7 @@
   </p:cSld>
   <p:clrMap bg1="lt1" tx1="dk1" bg2="lt2" tx2="dk2" accent1="accent1" accent2="accent2" accent3="accent3" accent4="accent4" accent5="accent5" accent6="accent6" hlink="hlink" folHlink="folHlink"/>
   <p:sldLayoutIdLst>
-    <p:sldLayoutId xmlns:r="http://schemas.openxmlformats.org/officeDocument/2006/relationships" id="2147483649" r:id="R35b87dabab304e20"/>
+    <p:sldLayoutId xmlns:r="http://schemas.openxmlformats.org/officeDocument/2006/relationships" id="2147483649" r:id="Re3826fd3e11f4900"/>
   </p:sldLayoutIdLst>
   <p:txStyles>
     <p:titleStyle>
@@ -3759,7 +3759,7 @@
           <p:cNvPr id="6" name="">
             <a:extLst xmlns:a="http://schemas.openxmlformats.org/drawingml/2006/main">
               <a:ext uri="{FF2B5EF4-FFF2-40B4-BE49-F238E27FC236}">
-                <a16:creationId xmlns:a16="http://schemas.microsoft.com/office/drawing/2014/main" id="{D2988816-D725-42A5-9BA9-EE9F9246F185}"/>
+                <a16:creationId xmlns:a16="http://schemas.microsoft.com/office/drawing/2014/main" id="{DFE18A95-E969-4DF9-A2F8-35BE6CF03A16}"/>
               </a:ext>
             </a:extLst>
           </p:cNvPr>
@@ -3769,7 +3769,7 @@
           <p:nvPr/>
         </p:nvPicPr>
         <p:blipFill>
-          <a:blip xmlns:r="http://schemas.openxmlformats.org/officeDocument/2006/relationships" xmlns:a="http://schemas.openxmlformats.org/drawingml/2006/main" r:embed="R01e2e17e42f34d51"/>
+          <a:blip xmlns:r="http://schemas.openxmlformats.org/officeDocument/2006/relationships" xmlns:a="http://schemas.openxmlformats.org/drawingml/2006/main" r:embed="Rdb070cfe6b3c4520"/>
           <a:srcRect xmlns:a="http://schemas.openxmlformats.org/drawingml/2006/main" l="0" t="27" r="0" b="27"/>
           <a:stretch xmlns:a="http://schemas.openxmlformats.org/drawingml/2006/main">
             <a:fillRect l="0" t="0" r="0" b="0"/>
@@ -4520,7 +4520,7 @@
           <p:cNvPr id="21" name="">
             <a:extLst xmlns:a="http://schemas.openxmlformats.org/drawingml/2006/main">
               <a:ext uri="{FF2B5EF4-FFF2-40B4-BE49-F238E27FC236}">
-                <a16:creationId xmlns:a16="http://schemas.microsoft.com/office/drawing/2014/main" id="{791D26F8-193D-40F9-9E14-DED6B6118AEC}"/>
+                <a16:creationId xmlns:a16="http://schemas.microsoft.com/office/drawing/2014/main" id="{47F9F56C-4865-4CF1-9F0A-ED2AA9B16922}"/>
               </a:ext>
             </a:extLst>
           </p:cNvPr>
@@ -4551,7 +4551,7 @@
           <p:cNvPr id="22" name="">
             <a:extLst xmlns:a="http://schemas.openxmlformats.org/drawingml/2006/main">
               <a:ext uri="{FF2B5EF4-FFF2-40B4-BE49-F238E27FC236}">
-                <a16:creationId xmlns:a16="http://schemas.microsoft.com/office/drawing/2014/main" id="{747D8BAF-6EB0-4C1A-B367-E9C089334F02}"/>
+                <a16:creationId xmlns:a16="http://schemas.microsoft.com/office/drawing/2014/main" id="{6950EF99-EC1C-4E30-9DB6-A3851D639FA8}"/>
               </a:ext>
             </a:extLst>
           </p:cNvPr>
@@ -4582,7 +4582,7 @@
           <p:cNvPr id="23" name="">
             <a:extLst xmlns:a="http://schemas.openxmlformats.org/drawingml/2006/main">
               <a:ext uri="{FF2B5EF4-FFF2-40B4-BE49-F238E27FC236}">
-                <a16:creationId xmlns:a16="http://schemas.microsoft.com/office/drawing/2014/main" id="{207CD218-C5BF-407C-90B0-87434EB7CBFF}"/>
+                <a16:creationId xmlns:a16="http://schemas.microsoft.com/office/drawing/2014/main" id="{03F0C189-1275-4366-85BB-DAB434FA3BD1}"/>
               </a:ext>
             </a:extLst>
           </p:cNvPr>
@@ -5903,7 +5903,7 @@
           <p:cNvPr id="7" name="">
             <a:extLst xmlns:a="http://schemas.openxmlformats.org/drawingml/2006/main">
               <a:ext uri="{FF2B5EF4-FFF2-40B4-BE49-F238E27FC236}">
-                <a16:creationId xmlns:a16="http://schemas.microsoft.com/office/drawing/2014/main" id="{BDC1A2F2-3C20-4E6D-BAA1-E634681D17A0}"/>
+                <a16:creationId xmlns:a16="http://schemas.microsoft.com/office/drawing/2014/main" id="{C03AD775-CE53-4084-9F14-7296E11F33B2}"/>
               </a:ext>
             </a:extLst>
           </p:cNvPr>
@@ -6993,7 +6993,7 @@
                 <a:ea typeface="Helvetica Neue"/>
                 <a:cs typeface="Helvetica Neue"/>
               </a:rPr>
-              <a:t>Planned DGX Spark</a:t>
+              <a:t>DGX Spark after installation</a:t>
             </a:r>
           </a:p>
           <a:p xmlns:a="http://schemas.openxmlformats.org/drawingml/2006/main">
@@ -7017,7 +7017,7 @@
                 <a:ea typeface="Helvetica Neue"/>
                 <a:cs typeface="Helvetica Neue"/>
               </a:rPr>
-              <a:t>Qwen and local AI stack</a:t>
+              <a:t>Resident Qwen 27B + TTS</a:t>
             </a:r>
           </a:p>
         </p:txBody>
@@ -7113,7 +7113,7 @@
           <p:cNvPr id="21" name="">
             <a:extLst xmlns:a="http://schemas.openxmlformats.org/drawingml/2006/main">
               <a:ext uri="{FF2B5EF4-FFF2-40B4-BE49-F238E27FC236}">
-                <a16:creationId xmlns:a16="http://schemas.microsoft.com/office/drawing/2014/main" id="{B04DB584-A50F-4A49-A11C-5AA7805F3F6C}"/>
+                <a16:creationId xmlns:a16="http://schemas.microsoft.com/office/drawing/2014/main" id="{BE386194-8649-4F89-8212-65B843C1247C}"/>
               </a:ext>
             </a:extLst>
           </p:cNvPr>
@@ -7147,7 +7147,7 @@
           <p:cNvPr id="22" name="">
             <a:extLst xmlns:a="http://schemas.openxmlformats.org/drawingml/2006/main">
               <a:ext uri="{FF2B5EF4-FFF2-40B4-BE49-F238E27FC236}">
-                <a16:creationId xmlns:a16="http://schemas.microsoft.com/office/drawing/2014/main" id="{59F39546-E25A-4AB7-B690-0F4C3E097F90}"/>
+                <a16:creationId xmlns:a16="http://schemas.microsoft.com/office/drawing/2014/main" id="{76015DD3-C035-4D6A-ABE1-798EA7FEAB0B}"/>
               </a:ext>
             </a:extLst>
           </p:cNvPr>
@@ -9437,7 +9437,7 @@
           <p:cNvPr id="17" name="">
             <a:extLst xmlns:a="http://schemas.openxmlformats.org/drawingml/2006/main">
               <a:ext uri="{FF2B5EF4-FFF2-40B4-BE49-F238E27FC236}">
-                <a16:creationId xmlns:a16="http://schemas.microsoft.com/office/drawing/2014/main" id="{E5CCF884-5945-48D2-BEAE-8F0636E5DD12}"/>
+                <a16:creationId xmlns:a16="http://schemas.microsoft.com/office/drawing/2014/main" id="{A4306D5B-B15F-46F2-928E-3E401FE76DB8}"/>
               </a:ext>
             </a:extLst>
           </p:cNvPr>
@@ -9468,7 +9468,7 @@
           <p:cNvPr id="18" name="">
             <a:extLst xmlns:a="http://schemas.openxmlformats.org/drawingml/2006/main">
               <a:ext uri="{FF2B5EF4-FFF2-40B4-BE49-F238E27FC236}">
-                <a16:creationId xmlns:a16="http://schemas.microsoft.com/office/drawing/2014/main" id="{1D1CEDF1-36AE-4FAA-BFCE-1B10DF458153}"/>
+                <a16:creationId xmlns:a16="http://schemas.microsoft.com/office/drawing/2014/main" id="{45DA09DA-7F2E-4977-9245-6E00D403E74F}"/>
               </a:ext>
             </a:extLst>
           </p:cNvPr>
@@ -9909,7 +9909,7 @@
           <p:cNvPr id="7" name="">
             <a:extLst xmlns:a="http://schemas.openxmlformats.org/drawingml/2006/main">
               <a:ext uri="{FF2B5EF4-FFF2-40B4-BE49-F238E27FC236}">
-                <a16:creationId xmlns:a16="http://schemas.microsoft.com/office/drawing/2014/main" id="{88C57A05-2EFF-4D4E-BBBF-83E484F8CD02}"/>
+                <a16:creationId xmlns:a16="http://schemas.microsoft.com/office/drawing/2014/main" id="{5B7BB6ED-3B93-4756-A814-CCF646ACAD73}"/>
               </a:ext>
             </a:extLst>
           </p:cNvPr>
@@ -10563,7 +10563,7 @@
           <p:cNvPr id="7" name="">
             <a:extLst xmlns:a="http://schemas.openxmlformats.org/drawingml/2006/main">
               <a:ext uri="{FF2B5EF4-FFF2-40B4-BE49-F238E27FC236}">
-                <a16:creationId xmlns:a16="http://schemas.microsoft.com/office/drawing/2014/main" id="{88C57A05-2EFF-4D4E-BBBF-83E484F8CD02}"/>
+                <a16:creationId xmlns:a16="http://schemas.microsoft.com/office/drawing/2014/main" id="{5B7BB6ED-3B93-4756-A814-CCF646ACAD73}"/>
               </a:ext>
             </a:extLst>
           </p:cNvPr>
@@ -12824,7 +12824,7 @@
           <p:cNvPr id="10" name="">
             <a:extLst xmlns:a="http://schemas.openxmlformats.org/drawingml/2006/main">
               <a:ext uri="{FF2B5EF4-FFF2-40B4-BE49-F238E27FC236}">
-                <a16:creationId xmlns:a16="http://schemas.microsoft.com/office/drawing/2014/main" id="{F755C09E-2F98-4847-9BF8-3C22CD21AD51}"/>
+                <a16:creationId xmlns:a16="http://schemas.microsoft.com/office/drawing/2014/main" id="{DDC65610-71B6-4D39-8591-82B0F8D28755}"/>
               </a:ext>
             </a:extLst>
           </p:cNvPr>
@@ -14017,7 +14017,7 @@
           <p:cNvPr id="18" name="">
             <a:extLst xmlns:a="http://schemas.openxmlformats.org/drawingml/2006/main">
               <a:ext uri="{FF2B5EF4-FFF2-40B4-BE49-F238E27FC236}">
-                <a16:creationId xmlns:a16="http://schemas.microsoft.com/office/drawing/2014/main" id="{1E209161-4F51-49AD-A264-499152218C4E}"/>
+                <a16:creationId xmlns:a16="http://schemas.microsoft.com/office/drawing/2014/main" id="{F9E9157D-B613-4AF4-946A-26CB7C3003AD}"/>
               </a:ext>
             </a:extLst>
           </p:cNvPr>
@@ -14048,7 +14048,7 @@
           <p:cNvPr id="19" name="">
             <a:extLst xmlns:a="http://schemas.openxmlformats.org/drawingml/2006/main">
               <a:ext uri="{FF2B5EF4-FFF2-40B4-BE49-F238E27FC236}">
-                <a16:creationId xmlns:a16="http://schemas.microsoft.com/office/drawing/2014/main" id="{F5FCD57A-6904-434B-B3B8-07EC0F38CF24}"/>
+                <a16:creationId xmlns:a16="http://schemas.microsoft.com/office/drawing/2014/main" id="{6630163D-C1C6-4450-9B04-57E2064ECCE2}"/>
               </a:ext>
             </a:extLst>
           </p:cNvPr>
@@ -16222,7 +16222,7 @@
           <p:cNvPr id="23" name="">
             <a:extLst xmlns:a="http://schemas.openxmlformats.org/drawingml/2006/main">
               <a:ext uri="{FF2B5EF4-FFF2-40B4-BE49-F238E27FC236}">
-                <a16:creationId xmlns:a16="http://schemas.microsoft.com/office/drawing/2014/main" id="{CC36737D-5EC6-408C-BA89-DADEA6C919F1}"/>
+                <a16:creationId xmlns:a16="http://schemas.microsoft.com/office/drawing/2014/main" id="{554ABFCD-BD18-4734-A0C6-64F09A9851B2}"/>
               </a:ext>
             </a:extLst>
           </p:cNvPr>
@@ -16253,7 +16253,7 @@
           <p:cNvPr id="24" name="">
             <a:extLst xmlns:a="http://schemas.openxmlformats.org/drawingml/2006/main">
               <a:ext uri="{FF2B5EF4-FFF2-40B4-BE49-F238E27FC236}">
-                <a16:creationId xmlns:a16="http://schemas.microsoft.com/office/drawing/2014/main" id="{95B07266-4409-4233-A07B-423242BDE04C}"/>
+                <a16:creationId xmlns:a16="http://schemas.microsoft.com/office/drawing/2014/main" id="{A9A7C02A-7B7B-4F5E-8179-8676848DA979}"/>
               </a:ext>
             </a:extLst>
           </p:cNvPr>
@@ -16284,7 +16284,7 @@
           <p:cNvPr id="25" name="">
             <a:extLst xmlns:a="http://schemas.openxmlformats.org/drawingml/2006/main">
               <a:ext uri="{FF2B5EF4-FFF2-40B4-BE49-F238E27FC236}">
-                <a16:creationId xmlns:a16="http://schemas.microsoft.com/office/drawing/2014/main" id="{6B38713F-C2D9-4574-9FCC-D9443E389BF8}"/>
+                <a16:creationId xmlns:a16="http://schemas.microsoft.com/office/drawing/2014/main" id="{9D44D394-ED0D-4E3B-9764-75F60E564516}"/>
               </a:ext>
             </a:extLst>
           </p:cNvPr>
@@ -16315,7 +16315,7 @@
           <p:cNvPr id="26" name="">
             <a:extLst xmlns:a="http://schemas.openxmlformats.org/drawingml/2006/main">
               <a:ext uri="{FF2B5EF4-FFF2-40B4-BE49-F238E27FC236}">
-                <a16:creationId xmlns:a16="http://schemas.microsoft.com/office/drawing/2014/main" id="{16147DE5-9388-46B1-82DC-A7BC1D284E81}"/>
+                <a16:creationId xmlns:a16="http://schemas.microsoft.com/office/drawing/2014/main" id="{C96EB339-4EA7-406E-B4F5-FBA5F37A593E}"/>
               </a:ext>
             </a:extLst>
           </p:cNvPr>
@@ -16346,7 +16346,7 @@
           <p:cNvPr id="27" name="">
             <a:extLst xmlns:a="http://schemas.openxmlformats.org/drawingml/2006/main">
               <a:ext uri="{FF2B5EF4-FFF2-40B4-BE49-F238E27FC236}">
-                <a16:creationId xmlns:a16="http://schemas.microsoft.com/office/drawing/2014/main" id="{55E55DE2-2D73-447B-9313-05379F2183CA}"/>
+                <a16:creationId xmlns:a16="http://schemas.microsoft.com/office/drawing/2014/main" id="{85F70B6A-A3D5-41FA-932A-D6C792DACF9D}"/>
               </a:ext>
             </a:extLst>
           </p:cNvPr>
@@ -18367,7 +18367,7 @@
                 <a:latin typeface="Helvetica Neue"/>
                 <a:ea typeface="Helvetica Neue"/>
                 <a:cs typeface="Helvetica Neue"/>
-                <a:hlinkClick xmlns:r="http://schemas.openxmlformats.org/officeDocument/2006/relationships" r:id="Rabf8648579914c34"/>
+                <a:hlinkClick xmlns:r="http://schemas.openxmlformats.org/officeDocument/2006/relationships" r:id="R391a5791b2774502"/>
               </a:rPr>
               <a:t>Open verification record</a:t>
             </a:r>
@@ -18379,7 +18379,7 @@
           <p:cNvPr id="16" name="">
             <a:extLst xmlns:a="http://schemas.openxmlformats.org/drawingml/2006/main">
               <a:ext uri="{FF2B5EF4-FFF2-40B4-BE49-F238E27FC236}">
-                <a16:creationId xmlns:a16="http://schemas.microsoft.com/office/drawing/2014/main" id="{08795465-7092-47F8-A504-293479A28B0E}"/>
+                <a16:creationId xmlns:a16="http://schemas.microsoft.com/office/drawing/2014/main" id="{391B372A-4F88-457B-875F-E900C8787871}"/>
               </a:ext>
             </a:extLst>
           </p:cNvPr>
@@ -18389,7 +18389,7 @@
           <p:nvPr/>
         </p:nvPicPr>
         <p:blipFill>
-          <a:blip xmlns:r="http://schemas.openxmlformats.org/officeDocument/2006/relationships" xmlns:a="http://schemas.openxmlformats.org/drawingml/2006/main" r:embed="Raed4119490ba45bc"/>
+          <a:blip xmlns:r="http://schemas.openxmlformats.org/officeDocument/2006/relationships" xmlns:a="http://schemas.openxmlformats.org/drawingml/2006/main" r:embed="Rce3d070aada74a58"/>
           <a:stretch xmlns:a="http://schemas.openxmlformats.org/drawingml/2006/main"/>
         </p:blipFill>
         <p:spPr>
@@ -19379,7 +19379,7 @@
           <p:cNvPr id="7" name="">
             <a:extLst xmlns:a="http://schemas.openxmlformats.org/drawingml/2006/main">
               <a:ext uri="{FF2B5EF4-FFF2-40B4-BE49-F238E27FC236}">
-                <a16:creationId xmlns:a16="http://schemas.microsoft.com/office/drawing/2014/main" id="{683D4C40-EC9A-45F7-994B-853977007C45}"/>
+                <a16:creationId xmlns:a16="http://schemas.microsoft.com/office/drawing/2014/main" id="{8F9EACA2-0966-49AF-83B7-B2F5C288B42A}"/>
               </a:ext>
             </a:extLst>
           </p:cNvPr>
@@ -20512,7 +20512,7 @@
           <p:cNvPr id="7" name="">
             <a:extLst xmlns:a="http://schemas.openxmlformats.org/drawingml/2006/main">
               <a:ext uri="{FF2B5EF4-FFF2-40B4-BE49-F238E27FC236}">
-                <a16:creationId xmlns:a16="http://schemas.microsoft.com/office/drawing/2014/main" id="{D0FEC43E-601C-40F3-BBDC-07CF0F515009}"/>
+                <a16:creationId xmlns:a16="http://schemas.microsoft.com/office/drawing/2014/main" id="{D45C859D-1B9C-4394-B7F4-08C80F1D5EDB}"/>
               </a:ext>
             </a:extLst>
           </p:cNvPr>
@@ -22290,7 +22290,7 @@
           <p:cNvPr id="7" name="">
             <a:extLst xmlns:a="http://schemas.openxmlformats.org/drawingml/2006/main">
               <a:ext uri="{FF2B5EF4-FFF2-40B4-BE49-F238E27FC236}">
-                <a16:creationId xmlns:a16="http://schemas.microsoft.com/office/drawing/2014/main" id="{8220121F-6FD6-4970-88BB-2E32252F9DB6}"/>
+                <a16:creationId xmlns:a16="http://schemas.microsoft.com/office/drawing/2014/main" id="{4D81623B-9600-4201-B023-AEC5E6FFF0B9}"/>
               </a:ext>
             </a:extLst>
           </p:cNvPr>
@@ -22944,7 +22944,7 @@
           <p:cNvPr id="9" name="">
             <a:extLst xmlns:a="http://schemas.openxmlformats.org/drawingml/2006/main">
               <a:ext uri="{FF2B5EF4-FFF2-40B4-BE49-F238E27FC236}">
-                <a16:creationId xmlns:a16="http://schemas.microsoft.com/office/drawing/2014/main" id="{EBFAA565-3582-41C5-B655-3B6B332FA0B9}"/>
+                <a16:creationId xmlns:a16="http://schemas.microsoft.com/office/drawing/2014/main" id="{2987961E-3143-49E8-9CDF-02926318E112}"/>
               </a:ext>
             </a:extLst>
           </p:cNvPr>
@@ -24257,7 +24257,7 @@
                 <a:ea typeface="Helvetica Neue"/>
                 <a:cs typeface="Helvetica Neue"/>
               </a:rPr>
-              <a:t>Keep Qwen and compatible AI workers resident on Spark. Free Station and laptops for editing, motion graphics and rendering.</a:t>
+              <a:t>Keep Qwen 27B, TTS and audio tools loaded on Spark. Station handles graphics, editing, rendering and development in parallel.</a:t>
             </a:r>
           </a:p>
         </p:txBody>
@@ -24326,7 +24326,7 @@
                 <a:ea typeface="Helvetica Neue"/>
                 <a:cs typeface="Helvetica Neue"/>
               </a:rPr>
-              <a:t>Model and workload compatibility checks</a:t>
+              <a:t>Persistent AI stack · flexible model upgrades</a:t>
             </a:r>
           </a:p>
         </p:txBody>
@@ -24464,7 +24464,7 @@
                 <a:ea typeface="Helvetica Neue"/>
                 <a:cs typeface="Helvetica Neue"/>
               </a:rPr>
-              <a:t>Expected impact: concurrent AI access, fewer waits and several-fold faster development cycles. Validate under load.</a:t>
+              <a:t>The main stack stays loaded between jobs. Additional models load as needed; development work can move from MacBook to Station.</a:t>
             </a:r>
           </a:p>
         </p:txBody>
@@ -25011,7 +25011,7 @@
                 <a:latin typeface="Helvetica Neue"/>
                 <a:ea typeface="Helvetica Neue"/>
                 <a:cs typeface="Helvetica Neue"/>
-                <a:hlinkClick xmlns:r="http://schemas.openxmlformats.org/officeDocument/2006/relationships" r:id="R838d41c0208e46dd"/>
+                <a:hlinkClick xmlns:r="http://schemas.openxmlformats.org/officeDocument/2006/relationships" r:id="R262027d37d2a421c"/>
               </a:rPr>
               <a:t>Website and current documentation</a:t>
             </a:r>
@@ -25070,7 +25070,7 @@
                 <a:latin typeface="Helvetica Neue"/>
                 <a:ea typeface="Helvetica Neue"/>
                 <a:cs typeface="Helvetica Neue"/>
-                <a:hlinkClick xmlns:r="http://schemas.openxmlformats.org/officeDocument/2006/relationships" r:id="R0497abb022be4fb7"/>
+                <a:hlinkClick xmlns:r="http://schemas.openxmlformats.org/officeDocument/2006/relationships" r:id="Reb416a6e27994f62"/>
               </a:rPr>
               <a:t>Founder LinkedIn</a:t>
             </a:r>
@@ -25343,7 +25343,7 @@
                 <a:latin typeface="Helvetica Neue"/>
                 <a:ea typeface="Helvetica Neue"/>
                 <a:cs typeface="Helvetica Neue"/>
-                <a:hlinkClick xmlns:r="http://schemas.openxmlformats.org/officeDocument/2006/relationships" r:id="R49a4d6d4bd8347c8"/>
+                <a:hlinkClick xmlns:r="http://schemas.openxmlformats.org/officeDocument/2006/relationships" r:id="R432dfd460a7e441e"/>
               </a:rPr>
               <a:t>Website and technical documentation</a:t>
             </a:r>
@@ -25413,7 +25413,7 @@
                 <a:latin typeface="Helvetica Neue"/>
                 <a:ea typeface="Helvetica Neue"/>
                 <a:cs typeface="Helvetica Neue"/>
-                <a:hlinkClick xmlns:r="http://schemas.openxmlformats.org/officeDocument/2006/relationships" r:id="R743c95a0d8fd437c"/>
+                <a:hlinkClick xmlns:r="http://schemas.openxmlformats.org/officeDocument/2006/relationships" r:id="R1d85f95103ab40ac"/>
               </a:rPr>
               <a:t>Public source and development modules</a:t>
             </a:r>
@@ -25483,7 +25483,7 @@
                 <a:latin typeface="Helvetica Neue"/>
                 <a:ea typeface="Helvetica Neue"/>
                 <a:cs typeface="Helvetica Neue"/>
-                <a:hlinkClick xmlns:r="http://schemas.openxmlformats.org/officeDocument/2006/relationships" r:id="R878d406b50ff4e87"/>
+                <a:hlinkClick xmlns:r="http://schemas.openxmlformats.org/officeDocument/2006/relationships" r:id="Rc94fe2620f974898"/>
               </a:rPr>
               <a:t>Historical demo and transaction references</a:t>
             </a:r>
@@ -25553,7 +25553,7 @@
                 <a:latin typeface="Helvetica Neue"/>
                 <a:ea typeface="Helvetica Neue"/>
                 <a:cs typeface="Helvetica Neue"/>
-                <a:hlinkClick xmlns:r="http://schemas.openxmlformats.org/officeDocument/2006/relationships" r:id="Rfa44f008e3184731"/>
+                <a:hlinkClick xmlns:r="http://schemas.openxmlformats.org/officeDocument/2006/relationships" r:id="Rede1f4dcc46a45bd"/>
               </a:rPr>
               <a:t>Market specification and fulfillment design</a:t>
             </a:r>
@@ -25612,7 +25612,7 @@
                 <a:latin typeface="Helvetica Neue"/>
                 <a:ea typeface="Helvetica Neue"/>
                 <a:cs typeface="Helvetica Neue"/>
-                <a:hlinkClick xmlns:r="http://schemas.openxmlformats.org/officeDocument/2006/relationships" r:id="R049fddf9476c45a6"/>
+                <a:hlinkClick xmlns:r="http://schemas.openxmlformats.org/officeDocument/2006/relationships" r:id="R9b5539ab93e948e8"/>
               </a:rPr>
               <a:t>Founder: Vitalii Pavlichuk</a:t>
             </a:r>
@@ -26197,7 +26197,7 @@
                 <a:latin typeface="Helvetica Neue"/>
                 <a:ea typeface="Helvetica Neue"/>
                 <a:cs typeface="Helvetica Neue"/>
-                <a:hlinkClick xmlns:r="http://schemas.openxmlformats.org/officeDocument/2006/relationships" r:id="Rd0358ea1c9694324"/>
+                <a:hlinkClick xmlns:r="http://schemas.openxmlformats.org/officeDocument/2006/relationships" r:id="R7d2401ad8e784e53"/>
               </a:rPr>
               <a:t>Reference: @anabology’s production example</a:t>
             </a:r>
@@ -27357,7 +27357,7 @@
           <p:cNvPr id="24" name="">
             <a:extLst xmlns:a="http://schemas.openxmlformats.org/drawingml/2006/main">
               <a:ext uri="{FF2B5EF4-FFF2-40B4-BE49-F238E27FC236}">
-                <a16:creationId xmlns:a16="http://schemas.microsoft.com/office/drawing/2014/main" id="{D0B0A192-C72C-4FA9-A469-F0DA8928BCC0}"/>
+                <a16:creationId xmlns:a16="http://schemas.microsoft.com/office/drawing/2014/main" id="{7853AF2E-8469-4E17-876A-5AC11BB15FCF}"/>
               </a:ext>
             </a:extLst>
           </p:cNvPr>
@@ -27388,7 +27388,7 @@
           <p:cNvPr id="25" name="">
             <a:extLst xmlns:a="http://schemas.openxmlformats.org/drawingml/2006/main">
               <a:ext uri="{FF2B5EF4-FFF2-40B4-BE49-F238E27FC236}">
-                <a16:creationId xmlns:a16="http://schemas.microsoft.com/office/drawing/2014/main" id="{845F967C-58DF-4D45-822A-ED887F98FB28}"/>
+                <a16:creationId xmlns:a16="http://schemas.microsoft.com/office/drawing/2014/main" id="{3080CF69-F096-488A-ADEF-261311A76E32}"/>
               </a:ext>
             </a:extLst>
           </p:cNvPr>
@@ -27419,7 +27419,7 @@
           <p:cNvPr id="26" name="">
             <a:extLst xmlns:a="http://schemas.openxmlformats.org/drawingml/2006/main">
               <a:ext uri="{FF2B5EF4-FFF2-40B4-BE49-F238E27FC236}">
-                <a16:creationId xmlns:a16="http://schemas.microsoft.com/office/drawing/2014/main" id="{0C145587-20E7-4B82-AC79-6FFD6DAD891C}"/>
+                <a16:creationId xmlns:a16="http://schemas.microsoft.com/office/drawing/2014/main" id="{76A5EE20-14D5-49B6-A6D3-071EA9D6A33F}"/>
               </a:ext>
             </a:extLst>
           </p:cNvPr>
@@ -27450,7 +27450,7 @@
           <p:cNvPr id="27" name="">
             <a:extLst xmlns:a="http://schemas.openxmlformats.org/drawingml/2006/main">
               <a:ext uri="{FF2B5EF4-FFF2-40B4-BE49-F238E27FC236}">
-                <a16:creationId xmlns:a16="http://schemas.microsoft.com/office/drawing/2014/main" id="{504F6BDF-E143-4272-96C9-7873DD868110}"/>
+                <a16:creationId xmlns:a16="http://schemas.microsoft.com/office/drawing/2014/main" id="{EA9EB707-1B2F-4C5E-99F6-905BA1E0C8FE}"/>
               </a:ext>
             </a:extLst>
           </p:cNvPr>
@@ -27481,7 +27481,7 @@
           <p:cNvPr id="28" name="">
             <a:extLst xmlns:a="http://schemas.openxmlformats.org/drawingml/2006/main">
               <a:ext uri="{FF2B5EF4-FFF2-40B4-BE49-F238E27FC236}">
-                <a16:creationId xmlns:a16="http://schemas.microsoft.com/office/drawing/2014/main" id="{4544EB8A-B90E-4CB7-BD18-2FEED274A3DA}"/>
+                <a16:creationId xmlns:a16="http://schemas.microsoft.com/office/drawing/2014/main" id="{A409EA3F-8C6A-4C34-BDFE-51B638C7BADC}"/>
               </a:ext>
             </a:extLst>
           </p:cNvPr>
@@ -27512,7 +27512,7 @@
           <p:cNvPr id="29" name="">
             <a:extLst xmlns:a="http://schemas.openxmlformats.org/drawingml/2006/main">
               <a:ext uri="{FF2B5EF4-FFF2-40B4-BE49-F238E27FC236}">
-                <a16:creationId xmlns:a16="http://schemas.microsoft.com/office/drawing/2014/main" id="{1846D5F1-A5B9-4907-A78F-7061B18F9626}"/>
+                <a16:creationId xmlns:a16="http://schemas.microsoft.com/office/drawing/2014/main" id="{0F45A5BF-8064-44FE-9150-A4D21C7F0B34}"/>
               </a:ext>
             </a:extLst>
           </p:cNvPr>
@@ -28150,7 +28150,7 @@
           <p:cNvPr id="21" name="">
             <a:extLst xmlns:a="http://schemas.openxmlformats.org/drawingml/2006/main">
               <a:ext uri="{FF2B5EF4-FFF2-40B4-BE49-F238E27FC236}">
-                <a16:creationId xmlns:a16="http://schemas.microsoft.com/office/drawing/2014/main" id="{DEAD7B4E-230E-48E1-8B56-6ACC600ED048}"/>
+                <a16:creationId xmlns:a16="http://schemas.microsoft.com/office/drawing/2014/main" id="{B1E3B5BD-AA62-49BD-9D40-CE8411D6E417}"/>
               </a:ext>
             </a:extLst>
           </p:cNvPr>
@@ -28181,7 +28181,7 @@
           <p:cNvPr id="22" name="">
             <a:extLst xmlns:a="http://schemas.openxmlformats.org/drawingml/2006/main">
               <a:ext uri="{FF2B5EF4-FFF2-40B4-BE49-F238E27FC236}">
-                <a16:creationId xmlns:a16="http://schemas.microsoft.com/office/drawing/2014/main" id="{B3FB3F56-B915-462C-A65D-3821D9804058}"/>
+                <a16:creationId xmlns:a16="http://schemas.microsoft.com/office/drawing/2014/main" id="{C6214AFE-3AC4-496F-A017-B6448C8FD397}"/>
               </a:ext>
             </a:extLst>
           </p:cNvPr>
@@ -28215,7 +28215,7 @@
           <p:cNvPr id="23" name="">
             <a:extLst xmlns:a="http://schemas.openxmlformats.org/drawingml/2006/main">
               <a:ext uri="{FF2B5EF4-FFF2-40B4-BE49-F238E27FC236}">
-                <a16:creationId xmlns:a16="http://schemas.microsoft.com/office/drawing/2014/main" id="{B89166E4-A4F9-4949-B3A8-083C93A2F885}"/>
+                <a16:creationId xmlns:a16="http://schemas.microsoft.com/office/drawing/2014/main" id="{37821667-B3BD-43B0-983A-BC8179DFC645}"/>
               </a:ext>
             </a:extLst>
           </p:cNvPr>
@@ -28246,7 +28246,7 @@
           <p:cNvPr id="24" name="">
             <a:extLst xmlns:a="http://schemas.openxmlformats.org/drawingml/2006/main">
               <a:ext uri="{FF2B5EF4-FFF2-40B4-BE49-F238E27FC236}">
-                <a16:creationId xmlns:a16="http://schemas.microsoft.com/office/drawing/2014/main" id="{0F5B3D54-7258-462D-8DA8-53C78AFCE991}"/>
+                <a16:creationId xmlns:a16="http://schemas.microsoft.com/office/drawing/2014/main" id="{3BFFADA6-387C-44F6-A5F0-53DA4A196995}"/>
               </a:ext>
             </a:extLst>
           </p:cNvPr>

</xml_diff>

<commit_message>
Finalize synchronized presentation layout
</commit_message>
<xml_diff>
--- a/docs/pitch/Vantemio_Presentation_2026-10-05.pptx
+++ b/docs/pitch/Vantemio_Presentation_2026-10-05.pptx
@@ -2,51 +2,51 @@
 <file path=ppt/presentation.xml><?xml version="1.0" encoding="utf-8"?>
 <p:presentation xmlns:p="http://schemas.openxmlformats.org/presentationml/2006/main">
   <p:sldMasterIdLst>
-    <p:sldMasterId xmlns:r="http://schemas.openxmlformats.org/officeDocument/2006/relationships" id="2147483648" r:id="R83f9cfc57952411a"/>
+    <p:sldMasterId xmlns:r="http://schemas.openxmlformats.org/officeDocument/2006/relationships" id="2147483648" r:id="R8165d272f8984eab"/>
   </p:sldMasterIdLst>
   <p:notesMasterIdLst>
-    <p:notesMasterId xmlns:r="http://schemas.openxmlformats.org/officeDocument/2006/relationships" r:id="R3f172132c0744595"/>
+    <p:notesMasterId xmlns:r="http://schemas.openxmlformats.org/officeDocument/2006/relationships" r:id="Rdbce6fdcd6ef415c"/>
   </p:notesMasterIdLst>
   <p:sldIdLst>
-    <p:sldId xmlns:r="http://schemas.openxmlformats.org/officeDocument/2006/relationships" id="256" r:id="R674ad9c8c0f041bc"/>
-    <p:sldId xmlns:r="http://schemas.openxmlformats.org/officeDocument/2006/relationships" id="257" r:id="R3882980f6a9b4f96"/>
-    <p:sldId xmlns:r="http://schemas.openxmlformats.org/officeDocument/2006/relationships" id="258" r:id="R926fb0f43664480a"/>
-    <p:sldId xmlns:r="http://schemas.openxmlformats.org/officeDocument/2006/relationships" id="259" r:id="R801f57b77c1e422d"/>
-    <p:sldId xmlns:r="http://schemas.openxmlformats.org/officeDocument/2006/relationships" id="260" r:id="Ra1a1047ae55c47a6"/>
-    <p:sldId xmlns:r="http://schemas.openxmlformats.org/officeDocument/2006/relationships" id="261" r:id="R0c0479ea9e844494"/>
-    <p:sldId xmlns:r="http://schemas.openxmlformats.org/officeDocument/2006/relationships" id="262" r:id="Rc36fd91f725d4871"/>
-    <p:sldId xmlns:r="http://schemas.openxmlformats.org/officeDocument/2006/relationships" id="263" r:id="R00b89ae1cdca4370"/>
-    <p:sldId xmlns:r="http://schemas.openxmlformats.org/officeDocument/2006/relationships" id="264" r:id="R9eec08d322254f56"/>
-    <p:sldId xmlns:r="http://schemas.openxmlformats.org/officeDocument/2006/relationships" id="265" r:id="Rc03e90bd6c764964"/>
-    <p:sldId xmlns:r="http://schemas.openxmlformats.org/officeDocument/2006/relationships" id="266" r:id="Re86ceb8ec02f4a0c"/>
-    <p:sldId xmlns:r="http://schemas.openxmlformats.org/officeDocument/2006/relationships" id="267" r:id="Rdc24ad3fc1434792"/>
-    <p:sldId xmlns:r="http://schemas.openxmlformats.org/officeDocument/2006/relationships" id="268" r:id="R76854dcec42c4cd2"/>
-    <p:sldId xmlns:r="http://schemas.openxmlformats.org/officeDocument/2006/relationships" id="269" r:id="Rff798e697e134ba4"/>
-    <p:sldId xmlns:r="http://schemas.openxmlformats.org/officeDocument/2006/relationships" id="270" r:id="R01ce6e7017794c32"/>
-    <p:sldId xmlns:r="http://schemas.openxmlformats.org/officeDocument/2006/relationships" id="271" r:id="Rc5d062ba07e04513"/>
-    <p:sldId xmlns:r="http://schemas.openxmlformats.org/officeDocument/2006/relationships" id="272" r:id="Red3ed8f4b5c045b0"/>
-    <p:sldId xmlns:r="http://schemas.openxmlformats.org/officeDocument/2006/relationships" id="273" r:id="Re0de5a822bb34db2"/>
-    <p:sldId xmlns:r="http://schemas.openxmlformats.org/officeDocument/2006/relationships" id="274" r:id="R9122fcf82f3c46c7"/>
-    <p:sldId xmlns:r="http://schemas.openxmlformats.org/officeDocument/2006/relationships" id="275" r:id="Rfa136cf0c5444c70"/>
-    <p:sldId xmlns:r="http://schemas.openxmlformats.org/officeDocument/2006/relationships" id="276" r:id="Rcaf93a75e91a47a2"/>
-    <p:sldId xmlns:r="http://schemas.openxmlformats.org/officeDocument/2006/relationships" id="277" r:id="Rcd82d4e53c4f4507"/>
-    <p:sldId xmlns:r="http://schemas.openxmlformats.org/officeDocument/2006/relationships" id="278" r:id="R9572961151ae4e66"/>
-    <p:sldId xmlns:r="http://schemas.openxmlformats.org/officeDocument/2006/relationships" id="279" r:id="Ra50321466cd04c17"/>
-    <p:sldId xmlns:r="http://schemas.openxmlformats.org/officeDocument/2006/relationships" id="280" r:id="Rba03ae52afcd404c"/>
-    <p:sldId xmlns:r="http://schemas.openxmlformats.org/officeDocument/2006/relationships" id="281" r:id="R3fa7b7fca3fe4571"/>
-    <p:sldId xmlns:r="http://schemas.openxmlformats.org/officeDocument/2006/relationships" id="282" r:id="R2dcfb699dc954e92"/>
-    <p:sldId xmlns:r="http://schemas.openxmlformats.org/officeDocument/2006/relationships" id="283" r:id="R39fa4ef19d344073"/>
-    <p:sldId xmlns:r="http://schemas.openxmlformats.org/officeDocument/2006/relationships" id="284" r:id="Rf66922f125ec4023"/>
-    <p:sldId xmlns:r="http://schemas.openxmlformats.org/officeDocument/2006/relationships" id="285" r:id="Ra9a08027d7f74dd1"/>
-    <p:sldId xmlns:r="http://schemas.openxmlformats.org/officeDocument/2006/relationships" id="286" r:id="Rd6f5d14428bf44df"/>
-    <p:sldId xmlns:r="http://schemas.openxmlformats.org/officeDocument/2006/relationships" id="287" r:id="R3c1ce8da5d3e48a9"/>
-    <p:sldId xmlns:r="http://schemas.openxmlformats.org/officeDocument/2006/relationships" id="288" r:id="R0d1fa832fb7345a1"/>
-    <p:sldId xmlns:r="http://schemas.openxmlformats.org/officeDocument/2006/relationships" id="289" r:id="R3252b9b666ea4e89"/>
-    <p:sldId xmlns:r="http://schemas.openxmlformats.org/officeDocument/2006/relationships" id="290" r:id="Rc7f5cf5fa00543ba"/>
-    <p:sldId xmlns:r="http://schemas.openxmlformats.org/officeDocument/2006/relationships" id="291" r:id="R5da5430ce6a14f17"/>
-    <p:sldId xmlns:r="http://schemas.openxmlformats.org/officeDocument/2006/relationships" id="292" r:id="R91594ead666a42ec"/>
-    <p:sldId xmlns:r="http://schemas.openxmlformats.org/officeDocument/2006/relationships" id="293" r:id="Raca1b36a285a4c9f"/>
-    <p:sldId xmlns:r="http://schemas.openxmlformats.org/officeDocument/2006/relationships" id="294" r:id="Ref0202cf9aaa4566"/>
+    <p:sldId xmlns:r="http://schemas.openxmlformats.org/officeDocument/2006/relationships" id="256" r:id="R7281a57ce74a467c"/>
+    <p:sldId xmlns:r="http://schemas.openxmlformats.org/officeDocument/2006/relationships" id="257" r:id="R8984548ec8dd498d"/>
+    <p:sldId xmlns:r="http://schemas.openxmlformats.org/officeDocument/2006/relationships" id="258" r:id="R90f422d7d0d84f81"/>
+    <p:sldId xmlns:r="http://schemas.openxmlformats.org/officeDocument/2006/relationships" id="259" r:id="R10bdf7dfc954464b"/>
+    <p:sldId xmlns:r="http://schemas.openxmlformats.org/officeDocument/2006/relationships" id="260" r:id="R164e10e959bd4957"/>
+    <p:sldId xmlns:r="http://schemas.openxmlformats.org/officeDocument/2006/relationships" id="261" r:id="R33d9117c0c2847f9"/>
+    <p:sldId xmlns:r="http://schemas.openxmlformats.org/officeDocument/2006/relationships" id="262" r:id="R8cd8bfbd356f4988"/>
+    <p:sldId xmlns:r="http://schemas.openxmlformats.org/officeDocument/2006/relationships" id="263" r:id="Re1e339d037904e46"/>
+    <p:sldId xmlns:r="http://schemas.openxmlformats.org/officeDocument/2006/relationships" id="264" r:id="Ra31c8df1ddd14f8d"/>
+    <p:sldId xmlns:r="http://schemas.openxmlformats.org/officeDocument/2006/relationships" id="265" r:id="Rb2ff6f29f8aa41ca"/>
+    <p:sldId xmlns:r="http://schemas.openxmlformats.org/officeDocument/2006/relationships" id="266" r:id="R7f9d83f34ea744b3"/>
+    <p:sldId xmlns:r="http://schemas.openxmlformats.org/officeDocument/2006/relationships" id="267" r:id="R43611d9f2e354de3"/>
+    <p:sldId xmlns:r="http://schemas.openxmlformats.org/officeDocument/2006/relationships" id="268" r:id="Re10925fd3bfa436d"/>
+    <p:sldId xmlns:r="http://schemas.openxmlformats.org/officeDocument/2006/relationships" id="269" r:id="Rc8849d471ae04205"/>
+    <p:sldId xmlns:r="http://schemas.openxmlformats.org/officeDocument/2006/relationships" id="270" r:id="R9a684debcda043d8"/>
+    <p:sldId xmlns:r="http://schemas.openxmlformats.org/officeDocument/2006/relationships" id="271" r:id="Rd79ea24c78a14dac"/>
+    <p:sldId xmlns:r="http://schemas.openxmlformats.org/officeDocument/2006/relationships" id="272" r:id="Re2d986f4e5c7474e"/>
+    <p:sldId xmlns:r="http://schemas.openxmlformats.org/officeDocument/2006/relationships" id="273" r:id="R3c7396b480984e3c"/>
+    <p:sldId xmlns:r="http://schemas.openxmlformats.org/officeDocument/2006/relationships" id="274" r:id="R98dc289576b64e00"/>
+    <p:sldId xmlns:r="http://schemas.openxmlformats.org/officeDocument/2006/relationships" id="275" r:id="Raa76182ccb5a49b3"/>
+    <p:sldId xmlns:r="http://schemas.openxmlformats.org/officeDocument/2006/relationships" id="276" r:id="R4a87c88b3dc34272"/>
+    <p:sldId xmlns:r="http://schemas.openxmlformats.org/officeDocument/2006/relationships" id="277" r:id="Re8093838df5d4304"/>
+    <p:sldId xmlns:r="http://schemas.openxmlformats.org/officeDocument/2006/relationships" id="278" r:id="R7aa51e9df2f340cf"/>
+    <p:sldId xmlns:r="http://schemas.openxmlformats.org/officeDocument/2006/relationships" id="279" r:id="R014219aaf8e94a99"/>
+    <p:sldId xmlns:r="http://schemas.openxmlformats.org/officeDocument/2006/relationships" id="280" r:id="Rf56f9970af1f4e64"/>
+    <p:sldId xmlns:r="http://schemas.openxmlformats.org/officeDocument/2006/relationships" id="281" r:id="R34ef4fcc53eb4e69"/>
+    <p:sldId xmlns:r="http://schemas.openxmlformats.org/officeDocument/2006/relationships" id="282" r:id="R43d2c975cf2b4f37"/>
+    <p:sldId xmlns:r="http://schemas.openxmlformats.org/officeDocument/2006/relationships" id="283" r:id="R2ce2d1c59f4747b3"/>
+    <p:sldId xmlns:r="http://schemas.openxmlformats.org/officeDocument/2006/relationships" id="284" r:id="R486d5150313e4b26"/>
+    <p:sldId xmlns:r="http://schemas.openxmlformats.org/officeDocument/2006/relationships" id="285" r:id="R2ed95a0b94904eba"/>
+    <p:sldId xmlns:r="http://schemas.openxmlformats.org/officeDocument/2006/relationships" id="286" r:id="Rf5d12e649a854118"/>
+    <p:sldId xmlns:r="http://schemas.openxmlformats.org/officeDocument/2006/relationships" id="287" r:id="Rfacb194db10e4aab"/>
+    <p:sldId xmlns:r="http://schemas.openxmlformats.org/officeDocument/2006/relationships" id="288" r:id="R8774038c16874639"/>
+    <p:sldId xmlns:r="http://schemas.openxmlformats.org/officeDocument/2006/relationships" id="289" r:id="R2e619350c8584bfa"/>
+    <p:sldId xmlns:r="http://schemas.openxmlformats.org/officeDocument/2006/relationships" id="290" r:id="R96aab52144f04308"/>
+    <p:sldId xmlns:r="http://schemas.openxmlformats.org/officeDocument/2006/relationships" id="291" r:id="R8b4e3ca8f96e4030"/>
+    <p:sldId xmlns:r="http://schemas.openxmlformats.org/officeDocument/2006/relationships" id="292" r:id="R7d2722a39f46454a"/>
+    <p:sldId xmlns:r="http://schemas.openxmlformats.org/officeDocument/2006/relationships" id="293" r:id="Ra009213a26f748bb"/>
+    <p:sldId xmlns:r="http://schemas.openxmlformats.org/officeDocument/2006/relationships" id="294" r:id="Ra2cb6f0a64b949d0"/>
   </p:sldIdLst>
   <p:sldSz cx="12192000" cy="6858000"/>
   <p:notesSz cx="6858000" cy="9144000"/>
@@ -3208,7 +3208,7 @@
   </p:cSld>
   <p:clrMap bg1="lt1" tx1="dk1" bg2="lt2" tx2="dk2" accent1="accent1" accent2="accent2" accent3="accent3" accent4="accent4" accent5="accent5" accent6="accent6" hlink="hlink" folHlink="folHlink"/>
   <p:sldLayoutIdLst>
-    <p:sldLayoutId xmlns:r="http://schemas.openxmlformats.org/officeDocument/2006/relationships" id="2147483649" r:id="Re3826fd3e11f4900"/>
+    <p:sldLayoutId xmlns:r="http://schemas.openxmlformats.org/officeDocument/2006/relationships" id="2147483649" r:id="R281f50f947ce4a8c"/>
   </p:sldLayoutIdLst>
   <p:txStyles>
     <p:titleStyle>
@@ -3759,7 +3759,7 @@
           <p:cNvPr id="6" name="">
             <a:extLst xmlns:a="http://schemas.openxmlformats.org/drawingml/2006/main">
               <a:ext uri="{FF2B5EF4-FFF2-40B4-BE49-F238E27FC236}">
-                <a16:creationId xmlns:a16="http://schemas.microsoft.com/office/drawing/2014/main" id="{DFE18A95-E969-4DF9-A2F8-35BE6CF03A16}"/>
+                <a16:creationId xmlns:a16="http://schemas.microsoft.com/office/drawing/2014/main" id="{B1464FFA-49E8-4367-B2B7-F420CD8EB1E2}"/>
               </a:ext>
             </a:extLst>
           </p:cNvPr>
@@ -3769,7 +3769,7 @@
           <p:nvPr/>
         </p:nvPicPr>
         <p:blipFill>
-          <a:blip xmlns:r="http://schemas.openxmlformats.org/officeDocument/2006/relationships" xmlns:a="http://schemas.openxmlformats.org/drawingml/2006/main" r:embed="Rdb070cfe6b3c4520"/>
+          <a:blip xmlns:r="http://schemas.openxmlformats.org/officeDocument/2006/relationships" xmlns:a="http://schemas.openxmlformats.org/drawingml/2006/main" r:embed="Rd28c04fa148441ae"/>
           <a:srcRect xmlns:a="http://schemas.openxmlformats.org/drawingml/2006/main" l="0" t="27" r="0" b="27"/>
           <a:stretch xmlns:a="http://schemas.openxmlformats.org/drawingml/2006/main">
             <a:fillRect l="0" t="0" r="0" b="0"/>
@@ -4520,7 +4520,7 @@
           <p:cNvPr id="21" name="">
             <a:extLst xmlns:a="http://schemas.openxmlformats.org/drawingml/2006/main">
               <a:ext uri="{FF2B5EF4-FFF2-40B4-BE49-F238E27FC236}">
-                <a16:creationId xmlns:a16="http://schemas.microsoft.com/office/drawing/2014/main" id="{47F9F56C-4865-4CF1-9F0A-ED2AA9B16922}"/>
+                <a16:creationId xmlns:a16="http://schemas.microsoft.com/office/drawing/2014/main" id="{8804C3BA-7C50-439D-B5AC-0E2D2EA8B4DB}"/>
               </a:ext>
             </a:extLst>
           </p:cNvPr>
@@ -4551,7 +4551,7 @@
           <p:cNvPr id="22" name="">
             <a:extLst xmlns:a="http://schemas.openxmlformats.org/drawingml/2006/main">
               <a:ext uri="{FF2B5EF4-FFF2-40B4-BE49-F238E27FC236}">
-                <a16:creationId xmlns:a16="http://schemas.microsoft.com/office/drawing/2014/main" id="{6950EF99-EC1C-4E30-9DB6-A3851D639FA8}"/>
+                <a16:creationId xmlns:a16="http://schemas.microsoft.com/office/drawing/2014/main" id="{8E63CCF0-8739-4514-A235-23E7EB48C03C}"/>
               </a:ext>
             </a:extLst>
           </p:cNvPr>
@@ -4582,7 +4582,7 @@
           <p:cNvPr id="23" name="">
             <a:extLst xmlns:a="http://schemas.openxmlformats.org/drawingml/2006/main">
               <a:ext uri="{FF2B5EF4-FFF2-40B4-BE49-F238E27FC236}">
-                <a16:creationId xmlns:a16="http://schemas.microsoft.com/office/drawing/2014/main" id="{03F0C189-1275-4366-85BB-DAB434FA3BD1}"/>
+                <a16:creationId xmlns:a16="http://schemas.microsoft.com/office/drawing/2014/main" id="{2A1294FA-02CC-49CE-92BA-4E9F93556E8D}"/>
               </a:ext>
             </a:extLst>
           </p:cNvPr>
@@ -5903,7 +5903,7 @@
           <p:cNvPr id="7" name="">
             <a:extLst xmlns:a="http://schemas.openxmlformats.org/drawingml/2006/main">
               <a:ext uri="{FF2B5EF4-FFF2-40B4-BE49-F238E27FC236}">
-                <a16:creationId xmlns:a16="http://schemas.microsoft.com/office/drawing/2014/main" id="{C03AD775-CE53-4084-9F14-7296E11F33B2}"/>
+                <a16:creationId xmlns:a16="http://schemas.microsoft.com/office/drawing/2014/main" id="{88799232-EF10-4F28-98BD-EFB771BA8554}"/>
               </a:ext>
             </a:extLst>
           </p:cNvPr>
@@ -6993,7 +6993,7 @@
                 <a:ea typeface="Helvetica Neue"/>
                 <a:cs typeface="Helvetica Neue"/>
               </a:rPr>
-              <a:t>DGX Spark after installation</a:t>
+              <a:t>DGX Spark</a:t>
             </a:r>
           </a:p>
           <a:p xmlns:a="http://schemas.openxmlformats.org/drawingml/2006/main">
@@ -7017,7 +7017,31 @@
                 <a:ea typeface="Helvetica Neue"/>
                 <a:cs typeface="Helvetica Neue"/>
               </a:rPr>
-              <a:t>Resident Qwen 27B + TTS</a:t>
+              <a:t>Qwen 27B + TTS</a:t>
+            </a:r>
+          </a:p>
+          <a:p xmlns:a="http://schemas.openxmlformats.org/drawingml/2006/main">
+            <a:pPr algn="ctr">
+              <a:buNone/>
+              <a:defRPr sz="1800" b="1">
+                <a:solidFill>
+                  <a:srgbClr val="EAF1F5"/>
+                </a:solidFill>
+                <a:latin typeface="Helvetica Neue"/>
+                <a:ea typeface="Helvetica Neue"/>
+                <a:cs typeface="Helvetica Neue"/>
+              </a:defRPr>
+            </a:pPr>
+            <a:r>
+              <a:rPr sz="1800" b="1">
+                <a:solidFill>
+                  <a:srgbClr val="EAF1F5"/>
+                </a:solidFill>
+                <a:latin typeface="Helvetica Neue"/>
+                <a:ea typeface="Helvetica Neue"/>
+                <a:cs typeface="Helvetica Neue"/>
+              </a:rPr>
+              <a:t>Resident AI stack</a:t>
             </a:r>
           </a:p>
         </p:txBody>
@@ -7113,7 +7137,7 @@
           <p:cNvPr id="21" name="">
             <a:extLst xmlns:a="http://schemas.openxmlformats.org/drawingml/2006/main">
               <a:ext uri="{FF2B5EF4-FFF2-40B4-BE49-F238E27FC236}">
-                <a16:creationId xmlns:a16="http://schemas.microsoft.com/office/drawing/2014/main" id="{BE386194-8649-4F89-8212-65B843C1247C}"/>
+                <a16:creationId xmlns:a16="http://schemas.microsoft.com/office/drawing/2014/main" id="{653EB82F-7635-4EDF-A2E2-1598C82ADA9F}"/>
               </a:ext>
             </a:extLst>
           </p:cNvPr>
@@ -7147,7 +7171,7 @@
           <p:cNvPr id="22" name="">
             <a:extLst xmlns:a="http://schemas.openxmlformats.org/drawingml/2006/main">
               <a:ext uri="{FF2B5EF4-FFF2-40B4-BE49-F238E27FC236}">
-                <a16:creationId xmlns:a16="http://schemas.microsoft.com/office/drawing/2014/main" id="{76015DD3-C035-4D6A-ABE1-798EA7FEAB0B}"/>
+                <a16:creationId xmlns:a16="http://schemas.microsoft.com/office/drawing/2014/main" id="{CA09822D-7832-4369-B1C0-AC6EC2C01D43}"/>
               </a:ext>
             </a:extLst>
           </p:cNvPr>
@@ -9437,7 +9461,7 @@
           <p:cNvPr id="17" name="">
             <a:extLst xmlns:a="http://schemas.openxmlformats.org/drawingml/2006/main">
               <a:ext uri="{FF2B5EF4-FFF2-40B4-BE49-F238E27FC236}">
-                <a16:creationId xmlns:a16="http://schemas.microsoft.com/office/drawing/2014/main" id="{A4306D5B-B15F-46F2-928E-3E401FE76DB8}"/>
+                <a16:creationId xmlns:a16="http://schemas.microsoft.com/office/drawing/2014/main" id="{A828838E-691D-4DE3-856F-F61FA50C56FA}"/>
               </a:ext>
             </a:extLst>
           </p:cNvPr>
@@ -9468,7 +9492,7 @@
           <p:cNvPr id="18" name="">
             <a:extLst xmlns:a="http://schemas.openxmlformats.org/drawingml/2006/main">
               <a:ext uri="{FF2B5EF4-FFF2-40B4-BE49-F238E27FC236}">
-                <a16:creationId xmlns:a16="http://schemas.microsoft.com/office/drawing/2014/main" id="{45DA09DA-7F2E-4977-9245-6E00D403E74F}"/>
+                <a16:creationId xmlns:a16="http://schemas.microsoft.com/office/drawing/2014/main" id="{ADB527BB-DE29-45AE-B868-E4CCC029D5EB}"/>
               </a:ext>
             </a:extLst>
           </p:cNvPr>
@@ -9909,7 +9933,7 @@
           <p:cNvPr id="7" name="">
             <a:extLst xmlns:a="http://schemas.openxmlformats.org/drawingml/2006/main">
               <a:ext uri="{FF2B5EF4-FFF2-40B4-BE49-F238E27FC236}">
-                <a16:creationId xmlns:a16="http://schemas.microsoft.com/office/drawing/2014/main" id="{5B7BB6ED-3B93-4756-A814-CCF646ACAD73}"/>
+                <a16:creationId xmlns:a16="http://schemas.microsoft.com/office/drawing/2014/main" id="{C2774502-CE87-418A-94B4-D7BA8CAD16F0}"/>
               </a:ext>
             </a:extLst>
           </p:cNvPr>
@@ -10563,7 +10587,7 @@
           <p:cNvPr id="7" name="">
             <a:extLst xmlns:a="http://schemas.openxmlformats.org/drawingml/2006/main">
               <a:ext uri="{FF2B5EF4-FFF2-40B4-BE49-F238E27FC236}">
-                <a16:creationId xmlns:a16="http://schemas.microsoft.com/office/drawing/2014/main" id="{5B7BB6ED-3B93-4756-A814-CCF646ACAD73}"/>
+                <a16:creationId xmlns:a16="http://schemas.microsoft.com/office/drawing/2014/main" id="{C2774502-CE87-418A-94B4-D7BA8CAD16F0}"/>
               </a:ext>
             </a:extLst>
           </p:cNvPr>
@@ -12824,7 +12848,7 @@
           <p:cNvPr id="10" name="">
             <a:extLst xmlns:a="http://schemas.openxmlformats.org/drawingml/2006/main">
               <a:ext uri="{FF2B5EF4-FFF2-40B4-BE49-F238E27FC236}">
-                <a16:creationId xmlns:a16="http://schemas.microsoft.com/office/drawing/2014/main" id="{DDC65610-71B6-4D39-8591-82B0F8D28755}"/>
+                <a16:creationId xmlns:a16="http://schemas.microsoft.com/office/drawing/2014/main" id="{02E3C05B-10AB-4694-82CC-745338901EC6}"/>
               </a:ext>
             </a:extLst>
           </p:cNvPr>
@@ -14017,7 +14041,7 @@
           <p:cNvPr id="18" name="">
             <a:extLst xmlns:a="http://schemas.openxmlformats.org/drawingml/2006/main">
               <a:ext uri="{FF2B5EF4-FFF2-40B4-BE49-F238E27FC236}">
-                <a16:creationId xmlns:a16="http://schemas.microsoft.com/office/drawing/2014/main" id="{F9E9157D-B613-4AF4-946A-26CB7C3003AD}"/>
+                <a16:creationId xmlns:a16="http://schemas.microsoft.com/office/drawing/2014/main" id="{3CF5E100-44CF-46F2-9AC8-C86EFDC82882}"/>
               </a:ext>
             </a:extLst>
           </p:cNvPr>
@@ -14048,7 +14072,7 @@
           <p:cNvPr id="19" name="">
             <a:extLst xmlns:a="http://schemas.openxmlformats.org/drawingml/2006/main">
               <a:ext uri="{FF2B5EF4-FFF2-40B4-BE49-F238E27FC236}">
-                <a16:creationId xmlns:a16="http://schemas.microsoft.com/office/drawing/2014/main" id="{6630163D-C1C6-4450-9B04-57E2064ECCE2}"/>
+                <a16:creationId xmlns:a16="http://schemas.microsoft.com/office/drawing/2014/main" id="{2B2BD2C2-A685-467C-8103-58BA0997931B}"/>
               </a:ext>
             </a:extLst>
           </p:cNvPr>
@@ -16222,7 +16246,7 @@
           <p:cNvPr id="23" name="">
             <a:extLst xmlns:a="http://schemas.openxmlformats.org/drawingml/2006/main">
               <a:ext uri="{FF2B5EF4-FFF2-40B4-BE49-F238E27FC236}">
-                <a16:creationId xmlns:a16="http://schemas.microsoft.com/office/drawing/2014/main" id="{554ABFCD-BD18-4734-A0C6-64F09A9851B2}"/>
+                <a16:creationId xmlns:a16="http://schemas.microsoft.com/office/drawing/2014/main" id="{5DFF196E-FF04-4115-9F0A-6527C7D93501}"/>
               </a:ext>
             </a:extLst>
           </p:cNvPr>
@@ -16253,7 +16277,7 @@
           <p:cNvPr id="24" name="">
             <a:extLst xmlns:a="http://schemas.openxmlformats.org/drawingml/2006/main">
               <a:ext uri="{FF2B5EF4-FFF2-40B4-BE49-F238E27FC236}">
-                <a16:creationId xmlns:a16="http://schemas.microsoft.com/office/drawing/2014/main" id="{A9A7C02A-7B7B-4F5E-8179-8676848DA979}"/>
+                <a16:creationId xmlns:a16="http://schemas.microsoft.com/office/drawing/2014/main" id="{B2DFC398-76A5-4556-B8EE-F082FD7B0D71}"/>
               </a:ext>
             </a:extLst>
           </p:cNvPr>
@@ -16284,7 +16308,7 @@
           <p:cNvPr id="25" name="">
             <a:extLst xmlns:a="http://schemas.openxmlformats.org/drawingml/2006/main">
               <a:ext uri="{FF2B5EF4-FFF2-40B4-BE49-F238E27FC236}">
-                <a16:creationId xmlns:a16="http://schemas.microsoft.com/office/drawing/2014/main" id="{9D44D394-ED0D-4E3B-9764-75F60E564516}"/>
+                <a16:creationId xmlns:a16="http://schemas.microsoft.com/office/drawing/2014/main" id="{4C4A63A9-6EC5-4E77-AD40-5ED77F4851E6}"/>
               </a:ext>
             </a:extLst>
           </p:cNvPr>
@@ -16315,7 +16339,7 @@
           <p:cNvPr id="26" name="">
             <a:extLst xmlns:a="http://schemas.openxmlformats.org/drawingml/2006/main">
               <a:ext uri="{FF2B5EF4-FFF2-40B4-BE49-F238E27FC236}">
-                <a16:creationId xmlns:a16="http://schemas.microsoft.com/office/drawing/2014/main" id="{C96EB339-4EA7-406E-B4F5-FBA5F37A593E}"/>
+                <a16:creationId xmlns:a16="http://schemas.microsoft.com/office/drawing/2014/main" id="{10D8BFD1-E5F8-48DE-AF17-BAB5E2B63898}"/>
               </a:ext>
             </a:extLst>
           </p:cNvPr>
@@ -16346,7 +16370,7 @@
           <p:cNvPr id="27" name="">
             <a:extLst xmlns:a="http://schemas.openxmlformats.org/drawingml/2006/main">
               <a:ext uri="{FF2B5EF4-FFF2-40B4-BE49-F238E27FC236}">
-                <a16:creationId xmlns:a16="http://schemas.microsoft.com/office/drawing/2014/main" id="{85F70B6A-A3D5-41FA-932A-D6C792DACF9D}"/>
+                <a16:creationId xmlns:a16="http://schemas.microsoft.com/office/drawing/2014/main" id="{5A2FEAAC-AED4-4D78-90A1-4F65AF53122B}"/>
               </a:ext>
             </a:extLst>
           </p:cNvPr>
@@ -18367,7 +18391,7 @@
                 <a:latin typeface="Helvetica Neue"/>
                 <a:ea typeface="Helvetica Neue"/>
                 <a:cs typeface="Helvetica Neue"/>
-                <a:hlinkClick xmlns:r="http://schemas.openxmlformats.org/officeDocument/2006/relationships" r:id="R391a5791b2774502"/>
+                <a:hlinkClick xmlns:r="http://schemas.openxmlformats.org/officeDocument/2006/relationships" r:id="R0960326e80644259"/>
               </a:rPr>
               <a:t>Open verification record</a:t>
             </a:r>
@@ -18379,7 +18403,7 @@
           <p:cNvPr id="16" name="">
             <a:extLst xmlns:a="http://schemas.openxmlformats.org/drawingml/2006/main">
               <a:ext uri="{FF2B5EF4-FFF2-40B4-BE49-F238E27FC236}">
-                <a16:creationId xmlns:a16="http://schemas.microsoft.com/office/drawing/2014/main" id="{391B372A-4F88-457B-875F-E900C8787871}"/>
+                <a16:creationId xmlns:a16="http://schemas.microsoft.com/office/drawing/2014/main" id="{875F3017-5BEF-446C-AE4E-C3F282F5EB66}"/>
               </a:ext>
             </a:extLst>
           </p:cNvPr>
@@ -18389,7 +18413,7 @@
           <p:nvPr/>
         </p:nvPicPr>
         <p:blipFill>
-          <a:blip xmlns:r="http://schemas.openxmlformats.org/officeDocument/2006/relationships" xmlns:a="http://schemas.openxmlformats.org/drawingml/2006/main" r:embed="Rce3d070aada74a58"/>
+          <a:blip xmlns:r="http://schemas.openxmlformats.org/officeDocument/2006/relationships" xmlns:a="http://schemas.openxmlformats.org/drawingml/2006/main" r:embed="R9d7f1e138636495e"/>
           <a:stretch xmlns:a="http://schemas.openxmlformats.org/drawingml/2006/main"/>
         </p:blipFill>
         <p:spPr>
@@ -19379,7 +19403,7 @@
           <p:cNvPr id="7" name="">
             <a:extLst xmlns:a="http://schemas.openxmlformats.org/drawingml/2006/main">
               <a:ext uri="{FF2B5EF4-FFF2-40B4-BE49-F238E27FC236}">
-                <a16:creationId xmlns:a16="http://schemas.microsoft.com/office/drawing/2014/main" id="{8F9EACA2-0966-49AF-83B7-B2F5C288B42A}"/>
+                <a16:creationId xmlns:a16="http://schemas.microsoft.com/office/drawing/2014/main" id="{B0D24825-F91F-4796-9191-37BAAA9CB3B3}"/>
               </a:ext>
             </a:extLst>
           </p:cNvPr>
@@ -20512,7 +20536,7 @@
           <p:cNvPr id="7" name="">
             <a:extLst xmlns:a="http://schemas.openxmlformats.org/drawingml/2006/main">
               <a:ext uri="{FF2B5EF4-FFF2-40B4-BE49-F238E27FC236}">
-                <a16:creationId xmlns:a16="http://schemas.microsoft.com/office/drawing/2014/main" id="{D45C859D-1B9C-4394-B7F4-08C80F1D5EDB}"/>
+                <a16:creationId xmlns:a16="http://schemas.microsoft.com/office/drawing/2014/main" id="{817CC4A0-FD40-4535-A6D2-7B6871A81C99}"/>
               </a:ext>
             </a:extLst>
           </p:cNvPr>
@@ -22290,7 +22314,7 @@
           <p:cNvPr id="7" name="">
             <a:extLst xmlns:a="http://schemas.openxmlformats.org/drawingml/2006/main">
               <a:ext uri="{FF2B5EF4-FFF2-40B4-BE49-F238E27FC236}">
-                <a16:creationId xmlns:a16="http://schemas.microsoft.com/office/drawing/2014/main" id="{4D81623B-9600-4201-B023-AEC5E6FFF0B9}"/>
+                <a16:creationId xmlns:a16="http://schemas.microsoft.com/office/drawing/2014/main" id="{37D35A01-61FD-4DA3-92F0-22276DEF0387}"/>
               </a:ext>
             </a:extLst>
           </p:cNvPr>
@@ -22944,7 +22968,7 @@
           <p:cNvPr id="9" name="">
             <a:extLst xmlns:a="http://schemas.openxmlformats.org/drawingml/2006/main">
               <a:ext uri="{FF2B5EF4-FFF2-40B4-BE49-F238E27FC236}">
-                <a16:creationId xmlns:a16="http://schemas.microsoft.com/office/drawing/2014/main" id="{2987961E-3143-49E8-9CDF-02926318E112}"/>
+                <a16:creationId xmlns:a16="http://schemas.microsoft.com/office/drawing/2014/main" id="{11C009DA-4477-4507-BC21-802C44886BE8}"/>
               </a:ext>
             </a:extLst>
           </p:cNvPr>
@@ -25011,7 +25035,7 @@
                 <a:latin typeface="Helvetica Neue"/>
                 <a:ea typeface="Helvetica Neue"/>
                 <a:cs typeface="Helvetica Neue"/>
-                <a:hlinkClick xmlns:r="http://schemas.openxmlformats.org/officeDocument/2006/relationships" r:id="R262027d37d2a421c"/>
+                <a:hlinkClick xmlns:r="http://schemas.openxmlformats.org/officeDocument/2006/relationships" r:id="R72a6136c1e3f4e45"/>
               </a:rPr>
               <a:t>Website and current documentation</a:t>
             </a:r>
@@ -25070,7 +25094,7 @@
                 <a:latin typeface="Helvetica Neue"/>
                 <a:ea typeface="Helvetica Neue"/>
                 <a:cs typeface="Helvetica Neue"/>
-                <a:hlinkClick xmlns:r="http://schemas.openxmlformats.org/officeDocument/2006/relationships" r:id="Reb416a6e27994f62"/>
+                <a:hlinkClick xmlns:r="http://schemas.openxmlformats.org/officeDocument/2006/relationships" r:id="Rbb3b1b2cabd44173"/>
               </a:rPr>
               <a:t>Founder LinkedIn</a:t>
             </a:r>
@@ -25343,7 +25367,7 @@
                 <a:latin typeface="Helvetica Neue"/>
                 <a:ea typeface="Helvetica Neue"/>
                 <a:cs typeface="Helvetica Neue"/>
-                <a:hlinkClick xmlns:r="http://schemas.openxmlformats.org/officeDocument/2006/relationships" r:id="R432dfd460a7e441e"/>
+                <a:hlinkClick xmlns:r="http://schemas.openxmlformats.org/officeDocument/2006/relationships" r:id="Rddf784fc7b124510"/>
               </a:rPr>
               <a:t>Website and technical documentation</a:t>
             </a:r>
@@ -25413,7 +25437,7 @@
                 <a:latin typeface="Helvetica Neue"/>
                 <a:ea typeface="Helvetica Neue"/>
                 <a:cs typeface="Helvetica Neue"/>
-                <a:hlinkClick xmlns:r="http://schemas.openxmlformats.org/officeDocument/2006/relationships" r:id="R1d85f95103ab40ac"/>
+                <a:hlinkClick xmlns:r="http://schemas.openxmlformats.org/officeDocument/2006/relationships" r:id="Ra72f8a1cbbf543b5"/>
               </a:rPr>
               <a:t>Public source and development modules</a:t>
             </a:r>
@@ -25483,7 +25507,7 @@
                 <a:latin typeface="Helvetica Neue"/>
                 <a:ea typeface="Helvetica Neue"/>
                 <a:cs typeface="Helvetica Neue"/>
-                <a:hlinkClick xmlns:r="http://schemas.openxmlformats.org/officeDocument/2006/relationships" r:id="Rc94fe2620f974898"/>
+                <a:hlinkClick xmlns:r="http://schemas.openxmlformats.org/officeDocument/2006/relationships" r:id="R65736af704184e5c"/>
               </a:rPr>
               <a:t>Historical demo and transaction references</a:t>
             </a:r>
@@ -25553,7 +25577,7 @@
                 <a:latin typeface="Helvetica Neue"/>
                 <a:ea typeface="Helvetica Neue"/>
                 <a:cs typeface="Helvetica Neue"/>
-                <a:hlinkClick xmlns:r="http://schemas.openxmlformats.org/officeDocument/2006/relationships" r:id="Rede1f4dcc46a45bd"/>
+                <a:hlinkClick xmlns:r="http://schemas.openxmlformats.org/officeDocument/2006/relationships" r:id="R8f015b2d9ef546a3"/>
               </a:rPr>
               <a:t>Market specification and fulfillment design</a:t>
             </a:r>
@@ -25612,7 +25636,7 @@
                 <a:latin typeface="Helvetica Neue"/>
                 <a:ea typeface="Helvetica Neue"/>
                 <a:cs typeface="Helvetica Neue"/>
-                <a:hlinkClick xmlns:r="http://schemas.openxmlformats.org/officeDocument/2006/relationships" r:id="R9b5539ab93e948e8"/>
+                <a:hlinkClick xmlns:r="http://schemas.openxmlformats.org/officeDocument/2006/relationships" r:id="Rbea0bfdfb71843ad"/>
               </a:rPr>
               <a:t>Founder: Vitalii Pavlichuk</a:t>
             </a:r>
@@ -26197,7 +26221,7 @@
                 <a:latin typeface="Helvetica Neue"/>
                 <a:ea typeface="Helvetica Neue"/>
                 <a:cs typeface="Helvetica Neue"/>
-                <a:hlinkClick xmlns:r="http://schemas.openxmlformats.org/officeDocument/2006/relationships" r:id="R7d2401ad8e784e53"/>
+                <a:hlinkClick xmlns:r="http://schemas.openxmlformats.org/officeDocument/2006/relationships" r:id="Rbd6479a76069445f"/>
               </a:rPr>
               <a:t>Reference: @anabology’s production example</a:t>
             </a:r>
@@ -27357,7 +27381,7 @@
           <p:cNvPr id="24" name="">
             <a:extLst xmlns:a="http://schemas.openxmlformats.org/drawingml/2006/main">
               <a:ext uri="{FF2B5EF4-FFF2-40B4-BE49-F238E27FC236}">
-                <a16:creationId xmlns:a16="http://schemas.microsoft.com/office/drawing/2014/main" id="{7853AF2E-8469-4E17-876A-5AC11BB15FCF}"/>
+                <a16:creationId xmlns:a16="http://schemas.microsoft.com/office/drawing/2014/main" id="{0F55982A-4679-4962-BDB6-06876962C7C1}"/>
               </a:ext>
             </a:extLst>
           </p:cNvPr>
@@ -27388,7 +27412,7 @@
           <p:cNvPr id="25" name="">
             <a:extLst xmlns:a="http://schemas.openxmlformats.org/drawingml/2006/main">
               <a:ext uri="{FF2B5EF4-FFF2-40B4-BE49-F238E27FC236}">
-                <a16:creationId xmlns:a16="http://schemas.microsoft.com/office/drawing/2014/main" id="{3080CF69-F096-488A-ADEF-261311A76E32}"/>
+                <a16:creationId xmlns:a16="http://schemas.microsoft.com/office/drawing/2014/main" id="{25FB6EDA-11E7-4851-86B8-F6369EFE3001}"/>
               </a:ext>
             </a:extLst>
           </p:cNvPr>
@@ -27419,7 +27443,7 @@
           <p:cNvPr id="26" name="">
             <a:extLst xmlns:a="http://schemas.openxmlformats.org/drawingml/2006/main">
               <a:ext uri="{FF2B5EF4-FFF2-40B4-BE49-F238E27FC236}">
-                <a16:creationId xmlns:a16="http://schemas.microsoft.com/office/drawing/2014/main" id="{76A5EE20-14D5-49B6-A6D3-071EA9D6A33F}"/>
+                <a16:creationId xmlns:a16="http://schemas.microsoft.com/office/drawing/2014/main" id="{5F38477D-5593-4F06-8F7B-CC4F972A6E84}"/>
               </a:ext>
             </a:extLst>
           </p:cNvPr>
@@ -27450,7 +27474,7 @@
           <p:cNvPr id="27" name="">
             <a:extLst xmlns:a="http://schemas.openxmlformats.org/drawingml/2006/main">
               <a:ext uri="{FF2B5EF4-FFF2-40B4-BE49-F238E27FC236}">
-                <a16:creationId xmlns:a16="http://schemas.microsoft.com/office/drawing/2014/main" id="{EA9EB707-1B2F-4C5E-99F6-905BA1E0C8FE}"/>
+                <a16:creationId xmlns:a16="http://schemas.microsoft.com/office/drawing/2014/main" id="{EFE74934-DC58-4FE4-99F9-BE11D3104415}"/>
               </a:ext>
             </a:extLst>
           </p:cNvPr>
@@ -27481,7 +27505,7 @@
           <p:cNvPr id="28" name="">
             <a:extLst xmlns:a="http://schemas.openxmlformats.org/drawingml/2006/main">
               <a:ext uri="{FF2B5EF4-FFF2-40B4-BE49-F238E27FC236}">
-                <a16:creationId xmlns:a16="http://schemas.microsoft.com/office/drawing/2014/main" id="{A409EA3F-8C6A-4C34-BDFE-51B638C7BADC}"/>
+                <a16:creationId xmlns:a16="http://schemas.microsoft.com/office/drawing/2014/main" id="{C3151414-9523-4015-97BD-5FC081F0640F}"/>
               </a:ext>
             </a:extLst>
           </p:cNvPr>
@@ -27512,7 +27536,7 @@
           <p:cNvPr id="29" name="">
             <a:extLst xmlns:a="http://schemas.openxmlformats.org/drawingml/2006/main">
               <a:ext uri="{FF2B5EF4-FFF2-40B4-BE49-F238E27FC236}">
-                <a16:creationId xmlns:a16="http://schemas.microsoft.com/office/drawing/2014/main" id="{0F45A5BF-8064-44FE-9150-A4D21C7F0B34}"/>
+                <a16:creationId xmlns:a16="http://schemas.microsoft.com/office/drawing/2014/main" id="{B36E5AE9-C3A3-4EF2-8308-E8867F439DBE}"/>
               </a:ext>
             </a:extLst>
           </p:cNvPr>
@@ -28150,7 +28174,7 @@
           <p:cNvPr id="21" name="">
             <a:extLst xmlns:a="http://schemas.openxmlformats.org/drawingml/2006/main">
               <a:ext uri="{FF2B5EF4-FFF2-40B4-BE49-F238E27FC236}">
-                <a16:creationId xmlns:a16="http://schemas.microsoft.com/office/drawing/2014/main" id="{B1E3B5BD-AA62-49BD-9D40-CE8411D6E417}"/>
+                <a16:creationId xmlns:a16="http://schemas.microsoft.com/office/drawing/2014/main" id="{BCA97507-E2B3-4F43-B277-67868E35F584}"/>
               </a:ext>
             </a:extLst>
           </p:cNvPr>
@@ -28181,7 +28205,7 @@
           <p:cNvPr id="22" name="">
             <a:extLst xmlns:a="http://schemas.openxmlformats.org/drawingml/2006/main">
               <a:ext uri="{FF2B5EF4-FFF2-40B4-BE49-F238E27FC236}">
-                <a16:creationId xmlns:a16="http://schemas.microsoft.com/office/drawing/2014/main" id="{C6214AFE-3AC4-496F-A017-B6448C8FD397}"/>
+                <a16:creationId xmlns:a16="http://schemas.microsoft.com/office/drawing/2014/main" id="{72BA2048-82AE-45C6-B974-423B70772B17}"/>
               </a:ext>
             </a:extLst>
           </p:cNvPr>
@@ -28215,7 +28239,7 @@
           <p:cNvPr id="23" name="">
             <a:extLst xmlns:a="http://schemas.openxmlformats.org/drawingml/2006/main">
               <a:ext uri="{FF2B5EF4-FFF2-40B4-BE49-F238E27FC236}">
-                <a16:creationId xmlns:a16="http://schemas.microsoft.com/office/drawing/2014/main" id="{37821667-B3BD-43B0-983A-BC8179DFC645}"/>
+                <a16:creationId xmlns:a16="http://schemas.microsoft.com/office/drawing/2014/main" id="{6D43FF7C-B459-4944-B8D8-C62F8D87D6F5}"/>
               </a:ext>
             </a:extLst>
           </p:cNvPr>
@@ -28246,7 +28270,7 @@
           <p:cNvPr id="24" name="">
             <a:extLst xmlns:a="http://schemas.openxmlformats.org/drawingml/2006/main">
               <a:ext uri="{FF2B5EF4-FFF2-40B4-BE49-F238E27FC236}">
-                <a16:creationId xmlns:a16="http://schemas.microsoft.com/office/drawing/2014/main" id="{3BFFADA6-387C-44F6-A5F0-53DA4A196995}"/>
+                <a16:creationId xmlns:a16="http://schemas.microsoft.com/office/drawing/2014/main" id="{BC9D20E7-EF82-4428-8E0D-2C0407DA2165}"/>
               </a:ext>
             </a:extLst>
           </p:cNvPr>

</xml_diff>